<commit_message>
Applying the Brand Typeface
</commit_message>
<xml_diff>
--- a/Documents/Original/FlexChroma_Tour_Guide_DE.pptx
+++ b/Documents/Original/FlexChroma_Tour_Guide_DE.pptx
@@ -1886,7 +1886,7 @@
           </a:ln>
           <a:extLst>
             <a:ext uri="{C572A759-6A51-4108-AA02-DFA0A04FC94B}">
-              <ma14:wrappingTextBoxFlag xmlns="" xmlns:m="http://schemas.openxmlformats.org/officeDocument/2006/math" xmlns:a14="http://schemas.microsoft.com/office/drawing/2010/main" xmlns:ma14="http://schemas.microsoft.com/office/mac/drawingml/2011/main" val="1"/>
+              <ma14:wrappingTextBoxFlag xmlns:ma14="http://schemas.microsoft.com/office/mac/drawingml/2011/main" xmlns:a14="http://schemas.microsoft.com/office/drawing/2010/main" xmlns:m="http://schemas.openxmlformats.org/officeDocument/2006/math" xmlns="" val="1"/>
             </a:ext>
           </a:extLst>
         </p:spPr>
@@ -1925,7 +1925,7 @@
           </a:ln>
           <a:extLst>
             <a:ext uri="{C572A759-6A51-4108-AA02-DFA0A04FC94B}">
-              <ma14:wrappingTextBoxFlag xmlns="" xmlns:m="http://schemas.openxmlformats.org/officeDocument/2006/math" xmlns:a14="http://schemas.microsoft.com/office/drawing/2010/main" xmlns:ma14="http://schemas.microsoft.com/office/mac/drawingml/2011/main" val="1"/>
+              <ma14:wrappingTextBoxFlag xmlns:ma14="http://schemas.microsoft.com/office/mac/drawingml/2011/main" xmlns:a14="http://schemas.microsoft.com/office/drawing/2010/main" xmlns:m="http://schemas.openxmlformats.org/officeDocument/2006/math" xmlns="" val="1"/>
             </a:ext>
           </a:extLst>
         </p:spPr>
@@ -3167,7 +3167,7 @@
           </a:ln>
           <a:extLst>
             <a:ext uri="{C572A759-6A51-4108-AA02-DFA0A04FC94B}">
-              <ma14:wrappingTextBoxFlag xmlns="" xmlns:m="http://schemas.openxmlformats.org/officeDocument/2006/math" xmlns:a14="http://schemas.microsoft.com/office/drawing/2010/main" xmlns:ma14="http://schemas.microsoft.com/office/mac/drawingml/2011/main" val="1"/>
+              <ma14:wrappingTextBoxFlag xmlns:ma14="http://schemas.microsoft.com/office/mac/drawingml/2011/main" xmlns:a14="http://schemas.microsoft.com/office/drawing/2010/main" xmlns:m="http://schemas.openxmlformats.org/officeDocument/2006/math" xmlns="" val="1"/>
             </a:ext>
           </a:extLst>
         </p:spPr>
@@ -3586,7 +3586,7 @@
           </a:ln>
           <a:extLst>
             <a:ext uri="{C572A759-6A51-4108-AA02-DFA0A04FC94B}">
-              <ma14:wrappingTextBoxFlag xmlns="" xmlns:m="http://schemas.openxmlformats.org/officeDocument/2006/math" xmlns:a14="http://schemas.microsoft.com/office/drawing/2010/main" xmlns:ma14="http://schemas.microsoft.com/office/mac/drawingml/2011/main" val="1"/>
+              <ma14:wrappingTextBoxFlag xmlns:ma14="http://schemas.microsoft.com/office/mac/drawingml/2011/main" xmlns:a14="http://schemas.microsoft.com/office/drawing/2010/main" xmlns:m="http://schemas.openxmlformats.org/officeDocument/2006/math" xmlns="" val="1"/>
             </a:ext>
           </a:extLst>
         </p:spPr>
@@ -3612,8 +3612,8 @@
         </p:nvSpPr>
         <p:spPr>
           <a:xfrm>
-            <a:off x="1599039" y="846314"/>
-            <a:ext cx="4088618" cy="584775"/>
+            <a:off x="1507599" y="846314"/>
+            <a:ext cx="4449293" cy="584775"/>
           </a:xfrm>
           <a:prstGeom prst="rect">
             <a:avLst/>
@@ -3623,7 +3623,7 @@
           </a:ln>
           <a:extLst>
             <a:ext uri="{C572A759-6A51-4108-AA02-DFA0A04FC94B}">
-              <ma14:wrappingTextBoxFlag xmlns="" xmlns:m="http://schemas.openxmlformats.org/officeDocument/2006/math" xmlns:a14="http://schemas.microsoft.com/office/drawing/2010/main" xmlns:ma14="http://schemas.microsoft.com/office/mac/drawingml/2011/main" val="1"/>
+              <ma14:wrappingTextBoxFlag xmlns:ma14="http://schemas.microsoft.com/office/mac/drawingml/2011/main" xmlns:a14="http://schemas.microsoft.com/office/drawing/2010/main" xmlns:m="http://schemas.openxmlformats.org/officeDocument/2006/math" xmlns="" val="1"/>
             </a:ext>
           </a:extLst>
         </p:spPr>
@@ -3642,7 +3642,10 @@
               </a:defRPr>
             </a:pPr>
             <a:r>
-              <a:rPr dirty="0"/>
+              <a:rPr dirty="0">
+                <a:latin typeface="Jost SemiBold" pitchFamily="2" charset="0"/>
+                <a:ea typeface="Jost SemiBold" pitchFamily="2" charset="0"/>
+              </a:rPr>
               <a:t>FlexChroma</a:t>
             </a:r>
             <a:r>
@@ -3656,8 +3659,8 @@
             </a:r>
             <a:r>
               <a:rPr dirty="0">
-                <a:ea typeface="+mn-ea"/>
-                <a:cs typeface="+mn-cs"/>
+                <a:latin typeface="Jost Medium" pitchFamily="2" charset="0"/>
+                <a:ea typeface="Jost Medium" pitchFamily="2" charset="0"/>
                 <a:sym typeface="Jost-Regular"/>
               </a:rPr>
               <a:t>Tour-Guide</a:t>
@@ -3723,7 +3726,7 @@
           </a:ln>
           <a:extLst>
             <a:ext uri="{C572A759-6A51-4108-AA02-DFA0A04FC94B}">
-              <ma14:wrappingTextBoxFlag xmlns="" xmlns:m="http://schemas.openxmlformats.org/officeDocument/2006/math" xmlns:a14="http://schemas.microsoft.com/office/drawing/2010/main" xmlns:ma14="http://schemas.microsoft.com/office/mac/drawingml/2011/main" val="1"/>
+              <ma14:wrappingTextBoxFlag xmlns:ma14="http://schemas.microsoft.com/office/mac/drawingml/2011/main" xmlns:a14="http://schemas.microsoft.com/office/drawing/2010/main" xmlns:m="http://schemas.openxmlformats.org/officeDocument/2006/math" xmlns="" val="1"/>
             </a:ext>
           </a:extLst>
         </p:spPr>
@@ -3757,7 +3760,7 @@
         <p:spPr>
           <a:xfrm>
             <a:off x="714228" y="3418925"/>
-            <a:ext cx="5558051" cy="662941"/>
+            <a:ext cx="5558051" cy="553998"/>
           </a:xfrm>
           <a:prstGeom prst="rect">
             <a:avLst/>
@@ -3767,7 +3770,7 @@
           </a:ln>
           <a:extLst>
             <a:ext uri="{C572A759-6A51-4108-AA02-DFA0A04FC94B}">
-              <ma14:wrappingTextBoxFlag xmlns="" xmlns:m="http://schemas.openxmlformats.org/officeDocument/2006/math" xmlns:a14="http://schemas.microsoft.com/office/drawing/2010/main" xmlns:ma14="http://schemas.microsoft.com/office/mac/drawingml/2011/main" val="1"/>
+              <ma14:wrappingTextBoxFlag xmlns:ma14="http://schemas.microsoft.com/office/mac/drawingml/2011/main" xmlns:a14="http://schemas.microsoft.com/office/drawing/2010/main" xmlns:m="http://schemas.openxmlformats.org/officeDocument/2006/math" xmlns="" val="1"/>
             </a:ext>
           </a:extLst>
         </p:spPr>
@@ -3786,16 +3789,164 @@
               </a:defRPr>
             </a:pPr>
             <a:r>
+              <a:rPr dirty="0">
+                <a:latin typeface="Jost SemiBold" pitchFamily="2" charset="0"/>
+                <a:ea typeface="Jost SemiBold" pitchFamily="2" charset="0"/>
+              </a:rPr>
               <a:t>FlexChroma</a:t>
             </a:r>
             <a:r>
-              <a:rPr b="0">
+              <a:rPr b="0" dirty="0">
                 <a:latin typeface="+mn-lt"/>
                 <a:ea typeface="+mn-ea"/>
                 <a:cs typeface="+mn-cs"/>
                 <a:sym typeface="Jost-Regular"/>
               </a:rPr>
-              <a:t> umfasst Modelle zur Herstellung eigener Filamente aus handelsüblichen Materialien. </a:t>
+              <a:t> </a:t>
+            </a:r>
+            <a:r>
+              <a:rPr b="0" dirty="0" err="1">
+                <a:latin typeface="+mn-lt"/>
+                <a:ea typeface="+mn-ea"/>
+                <a:cs typeface="+mn-cs"/>
+                <a:sym typeface="Jost-Regular"/>
+              </a:rPr>
+              <a:t>umfasst</a:t>
+            </a:r>
+            <a:r>
+              <a:rPr b="0" dirty="0">
+                <a:latin typeface="+mn-lt"/>
+                <a:ea typeface="+mn-ea"/>
+                <a:cs typeface="+mn-cs"/>
+                <a:sym typeface="Jost-Regular"/>
+              </a:rPr>
+              <a:t> Modelle </a:t>
+            </a:r>
+            <a:r>
+              <a:rPr b="0" dirty="0" err="1">
+                <a:latin typeface="+mn-lt"/>
+                <a:ea typeface="+mn-ea"/>
+                <a:cs typeface="+mn-cs"/>
+                <a:sym typeface="Jost-Regular"/>
+              </a:rPr>
+              <a:t>zur</a:t>
+            </a:r>
+            <a:r>
+              <a:rPr b="0" dirty="0">
+                <a:latin typeface="+mn-lt"/>
+                <a:ea typeface="+mn-ea"/>
+                <a:cs typeface="+mn-cs"/>
+                <a:sym typeface="Jost-Regular"/>
+              </a:rPr>
+              <a:t> </a:t>
+            </a:r>
+            <a:r>
+              <a:rPr b="0" dirty="0" err="1">
+                <a:latin typeface="+mn-lt"/>
+                <a:ea typeface="+mn-ea"/>
+                <a:cs typeface="+mn-cs"/>
+                <a:sym typeface="Jost-Regular"/>
+              </a:rPr>
+              <a:t>Herstellung</a:t>
+            </a:r>
+            <a:r>
+              <a:rPr b="0" dirty="0">
+                <a:latin typeface="+mn-lt"/>
+                <a:ea typeface="+mn-ea"/>
+                <a:cs typeface="+mn-cs"/>
+                <a:sym typeface="Jost-Regular"/>
+              </a:rPr>
+              <a:t> </a:t>
+            </a:r>
+            <a:r>
+              <a:rPr b="0" dirty="0" err="1">
+                <a:latin typeface="+mn-lt"/>
+                <a:ea typeface="+mn-ea"/>
+                <a:cs typeface="+mn-cs"/>
+                <a:sym typeface="Jost-Regular"/>
+              </a:rPr>
+              <a:t>eigener</a:t>
+            </a:r>
+            <a:r>
+              <a:rPr b="0" dirty="0">
+                <a:latin typeface="+mn-lt"/>
+                <a:ea typeface="+mn-ea"/>
+                <a:cs typeface="+mn-cs"/>
+                <a:sym typeface="Jost-Regular"/>
+              </a:rPr>
+              <a:t> </a:t>
+            </a:r>
+            <a:r>
+              <a:rPr b="0" dirty="0" err="1">
+                <a:latin typeface="+mn-lt"/>
+                <a:ea typeface="+mn-ea"/>
+                <a:cs typeface="+mn-cs"/>
+                <a:sym typeface="Jost-Regular"/>
+              </a:rPr>
+              <a:t>Filamente</a:t>
+            </a:r>
+            <a:r>
+              <a:rPr b="0" dirty="0">
+                <a:latin typeface="+mn-lt"/>
+                <a:ea typeface="+mn-ea"/>
+                <a:cs typeface="+mn-cs"/>
+                <a:sym typeface="Jost-Regular"/>
+              </a:rPr>
+              <a:t> </a:t>
+            </a:r>
+            <a:r>
+              <a:rPr b="0" dirty="0" err="1">
+                <a:latin typeface="+mn-lt"/>
+                <a:ea typeface="+mn-ea"/>
+                <a:cs typeface="+mn-cs"/>
+                <a:sym typeface="Jost-Regular"/>
+              </a:rPr>
+              <a:t>aus</a:t>
+            </a:r>
+            <a:r>
+              <a:rPr b="0" dirty="0">
+                <a:latin typeface="+mn-lt"/>
+                <a:ea typeface="+mn-ea"/>
+                <a:cs typeface="+mn-cs"/>
+                <a:sym typeface="Jost-Regular"/>
+              </a:rPr>
+              <a:t> </a:t>
+            </a:r>
+            <a:r>
+              <a:rPr b="0" dirty="0" err="1">
+                <a:latin typeface="+mn-lt"/>
+                <a:ea typeface="+mn-ea"/>
+                <a:cs typeface="+mn-cs"/>
+                <a:sym typeface="Jost-Regular"/>
+              </a:rPr>
+              <a:t>handelsüblichen</a:t>
+            </a:r>
+            <a:r>
+              <a:rPr b="0" dirty="0">
+                <a:latin typeface="+mn-lt"/>
+                <a:ea typeface="+mn-ea"/>
+                <a:cs typeface="+mn-cs"/>
+                <a:sym typeface="Jost-Regular"/>
+              </a:rPr>
+              <a:t> </a:t>
+            </a:r>
+            <a:r>
+              <a:rPr b="0" dirty="0" err="1">
+                <a:latin typeface="+mn-lt"/>
+                <a:ea typeface="+mn-ea"/>
+                <a:cs typeface="+mn-cs"/>
+                <a:sym typeface="Jost-Regular"/>
+              </a:rPr>
+              <a:t>Materialien</a:t>
+            </a:r>
+            <a:r>
+              <a:rPr b="0" dirty="0">
+                <a:latin typeface="+mn-lt"/>
+                <a:ea typeface="+mn-ea"/>
+                <a:cs typeface="+mn-cs"/>
+                <a:sym typeface="Jost-Regular"/>
+              </a:rPr>
+              <a:t>. </a:t>
             </a:r>
           </a:p>
           <a:p>
@@ -3803,7 +3954,112 @@
               <a:defRPr sz="1000"/>
             </a:pPr>
             <a:r>
-              <a:t>Das System unterteilt sich in verschiedene Serien für unterschiedliche Einsatzzwecke. Jede Serie bietet mehrere Modelle, Profile und Druckplatten, abgestimmt auf Größe und Anwendung.</a:t>
+              <a:rPr dirty="0"/>
+              <a:t>Das System </a:t>
+            </a:r>
+            <a:r>
+              <a:rPr dirty="0" err="1"/>
+              <a:t>unterteilt</a:t>
+            </a:r>
+            <a:r>
+              <a:rPr dirty="0"/>
+              <a:t> </a:t>
+            </a:r>
+            <a:r>
+              <a:rPr dirty="0" err="1"/>
+              <a:t>sich</a:t>
+            </a:r>
+            <a:r>
+              <a:rPr dirty="0"/>
+              <a:t> in </a:t>
+            </a:r>
+            <a:r>
+              <a:rPr dirty="0" err="1"/>
+              <a:t>verschiedene</a:t>
+            </a:r>
+            <a:r>
+              <a:rPr dirty="0"/>
+              <a:t> </a:t>
+            </a:r>
+            <a:r>
+              <a:rPr dirty="0" err="1"/>
+              <a:t>Serien</a:t>
+            </a:r>
+            <a:r>
+              <a:rPr dirty="0"/>
+              <a:t> für </a:t>
+            </a:r>
+            <a:r>
+              <a:rPr dirty="0" err="1"/>
+              <a:t>unterschiedliche</a:t>
+            </a:r>
+            <a:r>
+              <a:rPr dirty="0"/>
+              <a:t> </a:t>
+            </a:r>
+            <a:r>
+              <a:rPr dirty="0" err="1"/>
+              <a:t>Einsatzzwecke</a:t>
+            </a:r>
+            <a:r>
+              <a:rPr dirty="0"/>
+              <a:t>. </a:t>
+            </a:r>
+            <a:r>
+              <a:rPr dirty="0" err="1"/>
+              <a:t>Jede</a:t>
+            </a:r>
+            <a:r>
+              <a:rPr dirty="0"/>
+              <a:t> Serie </a:t>
+            </a:r>
+            <a:r>
+              <a:rPr dirty="0" err="1"/>
+              <a:t>bietet</a:t>
+            </a:r>
+            <a:r>
+              <a:rPr dirty="0"/>
+              <a:t> </a:t>
+            </a:r>
+            <a:r>
+              <a:rPr dirty="0" err="1"/>
+              <a:t>mehrere</a:t>
+            </a:r>
+            <a:r>
+              <a:rPr dirty="0"/>
+              <a:t> Modelle, Profile und </a:t>
+            </a:r>
+            <a:r>
+              <a:rPr dirty="0" err="1"/>
+              <a:t>Druckplatten</a:t>
+            </a:r>
+            <a:r>
+              <a:rPr dirty="0"/>
+              <a:t>, </a:t>
+            </a:r>
+            <a:r>
+              <a:rPr dirty="0" err="1"/>
+              <a:t>abgestimmt</a:t>
+            </a:r>
+            <a:r>
+              <a:rPr dirty="0"/>
+              <a:t> auf </a:t>
+            </a:r>
+            <a:r>
+              <a:rPr dirty="0" err="1"/>
+              <a:t>Größe</a:t>
+            </a:r>
+            <a:r>
+              <a:rPr dirty="0"/>
+              <a:t> und </a:t>
+            </a:r>
+            <a:r>
+              <a:rPr dirty="0" err="1"/>
+              <a:t>Anwendung</a:t>
+            </a:r>
+            <a:r>
+              <a:rPr dirty="0"/>
+              <a:t>.</a:t>
             </a:r>
           </a:p>
         </p:txBody>
@@ -3866,7 +4122,7 @@
           </a:ln>
           <a:extLst>
             <a:ext uri="{C572A759-6A51-4108-AA02-DFA0A04FC94B}">
-              <ma14:wrappingTextBoxFlag xmlns="" xmlns:m="http://schemas.openxmlformats.org/officeDocument/2006/math" xmlns:a14="http://schemas.microsoft.com/office/drawing/2010/main" xmlns:ma14="http://schemas.microsoft.com/office/mac/drawingml/2011/main" val="1"/>
+              <ma14:wrappingTextBoxFlag xmlns:ma14="http://schemas.microsoft.com/office/mac/drawingml/2011/main" xmlns:a14="http://schemas.microsoft.com/office/drawing/2010/main" xmlns:m="http://schemas.openxmlformats.org/officeDocument/2006/math" xmlns="" val="1"/>
             </a:ext>
           </a:extLst>
         </p:spPr>
@@ -3910,7 +4166,7 @@
           </a:ln>
           <a:extLst>
             <a:ext uri="{C572A759-6A51-4108-AA02-DFA0A04FC94B}">
-              <ma14:wrappingTextBoxFlag xmlns="" xmlns:m="http://schemas.openxmlformats.org/officeDocument/2006/math" xmlns:a14="http://schemas.microsoft.com/office/drawing/2010/main" xmlns:ma14="http://schemas.microsoft.com/office/mac/drawingml/2011/main" val="1"/>
+              <ma14:wrappingTextBoxFlag xmlns:ma14="http://schemas.microsoft.com/office/mac/drawingml/2011/main" xmlns:a14="http://schemas.microsoft.com/office/drawing/2010/main" xmlns:m="http://schemas.openxmlformats.org/officeDocument/2006/math" xmlns="" val="1"/>
             </a:ext>
           </a:extLst>
         </p:spPr>
@@ -3949,7 +4205,7 @@
           </a:ln>
           <a:extLst>
             <a:ext uri="{C572A759-6A51-4108-AA02-DFA0A04FC94B}">
-              <ma14:wrappingTextBoxFlag xmlns="" xmlns:m="http://schemas.openxmlformats.org/officeDocument/2006/math" xmlns:a14="http://schemas.microsoft.com/office/drawing/2010/main" xmlns:ma14="http://schemas.microsoft.com/office/mac/drawingml/2011/main" val="1"/>
+              <ma14:wrappingTextBoxFlag xmlns:ma14="http://schemas.microsoft.com/office/mac/drawingml/2011/main" xmlns:a14="http://schemas.microsoft.com/office/drawing/2010/main" xmlns:m="http://schemas.openxmlformats.org/officeDocument/2006/math" xmlns="" val="1"/>
             </a:ext>
           </a:extLst>
         </p:spPr>
@@ -4057,7 +4313,7 @@
           </a:ln>
           <a:extLst>
             <a:ext uri="{C572A759-6A51-4108-AA02-DFA0A04FC94B}">
-              <ma14:wrappingTextBoxFlag xmlns="" xmlns:m="http://schemas.openxmlformats.org/officeDocument/2006/math" xmlns:a14="http://schemas.microsoft.com/office/drawing/2010/main" xmlns:ma14="http://schemas.microsoft.com/office/mac/drawingml/2011/main" val="1"/>
+              <ma14:wrappingTextBoxFlag xmlns:ma14="http://schemas.microsoft.com/office/mac/drawingml/2011/main" xmlns:a14="http://schemas.microsoft.com/office/drawing/2010/main" xmlns:m="http://schemas.openxmlformats.org/officeDocument/2006/math" xmlns="" val="1"/>
             </a:ext>
           </a:extLst>
         </p:spPr>
@@ -4481,7 +4737,7 @@
         <p:spPr>
           <a:xfrm>
             <a:off x="816562" y="8157903"/>
-            <a:ext cx="5372560" cy="421641"/>
+            <a:ext cx="5372560" cy="369332"/>
           </a:xfrm>
           <a:prstGeom prst="rect">
             <a:avLst/>
@@ -4491,7 +4747,7 @@
           </a:ln>
           <a:extLst>
             <a:ext uri="{C572A759-6A51-4108-AA02-DFA0A04FC94B}">
-              <ma14:wrappingTextBoxFlag xmlns="" xmlns:m="http://schemas.openxmlformats.org/officeDocument/2006/math" xmlns:a14="http://schemas.microsoft.com/office/drawing/2010/main" xmlns:ma14="http://schemas.microsoft.com/office/mac/drawingml/2011/main" val="1"/>
+              <ma14:wrappingTextBoxFlag xmlns:ma14="http://schemas.microsoft.com/office/mac/drawingml/2011/main" xmlns:a14="http://schemas.microsoft.com/office/drawing/2010/main" xmlns:m="http://schemas.openxmlformats.org/officeDocument/2006/math" xmlns="" val="1"/>
             </a:ext>
           </a:extLst>
         </p:spPr>
@@ -4510,7 +4766,99 @@
               </a:defRPr>
             </a:pPr>
             <a:r>
-              <a:t>*Hinweis: Der Begriff „Profil“ steht in FlexChroma für eine Einteilung nach Verwendungszweck, nicht für abweichende Druckeinstellungen.</a:t>
+              <a:rPr dirty="0"/>
+              <a:t>*</a:t>
+            </a:r>
+            <a:r>
+              <a:rPr dirty="0" err="1"/>
+              <a:t>Hinweis</a:t>
+            </a:r>
+            <a:r>
+              <a:rPr dirty="0"/>
+              <a:t>: Der </a:t>
+            </a:r>
+            <a:r>
+              <a:rPr dirty="0" err="1"/>
+              <a:t>Begriff</a:t>
+            </a:r>
+            <a:r>
+              <a:rPr dirty="0"/>
+              <a:t> „</a:t>
+            </a:r>
+            <a:r>
+              <a:rPr dirty="0" err="1"/>
+              <a:t>Profil</a:t>
+            </a:r>
+            <a:r>
+              <a:rPr dirty="0"/>
+              <a:t>“ </a:t>
+            </a:r>
+            <a:r>
+              <a:rPr dirty="0" err="1"/>
+              <a:t>steht</a:t>
+            </a:r>
+            <a:r>
+              <a:rPr dirty="0"/>
+              <a:t> in </a:t>
+            </a:r>
+            <a:r>
+              <a:rPr dirty="0">
+                <a:latin typeface="Jost SemiBold" pitchFamily="2" charset="0"/>
+                <a:ea typeface="Jost SemiBold" pitchFamily="2" charset="0"/>
+              </a:rPr>
+              <a:t>FlexChroma</a:t>
+            </a:r>
+            <a:r>
+              <a:rPr dirty="0"/>
+              <a:t> für </a:t>
+            </a:r>
+            <a:r>
+              <a:rPr dirty="0" err="1"/>
+              <a:t>eine</a:t>
+            </a:r>
+            <a:r>
+              <a:rPr dirty="0"/>
+              <a:t> </a:t>
+            </a:r>
+            <a:r>
+              <a:rPr dirty="0" err="1"/>
+              <a:t>Einteilung</a:t>
+            </a:r>
+            <a:r>
+              <a:rPr dirty="0"/>
+              <a:t> </a:t>
+            </a:r>
+            <a:r>
+              <a:rPr dirty="0" err="1"/>
+              <a:t>nach</a:t>
+            </a:r>
+            <a:r>
+              <a:rPr dirty="0"/>
+              <a:t> </a:t>
+            </a:r>
+            <a:r>
+              <a:rPr dirty="0" err="1"/>
+              <a:t>Verwendungszweck</a:t>
+            </a:r>
+            <a:r>
+              <a:rPr dirty="0"/>
+              <a:t>, nicht für </a:t>
+            </a:r>
+            <a:r>
+              <a:rPr dirty="0" err="1"/>
+              <a:t>abweichende</a:t>
+            </a:r>
+            <a:r>
+              <a:rPr dirty="0"/>
+              <a:t> </a:t>
+            </a:r>
+            <a:r>
+              <a:rPr dirty="0" err="1"/>
+              <a:t>Druckeinstellungen</a:t>
+            </a:r>
+            <a:r>
+              <a:rPr dirty="0"/>
+              <a:t>.</a:t>
             </a:r>
           </a:p>
         </p:txBody>
@@ -4523,8 +4871,8 @@
         </p:nvGrpSpPr>
         <p:grpSpPr>
           <a:xfrm>
-            <a:off x="1042025" y="441444"/>
-            <a:ext cx="4781217" cy="377794"/>
+            <a:off x="993974" y="441444"/>
+            <a:ext cx="4877319" cy="377794"/>
             <a:chOff x="0" y="0"/>
             <a:chExt cx="4781215" cy="377792"/>
           </a:xfrm>
@@ -4718,8 +5066,8 @@
         </p:nvGrpSpPr>
         <p:grpSpPr>
           <a:xfrm>
-            <a:off x="1042024" y="2224672"/>
-            <a:ext cx="4781217" cy="377794"/>
+            <a:off x="993973" y="2224672"/>
+            <a:ext cx="4877319" cy="377794"/>
             <a:chOff x="0" y="0"/>
             <a:chExt cx="4781215" cy="377792"/>
           </a:xfrm>
@@ -4914,7 +5262,7 @@
         <p:spPr>
           <a:xfrm>
             <a:off x="1934144" y="1459500"/>
-            <a:ext cx="2970886" cy="383541"/>
+            <a:ext cx="3072314" cy="338554"/>
           </a:xfrm>
           <a:prstGeom prst="rect">
             <a:avLst/>
@@ -4924,7 +5272,7 @@
           </a:ln>
           <a:extLst>
             <a:ext uri="{C572A759-6A51-4108-AA02-DFA0A04FC94B}">
-              <ma14:wrappingTextBoxFlag xmlns="" xmlns:m="http://schemas.openxmlformats.org/officeDocument/2006/math" xmlns:a14="http://schemas.microsoft.com/office/drawing/2010/main" xmlns:ma14="http://schemas.microsoft.com/office/mac/drawingml/2011/main" val="1"/>
+              <ma14:wrappingTextBoxFlag xmlns:ma14="http://schemas.microsoft.com/office/mac/drawingml/2011/main" xmlns:a14="http://schemas.microsoft.com/office/drawing/2010/main" xmlns:m="http://schemas.openxmlformats.org/officeDocument/2006/math" xmlns="" val="1"/>
             </a:ext>
           </a:extLst>
         </p:spPr>
@@ -4939,7 +5287,30 @@
           </a:lstStyle>
           <a:p>
             <a:r>
-              <a:t>- FlexChroma Dokumentenarchiv -</a:t>
+              <a:rPr dirty="0"/>
+              <a:t>- </a:t>
+            </a:r>
+            <a:r>
+              <a:rPr dirty="0">
+                <a:latin typeface="Jost SemiBold" pitchFamily="2" charset="0"/>
+                <a:ea typeface="Jost SemiBold" pitchFamily="2" charset="0"/>
+              </a:rPr>
+              <a:t>FlexChroma</a:t>
+            </a:r>
+            <a:r>
+              <a:rPr dirty="0"/>
+              <a:t> </a:t>
+            </a:r>
+            <a:r>
+              <a:rPr dirty="0" err="1">
+                <a:latin typeface="Jost" pitchFamily="2" charset="0"/>
+                <a:ea typeface="Jost" pitchFamily="2" charset="0"/>
+              </a:rPr>
+              <a:t>Dokumentenarchiv</a:t>
+            </a:r>
+            <a:r>
+              <a:rPr dirty="0"/>
+              <a:t> -</a:t>
             </a:r>
           </a:p>
         </p:txBody>
@@ -4963,7 +5334,7 @@
           </a:ln>
           <a:extLst>
             <a:ext uri="{C572A759-6A51-4108-AA02-DFA0A04FC94B}">
-              <ma14:wrappingTextBoxFlag xmlns="" xmlns:m="http://schemas.openxmlformats.org/officeDocument/2006/math" xmlns:a14="http://schemas.microsoft.com/office/drawing/2010/main" xmlns:ma14="http://schemas.microsoft.com/office/mac/drawingml/2011/main" val="1"/>
+              <ma14:wrappingTextBoxFlag xmlns:ma14="http://schemas.microsoft.com/office/mac/drawingml/2011/main" xmlns:a14="http://schemas.microsoft.com/office/drawing/2010/main" xmlns:m="http://schemas.openxmlformats.org/officeDocument/2006/math" xmlns="" val="1"/>
             </a:ext>
           </a:extLst>
         </p:spPr>
@@ -4978,6 +5349,7 @@
           </a:lstStyle>
           <a:p>
             <a:r>
+              <a:rPr dirty="0"/>
               <a:t>Ver.1.00  2026.9.1</a:t>
             </a:r>
           </a:p>
@@ -4999,7 +5371,7 @@
         </p:blipFill>
         <p:spPr>
           <a:xfrm>
-            <a:off x="1062623" y="950702"/>
+            <a:off x="993972" y="877017"/>
             <a:ext cx="484295" cy="466866"/>
           </a:xfrm>
           <a:prstGeom prst="rect">
@@ -5497,7 +5869,7 @@
           </a:ln>
           <a:extLst>
             <a:ext uri="{C572A759-6A51-4108-AA02-DFA0A04FC94B}">
-              <ma14:wrappingTextBoxFlag xmlns="" xmlns:m="http://schemas.openxmlformats.org/officeDocument/2006/math" xmlns:a14="http://schemas.microsoft.com/office/drawing/2010/main" xmlns:ma14="http://schemas.microsoft.com/office/mac/drawingml/2011/main" val="1"/>
+              <ma14:wrappingTextBoxFlag xmlns:ma14="http://schemas.microsoft.com/office/mac/drawingml/2011/main" xmlns:a14="http://schemas.microsoft.com/office/drawing/2010/main" xmlns:m="http://schemas.openxmlformats.org/officeDocument/2006/math" xmlns="" val="1"/>
             </a:ext>
           </a:extLst>
         </p:spPr>
@@ -5612,7 +5984,7 @@
           </a:ln>
           <a:extLst>
             <a:ext uri="{C572A759-6A51-4108-AA02-DFA0A04FC94B}">
-              <ma14:wrappingTextBoxFlag xmlns="" xmlns:m="http://schemas.openxmlformats.org/officeDocument/2006/math" xmlns:a14="http://schemas.microsoft.com/office/drawing/2010/main" xmlns:ma14="http://schemas.microsoft.com/office/mac/drawingml/2011/main" val="1"/>
+              <ma14:wrappingTextBoxFlag xmlns:ma14="http://schemas.microsoft.com/office/mac/drawingml/2011/main" xmlns:a14="http://schemas.microsoft.com/office/drawing/2010/main" xmlns:m="http://schemas.openxmlformats.org/officeDocument/2006/math" xmlns="" val="1"/>
             </a:ext>
           </a:extLst>
         </p:spPr>
@@ -5657,7 +6029,7 @@
           </a:ln>
           <a:extLst>
             <a:ext uri="{C572A759-6A51-4108-AA02-DFA0A04FC94B}">
-              <ma14:wrappingTextBoxFlag xmlns="" xmlns:m="http://schemas.openxmlformats.org/officeDocument/2006/math" xmlns:a14="http://schemas.microsoft.com/office/drawing/2010/main" xmlns:ma14="http://schemas.microsoft.com/office/mac/drawingml/2011/main" val="1"/>
+              <ma14:wrappingTextBoxFlag xmlns:ma14="http://schemas.microsoft.com/office/mac/drawingml/2011/main" xmlns:a14="http://schemas.microsoft.com/office/drawing/2010/main" xmlns:m="http://schemas.openxmlformats.org/officeDocument/2006/math" xmlns="" val="1"/>
             </a:ext>
           </a:extLst>
         </p:spPr>
@@ -5676,8 +6048,8 @@
             </a:r>
             <a:r>
               <a:rPr dirty="0">
-                <a:latin typeface="Jost Medium" pitchFamily="2" charset="0"/>
-                <a:ea typeface="Jost Medium" pitchFamily="2" charset="0"/>
+                <a:latin typeface="Jost SemiBold" pitchFamily="2" charset="0"/>
+                <a:ea typeface="Jost SemiBold" pitchFamily="2" charset="0"/>
               </a:rPr>
               <a:t>FlexChroma</a:t>
             </a:r>
@@ -5940,7 +6312,7 @@
           </a:ln>
           <a:extLst>
             <a:ext uri="{C572A759-6A51-4108-AA02-DFA0A04FC94B}">
-              <ma14:wrappingTextBoxFlag xmlns="" xmlns:m="http://schemas.openxmlformats.org/officeDocument/2006/math" xmlns:a14="http://schemas.microsoft.com/office/drawing/2010/main" xmlns:ma14="http://schemas.microsoft.com/office/mac/drawingml/2011/main" val="1"/>
+              <ma14:wrappingTextBoxFlag xmlns:ma14="http://schemas.microsoft.com/office/mac/drawingml/2011/main" xmlns:a14="http://schemas.microsoft.com/office/drawing/2010/main" xmlns:m="http://schemas.openxmlformats.org/officeDocument/2006/math" xmlns="" val="1"/>
             </a:ext>
           </a:extLst>
         </p:spPr>
@@ -5974,7 +6346,7 @@
         <p:spPr>
           <a:xfrm>
             <a:off x="714228" y="2819223"/>
-            <a:ext cx="5550784" cy="1704341"/>
+            <a:ext cx="5550784" cy="1400383"/>
           </a:xfrm>
           <a:prstGeom prst="rect">
             <a:avLst/>
@@ -5984,7 +6356,7 @@
           </a:ln>
           <a:extLst>
             <a:ext uri="{C572A759-6A51-4108-AA02-DFA0A04FC94B}">
-              <ma14:wrappingTextBoxFlag xmlns="" xmlns:m="http://schemas.openxmlformats.org/officeDocument/2006/math" xmlns:a14="http://schemas.microsoft.com/office/drawing/2010/main" xmlns:ma14="http://schemas.microsoft.com/office/mac/drawingml/2011/main" val="1"/>
+              <ma14:wrappingTextBoxFlag xmlns:ma14="http://schemas.microsoft.com/office/mac/drawingml/2011/main" xmlns:a14="http://schemas.microsoft.com/office/drawing/2010/main" xmlns:m="http://schemas.openxmlformats.org/officeDocument/2006/math" xmlns="" val="1"/>
             </a:ext>
           </a:extLst>
         </p:spPr>
@@ -5998,7 +6370,155 @@
               <a:defRPr sz="1000"/>
             </a:pPr>
             <a:r>
-              <a:t>Die Mischfilament Serie bildet das grundlegendste Sortiment von FlexChroma. Sie ermöglicht es Ihnen, zwei Filamente in verschiedenen Verhältnissen zu mischen, um Ihre eigene individuelle Farbe zu kreieren. </a:t>
+              <a:rPr dirty="0"/>
+              <a:t>Die </a:t>
+            </a:r>
+            <a:r>
+              <a:rPr dirty="0" err="1"/>
+              <a:t>Mischfilament</a:t>
+            </a:r>
+            <a:r>
+              <a:rPr dirty="0"/>
+              <a:t> Serie </a:t>
+            </a:r>
+            <a:r>
+              <a:rPr dirty="0" err="1"/>
+              <a:t>bildet</a:t>
+            </a:r>
+            <a:r>
+              <a:rPr dirty="0"/>
+              <a:t> das </a:t>
+            </a:r>
+            <a:r>
+              <a:rPr dirty="0" err="1"/>
+              <a:t>grundlegendste</a:t>
+            </a:r>
+            <a:r>
+              <a:rPr dirty="0"/>
+              <a:t> </a:t>
+            </a:r>
+            <a:r>
+              <a:rPr dirty="0" err="1"/>
+              <a:t>Sortiment</a:t>
+            </a:r>
+            <a:r>
+              <a:rPr dirty="0"/>
+              <a:t> von </a:t>
+            </a:r>
+            <a:r>
+              <a:rPr dirty="0">
+                <a:latin typeface="Jost SemiBold" pitchFamily="2" charset="0"/>
+                <a:ea typeface="Jost SemiBold" pitchFamily="2" charset="0"/>
+              </a:rPr>
+              <a:t>FlexChroma</a:t>
+            </a:r>
+            <a:r>
+              <a:rPr dirty="0"/>
+              <a:t>. Sie </a:t>
+            </a:r>
+            <a:r>
+              <a:rPr dirty="0" err="1"/>
+              <a:t>ermöglicht</a:t>
+            </a:r>
+            <a:r>
+              <a:rPr dirty="0"/>
+              <a:t> es Ihnen, </a:t>
+            </a:r>
+            <a:r>
+              <a:rPr dirty="0" err="1"/>
+              <a:t>zwei</a:t>
+            </a:r>
+            <a:r>
+              <a:rPr dirty="0"/>
+              <a:t> </a:t>
+            </a:r>
+            <a:r>
+              <a:rPr dirty="0" err="1"/>
+              <a:t>Filamente</a:t>
+            </a:r>
+            <a:r>
+              <a:rPr dirty="0"/>
+              <a:t> in </a:t>
+            </a:r>
+            <a:r>
+              <a:rPr dirty="0" err="1"/>
+              <a:t>verschiedenen</a:t>
+            </a:r>
+            <a:r>
+              <a:rPr dirty="0"/>
+              <a:t> </a:t>
+            </a:r>
+            <a:r>
+              <a:rPr dirty="0" err="1"/>
+              <a:t>Verhältnissen</a:t>
+            </a:r>
+            <a:r>
+              <a:rPr dirty="0"/>
+              <a:t> </a:t>
+            </a:r>
+            <a:r>
+              <a:rPr dirty="0" err="1"/>
+              <a:t>zu</a:t>
+            </a:r>
+            <a:r>
+              <a:rPr dirty="0"/>
+              <a:t> </a:t>
+            </a:r>
+            <a:r>
+              <a:rPr dirty="0" err="1"/>
+              <a:t>mischen</a:t>
+            </a:r>
+            <a:r>
+              <a:rPr dirty="0"/>
+              <a:t>, um </a:t>
+            </a:r>
+            <a:r>
+              <a:rPr dirty="0" err="1"/>
+              <a:t>Ihre</a:t>
+            </a:r>
+            <a:r>
+              <a:rPr dirty="0"/>
+              <a:t> </a:t>
+            </a:r>
+            <a:r>
+              <a:rPr dirty="0" err="1"/>
+              <a:t>eigene</a:t>
+            </a:r>
+            <a:r>
+              <a:rPr dirty="0"/>
+              <a:t> </a:t>
+            </a:r>
+            <a:r>
+              <a:rPr dirty="0" err="1"/>
+              <a:t>individuelle</a:t>
+            </a:r>
+            <a:r>
+              <a:rPr dirty="0"/>
+              <a:t> </a:t>
+            </a:r>
+            <a:r>
+              <a:rPr dirty="0" err="1"/>
+              <a:t>Farbe</a:t>
+            </a:r>
+            <a:r>
+              <a:rPr dirty="0"/>
+              <a:t> </a:t>
+            </a:r>
+            <a:r>
+              <a:rPr dirty="0" err="1"/>
+              <a:t>zu</a:t>
+            </a:r>
+            <a:r>
+              <a:rPr dirty="0"/>
+              <a:t> </a:t>
+            </a:r>
+            <a:r>
+              <a:rPr dirty="0" err="1"/>
+              <a:t>kreieren</a:t>
+            </a:r>
+            <a:r>
+              <a:rPr dirty="0"/>
+              <a:t>. </a:t>
             </a:r>
           </a:p>
           <a:p>
@@ -6011,8 +6531,74 @@
               </a:defRPr>
             </a:pPr>
             <a:r>
-              <a:t>Jedes Modell deckt dabei Mischungsverhältnisse von 50 % bis 99,5 % ab. Für Werte unter 50 % tauschen Sie einfach Filament A und Filament B aus.</a:t>
-            </a:r>
+              <a:rPr dirty="0" err="1"/>
+              <a:t>Jedes</a:t>
+            </a:r>
+            <a:r>
+              <a:rPr dirty="0"/>
+              <a:t> Modell </a:t>
+            </a:r>
+            <a:r>
+              <a:rPr dirty="0" err="1"/>
+              <a:t>deckt</a:t>
+            </a:r>
+            <a:r>
+              <a:rPr dirty="0"/>
+              <a:t> </a:t>
+            </a:r>
+            <a:r>
+              <a:rPr dirty="0" err="1"/>
+              <a:t>dabei</a:t>
+            </a:r>
+            <a:r>
+              <a:rPr dirty="0"/>
+              <a:t> </a:t>
+            </a:r>
+            <a:r>
+              <a:rPr dirty="0" err="1"/>
+              <a:t>Mischungsverhältnisse</a:t>
+            </a:r>
+            <a:r>
+              <a:rPr dirty="0"/>
+              <a:t> von 50 % bis 99,5 % ab. Für </a:t>
+            </a:r>
+            <a:r>
+              <a:rPr dirty="0" err="1"/>
+              <a:t>Werte</a:t>
+            </a:r>
+            <a:r>
+              <a:rPr dirty="0"/>
+              <a:t> </a:t>
+            </a:r>
+            <a:r>
+              <a:rPr dirty="0" err="1"/>
+              <a:t>unter</a:t>
+            </a:r>
+            <a:r>
+              <a:rPr dirty="0"/>
+              <a:t> 50 % </a:t>
+            </a:r>
+            <a:r>
+              <a:rPr dirty="0" err="1"/>
+              <a:t>tauschen</a:t>
+            </a:r>
+            <a:r>
+              <a:rPr dirty="0"/>
+              <a:t> Sie </a:t>
+            </a:r>
+            <a:r>
+              <a:rPr dirty="0" err="1"/>
+              <a:t>einfach</a:t>
+            </a:r>
+            <a:r>
+              <a:rPr dirty="0"/>
+              <a:t> Filament A und Filament B </a:t>
+            </a:r>
+            <a:r>
+              <a:rPr dirty="0" err="1"/>
+              <a:t>aus.</a:t>
+            </a:r>
+            <a:endParaRPr dirty="0"/>
           </a:p>
           <a:p>
             <a:pPr>
@@ -6023,14 +6609,131 @@
                 <a:sym typeface="JostRoman-Bold"/>
               </a:defRPr>
             </a:pPr>
-            <a:endParaRPr/>
+            <a:endParaRPr dirty="0"/>
           </a:p>
           <a:p>
             <a:pPr>
               <a:defRPr sz="1000"/>
             </a:pPr>
             <a:r>
-              <a:t>Beispiel: Um ein Filament mit 25 % Cyan gemischt in Gelb zu erstellen, lesen Sie den Wert der Druckplatte als Verhältnis von Filament A ab, interpretieren diesen als 75 % Gelb und slicen das Modell entsprechend.</a:t>
+              <a:rPr dirty="0" err="1"/>
+              <a:t>Beispiel</a:t>
+            </a:r>
+            <a:r>
+              <a:rPr dirty="0"/>
+              <a:t>: Um </a:t>
+            </a:r>
+            <a:r>
+              <a:rPr dirty="0" err="1"/>
+              <a:t>ein</a:t>
+            </a:r>
+            <a:r>
+              <a:rPr dirty="0"/>
+              <a:t> Filament </a:t>
+            </a:r>
+            <a:r>
+              <a:rPr dirty="0" err="1"/>
+              <a:t>mit</a:t>
+            </a:r>
+            <a:r>
+              <a:rPr dirty="0"/>
+              <a:t> 25 % Cyan </a:t>
+            </a:r>
+            <a:r>
+              <a:rPr dirty="0" err="1"/>
+              <a:t>gemischt</a:t>
+            </a:r>
+            <a:r>
+              <a:rPr dirty="0"/>
+              <a:t> in Gelb </a:t>
+            </a:r>
+            <a:r>
+              <a:rPr dirty="0" err="1"/>
+              <a:t>zu</a:t>
+            </a:r>
+            <a:r>
+              <a:rPr dirty="0"/>
+              <a:t> </a:t>
+            </a:r>
+            <a:r>
+              <a:rPr dirty="0" err="1"/>
+              <a:t>erstellen</a:t>
+            </a:r>
+            <a:r>
+              <a:rPr dirty="0"/>
+              <a:t>, </a:t>
+            </a:r>
+            <a:r>
+              <a:rPr dirty="0" err="1"/>
+              <a:t>lesen</a:t>
+            </a:r>
+            <a:r>
+              <a:rPr dirty="0"/>
+              <a:t> Sie den Wert der </a:t>
+            </a:r>
+            <a:r>
+              <a:rPr dirty="0" err="1"/>
+              <a:t>Druckplatte</a:t>
+            </a:r>
+            <a:r>
+              <a:rPr dirty="0"/>
+              <a:t> </a:t>
+            </a:r>
+            <a:r>
+              <a:rPr dirty="0" err="1"/>
+              <a:t>als</a:t>
+            </a:r>
+            <a:r>
+              <a:rPr dirty="0"/>
+              <a:t> </a:t>
+            </a:r>
+            <a:r>
+              <a:rPr dirty="0" err="1"/>
+              <a:t>Verhältnis</a:t>
+            </a:r>
+            <a:r>
+              <a:rPr dirty="0"/>
+              <a:t> von Filament A ab, </a:t>
+            </a:r>
+            <a:r>
+              <a:rPr dirty="0" err="1"/>
+              <a:t>interpretieren</a:t>
+            </a:r>
+            <a:r>
+              <a:rPr dirty="0"/>
+              <a:t> </a:t>
+            </a:r>
+            <a:r>
+              <a:rPr dirty="0" err="1"/>
+              <a:t>diesen</a:t>
+            </a:r>
+            <a:r>
+              <a:rPr dirty="0"/>
+              <a:t> </a:t>
+            </a:r>
+            <a:r>
+              <a:rPr dirty="0" err="1"/>
+              <a:t>als</a:t>
+            </a:r>
+            <a:r>
+              <a:rPr dirty="0"/>
+              <a:t> 75 % Gelb und </a:t>
+            </a:r>
+            <a:r>
+              <a:rPr dirty="0" err="1"/>
+              <a:t>slicen</a:t>
+            </a:r>
+            <a:r>
+              <a:rPr dirty="0"/>
+              <a:t> das Modell </a:t>
+            </a:r>
+            <a:r>
+              <a:rPr dirty="0" err="1"/>
+              <a:t>entsprechend</a:t>
+            </a:r>
+            <a:r>
+              <a:rPr dirty="0"/>
+              <a:t>.</a:t>
             </a:r>
           </a:p>
         </p:txBody>
@@ -6054,7 +6757,7 @@
           </a:ln>
           <a:extLst>
             <a:ext uri="{C572A759-6A51-4108-AA02-DFA0A04FC94B}">
-              <ma14:wrappingTextBoxFlag xmlns="" xmlns:m="http://schemas.openxmlformats.org/officeDocument/2006/math" xmlns:a14="http://schemas.microsoft.com/office/drawing/2010/main" xmlns:ma14="http://schemas.microsoft.com/office/mac/drawingml/2011/main" val="1"/>
+              <ma14:wrappingTextBoxFlag xmlns:ma14="http://schemas.microsoft.com/office/mac/drawingml/2011/main" xmlns:a14="http://schemas.microsoft.com/office/drawing/2010/main" xmlns:m="http://schemas.openxmlformats.org/officeDocument/2006/math" xmlns="" val="1"/>
             </a:ext>
           </a:extLst>
         </p:spPr>
@@ -6615,7 +7318,7 @@
           </a:ln>
           <a:extLst>
             <a:ext uri="{C572A759-6A51-4108-AA02-DFA0A04FC94B}">
-              <ma14:wrappingTextBoxFlag xmlns="" xmlns:m="http://schemas.openxmlformats.org/officeDocument/2006/math" xmlns:a14="http://schemas.microsoft.com/office/drawing/2010/main" xmlns:ma14="http://schemas.microsoft.com/office/mac/drawingml/2011/main" val="1"/>
+              <ma14:wrappingTextBoxFlag xmlns:ma14="http://schemas.microsoft.com/office/mac/drawingml/2011/main" xmlns:a14="http://schemas.microsoft.com/office/drawing/2010/main" xmlns:m="http://schemas.openxmlformats.org/officeDocument/2006/math" xmlns="" val="1"/>
             </a:ext>
           </a:extLst>
         </p:spPr>
@@ -6691,7 +7394,7 @@
           </a:ln>
           <a:extLst>
             <a:ext uri="{C572A759-6A51-4108-AA02-DFA0A04FC94B}">
-              <ma14:wrappingTextBoxFlag xmlns="" xmlns:m="http://schemas.openxmlformats.org/officeDocument/2006/math" xmlns:a14="http://schemas.microsoft.com/office/drawing/2010/main" xmlns:ma14="http://schemas.microsoft.com/office/mac/drawingml/2011/main" val="1"/>
+              <ma14:wrappingTextBoxFlag xmlns:ma14="http://schemas.microsoft.com/office/mac/drawingml/2011/main" xmlns:a14="http://schemas.microsoft.com/office/drawing/2010/main" xmlns:m="http://schemas.openxmlformats.org/officeDocument/2006/math" xmlns="" val="1"/>
             </a:ext>
           </a:extLst>
         </p:spPr>
@@ -6744,7 +7447,7 @@
           </a:ln>
           <a:extLst>
             <a:ext uri="{C572A759-6A51-4108-AA02-DFA0A04FC94B}">
-              <ma14:wrappingTextBoxFlag xmlns="" xmlns:m="http://schemas.openxmlformats.org/officeDocument/2006/math" xmlns:a14="http://schemas.microsoft.com/office/drawing/2010/main" xmlns:ma14="http://schemas.microsoft.com/office/mac/drawingml/2011/main" val="1"/>
+              <ma14:wrappingTextBoxFlag xmlns:ma14="http://schemas.microsoft.com/office/mac/drawingml/2011/main" xmlns:a14="http://schemas.microsoft.com/office/drawing/2010/main" xmlns:m="http://schemas.openxmlformats.org/officeDocument/2006/math" xmlns="" val="1"/>
             </a:ext>
           </a:extLst>
         </p:spPr>
@@ -6812,7 +7515,7 @@
           </a:ln>
           <a:extLst>
             <a:ext uri="{C572A759-6A51-4108-AA02-DFA0A04FC94B}">
-              <ma14:wrappingTextBoxFlag xmlns="" xmlns:m="http://schemas.openxmlformats.org/officeDocument/2006/math" xmlns:a14="http://schemas.microsoft.com/office/drawing/2010/main" xmlns:ma14="http://schemas.microsoft.com/office/mac/drawingml/2011/main" val="1"/>
+              <ma14:wrappingTextBoxFlag xmlns:ma14="http://schemas.microsoft.com/office/mac/drawingml/2011/main" xmlns:a14="http://schemas.microsoft.com/office/drawing/2010/main" xmlns:m="http://schemas.openxmlformats.org/officeDocument/2006/math" xmlns="" val="1"/>
             </a:ext>
           </a:extLst>
         </p:spPr>
@@ -7930,8 +8633,8 @@
         </p:nvSpPr>
         <p:spPr>
           <a:xfrm>
-            <a:off x="3209546" y="8485377"/>
-            <a:ext cx="484295" cy="421641"/>
+            <a:off x="3209546" y="8511531"/>
+            <a:ext cx="484295" cy="369332"/>
           </a:xfrm>
           <a:prstGeom prst="rect">
             <a:avLst/>
@@ -7941,7 +8644,7 @@
           </a:ln>
           <a:extLst>
             <a:ext uri="{C572A759-6A51-4108-AA02-DFA0A04FC94B}">
-              <ma14:wrappingTextBoxFlag xmlns="" xmlns:m="http://schemas.openxmlformats.org/officeDocument/2006/math" xmlns:a14="http://schemas.microsoft.com/office/drawing/2010/main" xmlns:ma14="http://schemas.microsoft.com/office/mac/drawingml/2011/main" val="1"/>
+              <ma14:wrappingTextBoxFlag xmlns:ma14="http://schemas.microsoft.com/office/mac/drawingml/2011/main" xmlns:a14="http://schemas.microsoft.com/office/drawing/2010/main" xmlns:m="http://schemas.openxmlformats.org/officeDocument/2006/math" xmlns="" val="1"/>
             </a:ext>
           </a:extLst>
         </p:spPr>
@@ -7954,6 +8657,7 @@
           </a:lstStyle>
           <a:p>
             <a:r>
+              <a:rPr dirty="0"/>
               <a:t>4</a:t>
             </a:r>
           </a:p>
@@ -8007,7 +8711,7 @@
         <p:spPr>
           <a:xfrm>
             <a:off x="823834" y="772101"/>
-            <a:ext cx="1804552" cy="383541"/>
+            <a:ext cx="1865252" cy="338554"/>
           </a:xfrm>
           <a:prstGeom prst="rect">
             <a:avLst/>
@@ -8017,7 +8721,7 @@
           </a:ln>
           <a:extLst>
             <a:ext uri="{C572A759-6A51-4108-AA02-DFA0A04FC94B}">
-              <ma14:wrappingTextBoxFlag xmlns="" xmlns:m="http://schemas.openxmlformats.org/officeDocument/2006/math" xmlns:a14="http://schemas.microsoft.com/office/drawing/2010/main" xmlns:ma14="http://schemas.microsoft.com/office/mac/drawingml/2011/main" val="1"/>
+              <ma14:wrappingTextBoxFlag xmlns:ma14="http://schemas.microsoft.com/office/mac/drawingml/2011/main" xmlns:a14="http://schemas.microsoft.com/office/drawing/2010/main" xmlns:m="http://schemas.openxmlformats.org/officeDocument/2006/math" xmlns="" val="1"/>
             </a:ext>
           </a:extLst>
         </p:spPr>
@@ -8037,14 +8741,20 @@
           </a:lstStyle>
           <a:p>
             <a:r>
-              <a:rPr dirty="0"/>
+              <a:rPr dirty="0">
+                <a:latin typeface="+mj-lt"/>
+              </a:rPr>
               <a:t>6. Update </a:t>
             </a:r>
             <a:r>
-              <a:rPr dirty="0" err="1"/>
+              <a:rPr dirty="0" err="1">
+                <a:latin typeface="+mj-lt"/>
+              </a:rPr>
               <a:t>Historie</a:t>
             </a:r>
-            <a:endParaRPr dirty="0"/>
+            <a:endParaRPr dirty="0">
+              <a:latin typeface="+mj-lt"/>
+            </a:endParaRPr>
           </a:p>
         </p:txBody>
       </p:sp>
@@ -8057,7 +8767,7 @@
         <p:spPr>
           <a:xfrm>
             <a:off x="684043" y="1115239"/>
-            <a:ext cx="5558051" cy="256541"/>
+            <a:ext cx="5558051" cy="230832"/>
           </a:xfrm>
           <a:prstGeom prst="rect">
             <a:avLst/>
@@ -8067,7 +8777,7 @@
           </a:ln>
           <a:extLst>
             <a:ext uri="{C572A759-6A51-4108-AA02-DFA0A04FC94B}">
-              <ma14:wrappingTextBoxFlag xmlns="" xmlns:m="http://schemas.openxmlformats.org/officeDocument/2006/math" xmlns:a14="http://schemas.microsoft.com/office/drawing/2010/main" xmlns:ma14="http://schemas.microsoft.com/office/mac/drawingml/2011/main" val="1"/>
+              <ma14:wrappingTextBoxFlag xmlns:ma14="http://schemas.microsoft.com/office/mac/drawingml/2011/main" xmlns:a14="http://schemas.microsoft.com/office/drawing/2010/main" xmlns:m="http://schemas.openxmlformats.org/officeDocument/2006/math" xmlns="" val="1"/>
             </a:ext>
           </a:extLst>
         </p:spPr>
@@ -8082,14 +8792,20 @@
           </a:lstStyle>
           <a:p>
             <a:r>
-              <a:rPr dirty="0"/>
+              <a:rPr dirty="0">
+                <a:latin typeface="+mj-lt"/>
+              </a:rPr>
               <a:t>Ver.1.00  2026-09-01  Erste Version </a:t>
             </a:r>
             <a:r>
-              <a:rPr dirty="0" err="1"/>
+              <a:rPr dirty="0" err="1">
+                <a:latin typeface="+mj-lt"/>
+              </a:rPr>
               <a:t>veröffentlicht</a:t>
             </a:r>
-            <a:endParaRPr dirty="0"/>
+            <a:endParaRPr dirty="0">
+              <a:latin typeface="+mj-lt"/>
+            </a:endParaRPr>
           </a:p>
         </p:txBody>
       </p:sp>
@@ -8118,7 +8834,7 @@
           </a:ln>
           <a:extLst>
             <a:ext uri="{C572A759-6A51-4108-AA02-DFA0A04FC94B}">
-              <ma14:wrappingTextBoxFlag xmlns="" xmlns:m="http://schemas.openxmlformats.org/officeDocument/2006/math" xmlns:a14="http://schemas.microsoft.com/office/drawing/2010/main" xmlns:ma14="http://schemas.microsoft.com/office/mac/drawingml/2011/main" val="1"/>
+              <ma14:wrappingTextBoxFlag xmlns:ma14="http://schemas.microsoft.com/office/mac/drawingml/2011/main" xmlns:a14="http://schemas.microsoft.com/office/drawing/2010/main" xmlns:m="http://schemas.openxmlformats.org/officeDocument/2006/math" xmlns="" val="1"/>
             </a:ext>
           </a:extLst>
         </p:spPr>
@@ -8133,28 +8849,40 @@
           </a:lstStyle>
           <a:p>
             <a:r>
-              <a:rPr lang="en-US" sz="1000" dirty="0" err="1"/>
+              <a:rPr lang="en-US" sz="1000" dirty="0" err="1">
+                <a:latin typeface="+mj-lt"/>
+              </a:rPr>
               <a:t>Nennung</a:t>
             </a:r>
             <a:r>
-              <a:rPr lang="en-US" sz="1000" dirty="0"/>
+              <a:rPr lang="en-US" sz="1000" dirty="0">
+                <a:latin typeface="+mj-lt"/>
+              </a:rPr>
               <a:t> : </a:t>
             </a:r>
           </a:p>
           <a:p>
             <a:r>
-              <a:rPr lang="en-US" sz="1000" dirty="0"/>
+              <a:rPr lang="en-US" sz="1000" dirty="0">
+                <a:latin typeface="+mj-lt"/>
+              </a:rPr>
               <a:t> Deutsche </a:t>
             </a:r>
             <a:r>
-              <a:rPr lang="en-US" sz="1000" dirty="0" err="1"/>
+              <a:rPr lang="en-US" sz="1000" dirty="0" err="1">
+                <a:latin typeface="+mj-lt"/>
+              </a:rPr>
               <a:t>Übersetzung</a:t>
             </a:r>
             <a:r>
-              <a:rPr lang="en-US" sz="1000" dirty="0"/>
+              <a:rPr lang="en-US" sz="1000" dirty="0">
+                <a:latin typeface="+mj-lt"/>
+              </a:rPr>
               <a:t> –Domenik</a:t>
             </a:r>
-            <a:endParaRPr sz="1000" dirty="0"/>
+            <a:endParaRPr sz="1000" dirty="0">
+              <a:latin typeface="+mj-lt"/>
+            </a:endParaRPr>
           </a:p>
         </p:txBody>
       </p:sp>
@@ -8175,7 +8903,7 @@
         <p:cNvPr id="1" name="">
           <a:extLst>
             <a:ext uri="{FF2B5EF4-FFF2-40B4-BE49-F238E27FC236}">
-              <a16:creationId xmlns:a16="http://schemas.microsoft.com/office/drawing/2014/main" id="{B181533B-51BE-0125-C0AC-3E921E28248A}"/>
+              <a16:creationId xmlns:a16="http://schemas.microsoft.com/office/drawing/2014/main" id="{CE693C9B-3BE9-8BCA-DC0E-07BE3EA89E80}"/>
             </a:ext>
           </a:extLst>
         </p:cNvPr>
@@ -8195,7 +8923,7 @@
           <p:cNvPr id="106" name="正方形/長方形 31">
             <a:extLst>
               <a:ext uri="{FF2B5EF4-FFF2-40B4-BE49-F238E27FC236}">
-                <a16:creationId xmlns:a16="http://schemas.microsoft.com/office/drawing/2014/main" id="{9758962D-A558-7663-91E8-5236D817CF32}"/>
+                <a16:creationId xmlns:a16="http://schemas.microsoft.com/office/drawing/2014/main" id="{DB8367BB-F6DF-650B-1E22-A347B5E349F2}"/>
               </a:ext>
             </a:extLst>
           </p:cNvPr>
@@ -8245,10 +8973,10 @@
       </p:sp>
       <p:sp>
         <p:nvSpPr>
-          <p:cNvPr id="11" name="フリーフォーム: 図形 10">
+          <p:cNvPr id="12" name="フリーフォーム: 図形 11">
             <a:extLst>
               <a:ext uri="{FF2B5EF4-FFF2-40B4-BE49-F238E27FC236}">
-                <a16:creationId xmlns:a16="http://schemas.microsoft.com/office/drawing/2014/main" id="{3B252398-2709-408A-29D1-04934C29BB60}"/>
+                <a16:creationId xmlns:a16="http://schemas.microsoft.com/office/drawing/2014/main" id="{E8A2B72B-57FF-3FC9-2C95-CFB6DC50C351}"/>
               </a:ext>
             </a:extLst>
           </p:cNvPr>
@@ -8257,379 +8985,379 @@
         </p:nvSpPr>
         <p:spPr>
           <a:xfrm>
-            <a:off x="-4150" y="0"/>
+            <a:off x="0" y="9342"/>
             <a:ext cx="6858000" cy="9144000"/>
           </a:xfrm>
           <a:custGeom>
             <a:avLst/>
             <a:gdLst>
-              <a:gd name="connsiteX0" fmla="*/ 3734844 w 6858000"/>
-              <a:gd name="connsiteY0" fmla="*/ 8661917 h 9144000"/>
-              <a:gd name="connsiteX1" fmla="*/ 3734844 w 6858000"/>
-              <a:gd name="connsiteY1" fmla="*/ 8715918 h 9144000"/>
-              <a:gd name="connsiteX2" fmla="*/ 6326845 w 6858000"/>
-              <a:gd name="connsiteY2" fmla="*/ 8715918 h 9144000"/>
-              <a:gd name="connsiteX3" fmla="*/ 6326845 w 6858000"/>
-              <a:gd name="connsiteY3" fmla="*/ 8661917 h 9144000"/>
-              <a:gd name="connsiteX4" fmla="*/ 554537 w 6858000"/>
-              <a:gd name="connsiteY4" fmla="*/ 8661917 h 9144000"/>
-              <a:gd name="connsiteX5" fmla="*/ 554537 w 6858000"/>
-              <a:gd name="connsiteY5" fmla="*/ 8715918 h 9144000"/>
-              <a:gd name="connsiteX6" fmla="*/ 3146539 w 6858000"/>
-              <a:gd name="connsiteY6" fmla="*/ 8715918 h 9144000"/>
-              <a:gd name="connsiteX7" fmla="*/ 3146539 w 6858000"/>
-              <a:gd name="connsiteY7" fmla="*/ 8661917 h 9144000"/>
-              <a:gd name="connsiteX8" fmla="*/ 663431 w 6858000"/>
-              <a:gd name="connsiteY8" fmla="*/ 4344641 h 9144000"/>
-              <a:gd name="connsiteX9" fmla="*/ 561095 w 6858000"/>
-              <a:gd name="connsiteY9" fmla="*/ 4446977 h 9144000"/>
-              <a:gd name="connsiteX10" fmla="*/ 663431 w 6858000"/>
-              <a:gd name="connsiteY10" fmla="*/ 4549313 h 9144000"/>
-              <a:gd name="connsiteX11" fmla="*/ 765767 w 6858000"/>
-              <a:gd name="connsiteY11" fmla="*/ 4446977 h 9144000"/>
-              <a:gd name="connsiteX12" fmla="*/ 663431 w 6858000"/>
-              <a:gd name="connsiteY12" fmla="*/ 4344641 h 9144000"/>
-              <a:gd name="connsiteX13" fmla="*/ 668510 w 6858000"/>
-              <a:gd name="connsiteY13" fmla="*/ 3089647 h 9144000"/>
-              <a:gd name="connsiteX14" fmla="*/ 566174 w 6858000"/>
-              <a:gd name="connsiteY14" fmla="*/ 3191983 h 9144000"/>
-              <a:gd name="connsiteX15" fmla="*/ 668510 w 6858000"/>
-              <a:gd name="connsiteY15" fmla="*/ 3294319 h 9144000"/>
-              <a:gd name="connsiteX16" fmla="*/ 770846 w 6858000"/>
-              <a:gd name="connsiteY16" fmla="*/ 3191983 h 9144000"/>
-              <a:gd name="connsiteX17" fmla="*/ 668510 w 6858000"/>
-              <a:gd name="connsiteY17" fmla="*/ 3089647 h 9144000"/>
-              <a:gd name="connsiteX18" fmla="*/ 5823241 w 6858000"/>
-              <a:gd name="connsiteY18" fmla="*/ 2279980 h 9144000"/>
-              <a:gd name="connsiteX19" fmla="*/ 5807028 w 6858000"/>
-              <a:gd name="connsiteY19" fmla="*/ 2319085 h 9144000"/>
-              <a:gd name="connsiteX20" fmla="*/ 5767904 w 6858000"/>
-              <a:gd name="connsiteY20" fmla="*/ 2335283 h 9144000"/>
-              <a:gd name="connsiteX21" fmla="*/ 1097361 w 6858000"/>
-              <a:gd name="connsiteY21" fmla="*/ 2335283 h 9144000"/>
-              <a:gd name="connsiteX22" fmla="*/ 1058237 w 6858000"/>
-              <a:gd name="connsiteY22" fmla="*/ 2319085 h 9144000"/>
-              <a:gd name="connsiteX23" fmla="*/ 1042025 w 6858000"/>
-              <a:gd name="connsiteY23" fmla="*/ 2279982 h 9144000"/>
-              <a:gd name="connsiteX24" fmla="*/ 1042025 w 6858000"/>
-              <a:gd name="connsiteY24" fmla="*/ 2413569 h 9144000"/>
-              <a:gd name="connsiteX25" fmla="*/ 1230839 w 6858000"/>
-              <a:gd name="connsiteY25" fmla="*/ 2602467 h 9144000"/>
-              <a:gd name="connsiteX26" fmla="*/ 5634427 w 6858000"/>
-              <a:gd name="connsiteY26" fmla="*/ 2602467 h 9144000"/>
-              <a:gd name="connsiteX27" fmla="*/ 5823241 w 6858000"/>
-              <a:gd name="connsiteY27" fmla="*/ 2413570 h 9144000"/>
-              <a:gd name="connsiteX28" fmla="*/ 1230839 w 6858000"/>
-              <a:gd name="connsiteY28" fmla="*/ 436680 h 9144000"/>
-              <a:gd name="connsiteX29" fmla="*/ 1042025 w 6858000"/>
-              <a:gd name="connsiteY29" fmla="*/ 625578 h 9144000"/>
-              <a:gd name="connsiteX30" fmla="*/ 1042025 w 6858000"/>
-              <a:gd name="connsiteY30" fmla="*/ 763930 h 9144000"/>
-              <a:gd name="connsiteX31" fmla="*/ 1058238 w 6858000"/>
-              <a:gd name="connsiteY31" fmla="*/ 724825 h 9144000"/>
-              <a:gd name="connsiteX32" fmla="*/ 1097362 w 6858000"/>
-              <a:gd name="connsiteY32" fmla="*/ 708627 h 9144000"/>
-              <a:gd name="connsiteX33" fmla="*/ 5767905 w 6858000"/>
-              <a:gd name="connsiteY33" fmla="*/ 708627 h 9144000"/>
-              <a:gd name="connsiteX34" fmla="*/ 5807029 w 6858000"/>
-              <a:gd name="connsiteY34" fmla="*/ 724825 h 9144000"/>
-              <a:gd name="connsiteX35" fmla="*/ 5823241 w 6858000"/>
-              <a:gd name="connsiteY35" fmla="*/ 763928 h 9144000"/>
-              <a:gd name="connsiteX36" fmla="*/ 5823241 w 6858000"/>
-              <a:gd name="connsiteY36" fmla="*/ 625578 h 9144000"/>
-              <a:gd name="connsiteX37" fmla="*/ 5634427 w 6858000"/>
-              <a:gd name="connsiteY37" fmla="*/ 436680 h 9144000"/>
-              <a:gd name="connsiteX38" fmla="*/ 0 w 6858000"/>
-              <a:gd name="connsiteY38" fmla="*/ 0 h 9144000"/>
-              <a:gd name="connsiteX39" fmla="*/ 6858000 w 6858000"/>
-              <a:gd name="connsiteY39" fmla="*/ 0 h 9144000"/>
-              <a:gd name="connsiteX40" fmla="*/ 6858000 w 6858000"/>
-              <a:gd name="connsiteY40" fmla="*/ 9144000 h 9144000"/>
-              <a:gd name="connsiteX41" fmla="*/ 0 w 6858000"/>
-              <a:gd name="connsiteY41" fmla="*/ 9144000 h 9144000"/>
+              <a:gd name="csX0" fmla="*/ 3734844 w 6858000"/>
+              <a:gd name="csY0" fmla="*/ 8652575 h 9144000"/>
+              <a:gd name="csX1" fmla="*/ 3734844 w 6858000"/>
+              <a:gd name="csY1" fmla="*/ 8706576 h 9144000"/>
+              <a:gd name="csX2" fmla="*/ 6326845 w 6858000"/>
+              <a:gd name="csY2" fmla="*/ 8706576 h 9144000"/>
+              <a:gd name="csX3" fmla="*/ 6326845 w 6858000"/>
+              <a:gd name="csY3" fmla="*/ 8652575 h 9144000"/>
+              <a:gd name="csX4" fmla="*/ 554537 w 6858000"/>
+              <a:gd name="csY4" fmla="*/ 8652575 h 9144000"/>
+              <a:gd name="csX5" fmla="*/ 554537 w 6858000"/>
+              <a:gd name="csY5" fmla="*/ 8706576 h 9144000"/>
+              <a:gd name="csX6" fmla="*/ 3146539 w 6858000"/>
+              <a:gd name="csY6" fmla="*/ 8706576 h 9144000"/>
+              <a:gd name="csX7" fmla="*/ 3146539 w 6858000"/>
+              <a:gd name="csY7" fmla="*/ 8652575 h 9144000"/>
+              <a:gd name="csX8" fmla="*/ 663431 w 6858000"/>
+              <a:gd name="csY8" fmla="*/ 4354349 h 9144000"/>
+              <a:gd name="csX9" fmla="*/ 561095 w 6858000"/>
+              <a:gd name="csY9" fmla="*/ 4456685 h 9144000"/>
+              <a:gd name="csX10" fmla="*/ 663431 w 6858000"/>
+              <a:gd name="csY10" fmla="*/ 4559021 h 9144000"/>
+              <a:gd name="csX11" fmla="*/ 765767 w 6858000"/>
+              <a:gd name="csY11" fmla="*/ 4456685 h 9144000"/>
+              <a:gd name="csX12" fmla="*/ 663431 w 6858000"/>
+              <a:gd name="csY12" fmla="*/ 4354349 h 9144000"/>
+              <a:gd name="csX13" fmla="*/ 668510 w 6858000"/>
+              <a:gd name="csY13" fmla="*/ 3105328 h 9144000"/>
+              <a:gd name="csX14" fmla="*/ 566174 w 6858000"/>
+              <a:gd name="csY14" fmla="*/ 3207664 h 9144000"/>
+              <a:gd name="csX15" fmla="*/ 668510 w 6858000"/>
+              <a:gd name="csY15" fmla="*/ 3310000 h 9144000"/>
+              <a:gd name="csX16" fmla="*/ 770846 w 6858000"/>
+              <a:gd name="csY16" fmla="*/ 3207664 h 9144000"/>
+              <a:gd name="csX17" fmla="*/ 668510 w 6858000"/>
+              <a:gd name="csY17" fmla="*/ 3105328 h 9144000"/>
+              <a:gd name="csX18" fmla="*/ 5871292 w 6858000"/>
+              <a:gd name="csY18" fmla="*/ 2270638 h 9144000"/>
+              <a:gd name="csX19" fmla="*/ 5854753 w 6858000"/>
+              <a:gd name="csY19" fmla="*/ 2309743 h 9144000"/>
+              <a:gd name="csX20" fmla="*/ 5814842 w 6858000"/>
+              <a:gd name="csY20" fmla="*/ 2325941 h 9144000"/>
+              <a:gd name="csX21" fmla="*/ 1050423 w 6858000"/>
+              <a:gd name="csY21" fmla="*/ 2325941 h 9144000"/>
+              <a:gd name="csX22" fmla="*/ 1010512 w 6858000"/>
+              <a:gd name="csY22" fmla="*/ 2309743 h 9144000"/>
+              <a:gd name="csX23" fmla="*/ 993974 w 6858000"/>
+              <a:gd name="csY23" fmla="*/ 2270640 h 9144000"/>
+              <a:gd name="csX24" fmla="*/ 993974 w 6858000"/>
+              <a:gd name="csY24" fmla="*/ 2404227 h 9144000"/>
+              <a:gd name="csX25" fmla="*/ 1186583 w 6858000"/>
+              <a:gd name="csY25" fmla="*/ 2593125 h 9144000"/>
+              <a:gd name="csX26" fmla="*/ 5678683 w 6858000"/>
+              <a:gd name="csY26" fmla="*/ 2593125 h 9144000"/>
+              <a:gd name="csX27" fmla="*/ 5871292 w 6858000"/>
+              <a:gd name="csY27" fmla="*/ 2404228 h 9144000"/>
+              <a:gd name="csX28" fmla="*/ 1186583 w 6858000"/>
+              <a:gd name="csY28" fmla="*/ 432102 h 9144000"/>
+              <a:gd name="csX29" fmla="*/ 993974 w 6858000"/>
+              <a:gd name="csY29" fmla="*/ 621000 h 9144000"/>
+              <a:gd name="csX30" fmla="*/ 993974 w 6858000"/>
+              <a:gd name="csY30" fmla="*/ 762209 h 9144000"/>
+              <a:gd name="csX31" fmla="*/ 1010513 w 6858000"/>
+              <a:gd name="csY31" fmla="*/ 723104 h 9144000"/>
+              <a:gd name="csX32" fmla="*/ 1050424 w 6858000"/>
+              <a:gd name="csY32" fmla="*/ 706906 h 9144000"/>
+              <a:gd name="csX33" fmla="*/ 5814844 w 6858000"/>
+              <a:gd name="csY33" fmla="*/ 706906 h 9144000"/>
+              <a:gd name="csX34" fmla="*/ 5854754 w 6858000"/>
+              <a:gd name="csY34" fmla="*/ 723104 h 9144000"/>
+              <a:gd name="csX35" fmla="*/ 5871292 w 6858000"/>
+              <a:gd name="csY35" fmla="*/ 762207 h 9144000"/>
+              <a:gd name="csX36" fmla="*/ 5871292 w 6858000"/>
+              <a:gd name="csY36" fmla="*/ 621000 h 9144000"/>
+              <a:gd name="csX37" fmla="*/ 5678683 w 6858000"/>
+              <a:gd name="csY37" fmla="*/ 432102 h 9144000"/>
+              <a:gd name="csX38" fmla="*/ 0 w 6858000"/>
+              <a:gd name="csY38" fmla="*/ 0 h 9144000"/>
+              <a:gd name="csX39" fmla="*/ 6858000 w 6858000"/>
+              <a:gd name="csY39" fmla="*/ 0 h 9144000"/>
+              <a:gd name="csX40" fmla="*/ 6858000 w 6858000"/>
+              <a:gd name="csY40" fmla="*/ 9144000 h 9144000"/>
+              <a:gd name="csX41" fmla="*/ 0 w 6858000"/>
+              <a:gd name="csY41" fmla="*/ 9144000 h 9144000"/>
             </a:gdLst>
             <a:ahLst/>
             <a:cxnLst>
               <a:cxn ang="0">
-                <a:pos x="connsiteX0" y="connsiteY0"/>
+                <a:pos x="csX0" y="csY0"/>
               </a:cxn>
               <a:cxn ang="0">
-                <a:pos x="connsiteX1" y="connsiteY1"/>
+                <a:pos x="csX1" y="csY1"/>
               </a:cxn>
               <a:cxn ang="0">
-                <a:pos x="connsiteX2" y="connsiteY2"/>
+                <a:pos x="csX2" y="csY2"/>
               </a:cxn>
               <a:cxn ang="0">
-                <a:pos x="connsiteX3" y="connsiteY3"/>
+                <a:pos x="csX3" y="csY3"/>
               </a:cxn>
               <a:cxn ang="0">
-                <a:pos x="connsiteX4" y="connsiteY4"/>
+                <a:pos x="csX4" y="csY4"/>
               </a:cxn>
               <a:cxn ang="0">
-                <a:pos x="connsiteX5" y="connsiteY5"/>
+                <a:pos x="csX5" y="csY5"/>
               </a:cxn>
               <a:cxn ang="0">
-                <a:pos x="connsiteX6" y="connsiteY6"/>
+                <a:pos x="csX6" y="csY6"/>
               </a:cxn>
               <a:cxn ang="0">
-                <a:pos x="connsiteX7" y="connsiteY7"/>
+                <a:pos x="csX7" y="csY7"/>
               </a:cxn>
               <a:cxn ang="0">
-                <a:pos x="connsiteX8" y="connsiteY8"/>
+                <a:pos x="csX8" y="csY8"/>
               </a:cxn>
               <a:cxn ang="0">
-                <a:pos x="connsiteX9" y="connsiteY9"/>
+                <a:pos x="csX9" y="csY9"/>
               </a:cxn>
               <a:cxn ang="0">
-                <a:pos x="connsiteX10" y="connsiteY10"/>
+                <a:pos x="csX10" y="csY10"/>
               </a:cxn>
               <a:cxn ang="0">
-                <a:pos x="connsiteX11" y="connsiteY11"/>
+                <a:pos x="csX11" y="csY11"/>
               </a:cxn>
               <a:cxn ang="0">
-                <a:pos x="connsiteX12" y="connsiteY12"/>
+                <a:pos x="csX12" y="csY12"/>
               </a:cxn>
               <a:cxn ang="0">
-                <a:pos x="connsiteX13" y="connsiteY13"/>
+                <a:pos x="csX13" y="csY13"/>
               </a:cxn>
               <a:cxn ang="0">
-                <a:pos x="connsiteX14" y="connsiteY14"/>
+                <a:pos x="csX14" y="csY14"/>
               </a:cxn>
               <a:cxn ang="0">
-                <a:pos x="connsiteX15" y="connsiteY15"/>
+                <a:pos x="csX15" y="csY15"/>
               </a:cxn>
               <a:cxn ang="0">
-                <a:pos x="connsiteX16" y="connsiteY16"/>
+                <a:pos x="csX16" y="csY16"/>
               </a:cxn>
               <a:cxn ang="0">
-                <a:pos x="connsiteX17" y="connsiteY17"/>
+                <a:pos x="csX17" y="csY17"/>
               </a:cxn>
               <a:cxn ang="0">
-                <a:pos x="connsiteX18" y="connsiteY18"/>
+                <a:pos x="csX18" y="csY18"/>
               </a:cxn>
               <a:cxn ang="0">
-                <a:pos x="connsiteX19" y="connsiteY19"/>
+                <a:pos x="csX19" y="csY19"/>
               </a:cxn>
               <a:cxn ang="0">
-                <a:pos x="connsiteX20" y="connsiteY20"/>
+                <a:pos x="csX20" y="csY20"/>
               </a:cxn>
               <a:cxn ang="0">
-                <a:pos x="connsiteX21" y="connsiteY21"/>
+                <a:pos x="csX21" y="csY21"/>
               </a:cxn>
               <a:cxn ang="0">
-                <a:pos x="connsiteX22" y="connsiteY22"/>
+                <a:pos x="csX22" y="csY22"/>
               </a:cxn>
               <a:cxn ang="0">
-                <a:pos x="connsiteX23" y="connsiteY23"/>
+                <a:pos x="csX23" y="csY23"/>
               </a:cxn>
               <a:cxn ang="0">
-                <a:pos x="connsiteX24" y="connsiteY24"/>
+                <a:pos x="csX24" y="csY24"/>
               </a:cxn>
               <a:cxn ang="0">
-                <a:pos x="connsiteX25" y="connsiteY25"/>
+                <a:pos x="csX25" y="csY25"/>
               </a:cxn>
               <a:cxn ang="0">
-                <a:pos x="connsiteX26" y="connsiteY26"/>
+                <a:pos x="csX26" y="csY26"/>
               </a:cxn>
               <a:cxn ang="0">
-                <a:pos x="connsiteX27" y="connsiteY27"/>
+                <a:pos x="csX27" y="csY27"/>
               </a:cxn>
               <a:cxn ang="0">
-                <a:pos x="connsiteX28" y="connsiteY28"/>
+                <a:pos x="csX28" y="csY28"/>
               </a:cxn>
               <a:cxn ang="0">
-                <a:pos x="connsiteX29" y="connsiteY29"/>
+                <a:pos x="csX29" y="csY29"/>
               </a:cxn>
               <a:cxn ang="0">
-                <a:pos x="connsiteX30" y="connsiteY30"/>
+                <a:pos x="csX30" y="csY30"/>
               </a:cxn>
               <a:cxn ang="0">
-                <a:pos x="connsiteX31" y="connsiteY31"/>
+                <a:pos x="csX31" y="csY31"/>
               </a:cxn>
               <a:cxn ang="0">
-                <a:pos x="connsiteX32" y="connsiteY32"/>
+                <a:pos x="csX32" y="csY32"/>
               </a:cxn>
               <a:cxn ang="0">
-                <a:pos x="connsiteX33" y="connsiteY33"/>
+                <a:pos x="csX33" y="csY33"/>
               </a:cxn>
               <a:cxn ang="0">
-                <a:pos x="connsiteX34" y="connsiteY34"/>
+                <a:pos x="csX34" y="csY34"/>
               </a:cxn>
               <a:cxn ang="0">
-                <a:pos x="connsiteX35" y="connsiteY35"/>
+                <a:pos x="csX35" y="csY35"/>
               </a:cxn>
               <a:cxn ang="0">
-                <a:pos x="connsiteX36" y="connsiteY36"/>
+                <a:pos x="csX36" y="csY36"/>
               </a:cxn>
               <a:cxn ang="0">
-                <a:pos x="connsiteX37" y="connsiteY37"/>
+                <a:pos x="csX37" y="csY37"/>
               </a:cxn>
               <a:cxn ang="0">
-                <a:pos x="connsiteX38" y="connsiteY38"/>
+                <a:pos x="csX38" y="csY38"/>
               </a:cxn>
               <a:cxn ang="0">
-                <a:pos x="connsiteX39" y="connsiteY39"/>
+                <a:pos x="csX39" y="csY39"/>
               </a:cxn>
               <a:cxn ang="0">
-                <a:pos x="connsiteX40" y="connsiteY40"/>
+                <a:pos x="csX40" y="csY40"/>
               </a:cxn>
               <a:cxn ang="0">
-                <a:pos x="connsiteX41" y="connsiteY41"/>
+                <a:pos x="csX41" y="csY41"/>
               </a:cxn>
             </a:cxnLst>
             <a:rect l="l" t="t" r="r" b="b"/>
             <a:pathLst>
               <a:path w="6858000" h="9144000">
                 <a:moveTo>
-                  <a:pt x="3734844" y="8661917"/>
+                  <a:pt x="3734844" y="8652575"/>
                 </a:moveTo>
                 <a:lnTo>
-                  <a:pt x="3734844" y="8715918"/>
+                  <a:pt x="3734844" y="8706576"/>
                 </a:lnTo>
                 <a:lnTo>
-                  <a:pt x="6326845" y="8715918"/>
+                  <a:pt x="6326845" y="8706576"/>
                 </a:lnTo>
                 <a:lnTo>
-                  <a:pt x="6326845" y="8661917"/>
+                  <a:pt x="6326845" y="8652575"/>
                 </a:lnTo>
                 <a:close/>
                 <a:moveTo>
-                  <a:pt x="554537" y="8661917"/>
+                  <a:pt x="554537" y="8652575"/>
                 </a:moveTo>
                 <a:lnTo>
-                  <a:pt x="554537" y="8715918"/>
+                  <a:pt x="554537" y="8706576"/>
                 </a:lnTo>
                 <a:lnTo>
-                  <a:pt x="3146539" y="8715918"/>
+                  <a:pt x="3146539" y="8706576"/>
                 </a:lnTo>
                 <a:lnTo>
-                  <a:pt x="3146539" y="8661917"/>
+                  <a:pt x="3146539" y="8652575"/>
                 </a:lnTo>
                 <a:close/>
                 <a:moveTo>
-                  <a:pt x="663431" y="4344641"/>
+                  <a:pt x="663431" y="4354349"/>
                 </a:moveTo>
                 <a:cubicBezTo>
-                  <a:pt x="606912" y="4344641"/>
-                  <a:pt x="561095" y="4390458"/>
-                  <a:pt x="561095" y="4446977"/>
+                  <a:pt x="606912" y="4354349"/>
+                  <a:pt x="561095" y="4400166"/>
+                  <a:pt x="561095" y="4456685"/>
                 </a:cubicBezTo>
                 <a:cubicBezTo>
-                  <a:pt x="561095" y="4503496"/>
-                  <a:pt x="606912" y="4549313"/>
-                  <a:pt x="663431" y="4549313"/>
+                  <a:pt x="561095" y="4513204"/>
+                  <a:pt x="606912" y="4559021"/>
+                  <a:pt x="663431" y="4559021"/>
                 </a:cubicBezTo>
                 <a:cubicBezTo>
-                  <a:pt x="719950" y="4549313"/>
-                  <a:pt x="765767" y="4503496"/>
-                  <a:pt x="765767" y="4446977"/>
+                  <a:pt x="719950" y="4559021"/>
+                  <a:pt x="765767" y="4513204"/>
+                  <a:pt x="765767" y="4456685"/>
                 </a:cubicBezTo>
                 <a:cubicBezTo>
-                  <a:pt x="765767" y="4390458"/>
-                  <a:pt x="719950" y="4344641"/>
-                  <a:pt x="663431" y="4344641"/>
+                  <a:pt x="765767" y="4400166"/>
+                  <a:pt x="719950" y="4354349"/>
+                  <a:pt x="663431" y="4354349"/>
                 </a:cubicBezTo>
                 <a:close/>
                 <a:moveTo>
-                  <a:pt x="668510" y="3089647"/>
+                  <a:pt x="668510" y="3105328"/>
                 </a:moveTo>
                 <a:cubicBezTo>
-                  <a:pt x="611991" y="3089647"/>
-                  <a:pt x="566174" y="3135464"/>
-                  <a:pt x="566174" y="3191983"/>
+                  <a:pt x="611991" y="3105328"/>
+                  <a:pt x="566174" y="3151145"/>
+                  <a:pt x="566174" y="3207664"/>
                 </a:cubicBezTo>
                 <a:cubicBezTo>
-                  <a:pt x="566174" y="3248502"/>
-                  <a:pt x="611991" y="3294319"/>
-                  <a:pt x="668510" y="3294319"/>
+                  <a:pt x="566174" y="3264183"/>
+                  <a:pt x="611991" y="3310000"/>
+                  <a:pt x="668510" y="3310000"/>
                 </a:cubicBezTo>
                 <a:cubicBezTo>
-                  <a:pt x="725029" y="3294319"/>
-                  <a:pt x="770846" y="3248502"/>
-                  <a:pt x="770846" y="3191983"/>
+                  <a:pt x="725029" y="3310000"/>
+                  <a:pt x="770846" y="3264183"/>
+                  <a:pt x="770846" y="3207664"/>
                 </a:cubicBezTo>
                 <a:cubicBezTo>
-                  <a:pt x="770846" y="3135464"/>
-                  <a:pt x="725029" y="3089647"/>
-                  <a:pt x="668510" y="3089647"/>
+                  <a:pt x="770846" y="3151145"/>
+                  <a:pt x="725029" y="3105328"/>
+                  <a:pt x="668510" y="3105328"/>
                 </a:cubicBezTo>
                 <a:close/>
                 <a:moveTo>
-                  <a:pt x="5823241" y="2279980"/>
+                  <a:pt x="5871292" y="2270638"/>
                 </a:moveTo>
                 <a:lnTo>
-                  <a:pt x="5807028" y="2319085"/>
+                  <a:pt x="5854753" y="2309743"/>
                 </a:lnTo>
                 <a:cubicBezTo>
-                  <a:pt x="5797011" y="2329093"/>
-                  <a:pt x="5783177" y="2335283"/>
-                  <a:pt x="5767904" y="2335283"/>
+                  <a:pt x="5844535" y="2319751"/>
+                  <a:pt x="5830422" y="2325941"/>
+                  <a:pt x="5814842" y="2325941"/>
                 </a:cubicBezTo>
                 <a:lnTo>
-                  <a:pt x="1097361" y="2335283"/>
+                  <a:pt x="1050423" y="2325941"/>
                 </a:lnTo>
                 <a:cubicBezTo>
-                  <a:pt x="1082088" y="2335283"/>
-                  <a:pt x="1068253" y="2329093"/>
-                  <a:pt x="1058237" y="2319085"/>
+                  <a:pt x="1034842" y="2325941"/>
+                  <a:pt x="1020730" y="2319751"/>
+                  <a:pt x="1010512" y="2309743"/>
                 </a:cubicBezTo>
                 <a:lnTo>
-                  <a:pt x="1042025" y="2279982"/>
+                  <a:pt x="993974" y="2270640"/>
                 </a:lnTo>
                 <a:lnTo>
-                  <a:pt x="1042025" y="2413569"/>
+                  <a:pt x="993974" y="2404227"/>
                 </a:lnTo>
                 <a:cubicBezTo>
-                  <a:pt x="1042025" y="2517900"/>
-                  <a:pt x="1126581" y="2602467"/>
-                  <a:pt x="1230839" y="2602467"/>
+                  <a:pt x="993974" y="2508558"/>
+                  <a:pt x="1080231" y="2593125"/>
+                  <a:pt x="1186583" y="2593125"/>
                 </a:cubicBezTo>
                 <a:lnTo>
-                  <a:pt x="5634427" y="2602467"/>
+                  <a:pt x="5678683" y="2593125"/>
                 </a:lnTo>
                 <a:cubicBezTo>
-                  <a:pt x="5738684" y="2602467"/>
-                  <a:pt x="5823241" y="2517901"/>
-                  <a:pt x="5823241" y="2413570"/>
+                  <a:pt x="5785035" y="2593125"/>
+                  <a:pt x="5871292" y="2508559"/>
+                  <a:pt x="5871292" y="2404228"/>
                 </a:cubicBezTo>
                 <a:close/>
                 <a:moveTo>
-                  <a:pt x="1230839" y="436680"/>
+                  <a:pt x="1186583" y="432102"/>
                 </a:moveTo>
                 <a:cubicBezTo>
-                  <a:pt x="1126582" y="436680"/>
-                  <a:pt x="1042025" y="521247"/>
-                  <a:pt x="1042025" y="625578"/>
+                  <a:pt x="1080230" y="432102"/>
+                  <a:pt x="993974" y="516669"/>
+                  <a:pt x="993974" y="621000"/>
                 </a:cubicBezTo>
                 <a:lnTo>
-                  <a:pt x="1042025" y="763930"/>
+                  <a:pt x="993974" y="762209"/>
                 </a:lnTo>
                 <a:lnTo>
-                  <a:pt x="1058238" y="724825"/>
+                  <a:pt x="1010513" y="723104"/>
                 </a:lnTo>
                 <a:cubicBezTo>
-                  <a:pt x="1068254" y="714817"/>
-                  <a:pt x="1082089" y="708627"/>
-                  <a:pt x="1097362" y="708627"/>
+                  <a:pt x="1020731" y="713096"/>
+                  <a:pt x="1034843" y="706906"/>
+                  <a:pt x="1050424" y="706906"/>
                 </a:cubicBezTo>
                 <a:lnTo>
-                  <a:pt x="5767905" y="708627"/>
+                  <a:pt x="5814844" y="706906"/>
                 </a:lnTo>
                 <a:cubicBezTo>
-                  <a:pt x="5783178" y="708627"/>
-                  <a:pt x="5797013" y="714817"/>
-                  <a:pt x="5807029" y="724825"/>
+                  <a:pt x="5830424" y="706906"/>
+                  <a:pt x="5844537" y="713096"/>
+                  <a:pt x="5854754" y="723104"/>
                 </a:cubicBezTo>
                 <a:lnTo>
-                  <a:pt x="5823241" y="763928"/>
+                  <a:pt x="5871292" y="762207"/>
                 </a:lnTo>
                 <a:lnTo>
-                  <a:pt x="5823241" y="625578"/>
+                  <a:pt x="5871292" y="621000"/>
                 </a:lnTo>
                 <a:cubicBezTo>
-                  <a:pt x="5823241" y="521247"/>
-                  <a:pt x="5738685" y="436680"/>
-                  <a:pt x="5634427" y="436680"/>
+                  <a:pt x="5871292" y="516669"/>
+                  <a:pt x="5785036" y="432102"/>
+                  <a:pt x="5678683" y="432102"/>
                 </a:cubicBezTo>
                 <a:close/>
                 <a:moveTo>
@@ -8668,7 +9396,7 @@
                 </a:solidFill>
               </a:defRPr>
             </a:pPr>
-            <a:endParaRPr/>
+            <a:endParaRPr dirty="0"/>
           </a:p>
         </p:txBody>
       </p:sp>
@@ -8677,7 +9405,7 @@
           <p:cNvPr id="115" name="テキスト ボックス 16">
             <a:extLst>
               <a:ext uri="{FF2B5EF4-FFF2-40B4-BE49-F238E27FC236}">
-                <a16:creationId xmlns:a16="http://schemas.microsoft.com/office/drawing/2014/main" id="{0B15B1FE-7F2C-2239-01F2-4A88DB500E16}"/>
+                <a16:creationId xmlns:a16="http://schemas.microsoft.com/office/drawing/2014/main" id="{0D915364-D7C8-96A6-15B1-F19934A47D3C}"/>
               </a:ext>
             </a:extLst>
           </p:cNvPr>
@@ -8697,7 +9425,7 @@
           </a:ln>
           <a:extLst>
             <a:ext uri="{C572A759-6A51-4108-AA02-DFA0A04FC94B}">
-              <ma14:wrappingTextBoxFlag xmlns="" xmlns:m="http://schemas.openxmlformats.org/officeDocument/2006/math" xmlns:a14="http://schemas.microsoft.com/office/drawing/2010/main" xmlns:ma14="http://schemas.microsoft.com/office/mac/drawingml/2011/main" val="1"/>
+              <ma14:wrappingTextBoxFlag xmlns:ma14="http://schemas.microsoft.com/office/mac/drawingml/2011/main" xmlns:a14="http://schemas.microsoft.com/office/drawing/2010/main" xmlns:m="http://schemas.openxmlformats.org/officeDocument/2006/math" xmlns="" val="1"/>
             </a:ext>
           </a:extLst>
         </p:spPr>
@@ -8720,7 +9448,7 @@
           <p:cNvPr id="116" name="テキスト ボックス 1">
             <a:extLst>
               <a:ext uri="{FF2B5EF4-FFF2-40B4-BE49-F238E27FC236}">
-                <a16:creationId xmlns:a16="http://schemas.microsoft.com/office/drawing/2014/main" id="{FF6A6F4D-0377-B8C0-99D6-7577D998AFDF}"/>
+                <a16:creationId xmlns:a16="http://schemas.microsoft.com/office/drawing/2014/main" id="{C9B07B58-8B3C-E714-B432-395E2E0BBBB3}"/>
               </a:ext>
             </a:extLst>
           </p:cNvPr>
@@ -8729,8 +9457,8 @@
         </p:nvSpPr>
         <p:spPr>
           <a:xfrm>
-            <a:off x="1599039" y="846314"/>
-            <a:ext cx="4252124" cy="584775"/>
+            <a:off x="1507599" y="846314"/>
+            <a:ext cx="4449293" cy="584775"/>
           </a:xfrm>
           <a:prstGeom prst="rect">
             <a:avLst/>
@@ -8740,7 +9468,7 @@
           </a:ln>
           <a:extLst>
             <a:ext uri="{C572A759-6A51-4108-AA02-DFA0A04FC94B}">
-              <ma14:wrappingTextBoxFlag xmlns="" xmlns:m="http://schemas.openxmlformats.org/officeDocument/2006/math" xmlns:a14="http://schemas.microsoft.com/office/drawing/2010/main" xmlns:ma14="http://schemas.microsoft.com/office/mac/drawingml/2011/main" val="1"/>
+              <ma14:wrappingTextBoxFlag xmlns:ma14="http://schemas.microsoft.com/office/mac/drawingml/2011/main" xmlns:a14="http://schemas.microsoft.com/office/drawing/2010/main" xmlns:m="http://schemas.openxmlformats.org/officeDocument/2006/math" xmlns="" val="1"/>
             </a:ext>
           </a:extLst>
         </p:spPr>
@@ -8760,8 +9488,8 @@
             </a:pPr>
             <a:r>
               <a:rPr dirty="0">
-                <a:latin typeface="Jost Medium" pitchFamily="2" charset="0"/>
-                <a:ea typeface="Jost Medium" pitchFamily="2" charset="0"/>
+                <a:latin typeface="Jost SemiBold" pitchFamily="2" charset="0"/>
+                <a:ea typeface="Jost SemiBold" pitchFamily="2" charset="0"/>
               </a:rPr>
               <a:t>FlexChroma</a:t>
             </a:r>
@@ -8776,8 +9504,8 @@
             </a:r>
             <a:r>
               <a:rPr dirty="0">
-                <a:ea typeface="+mn-ea"/>
-                <a:cs typeface="+mn-cs"/>
+                <a:latin typeface="Jost Medium" pitchFamily="2" charset="0"/>
+                <a:ea typeface="Jost Medium" pitchFamily="2" charset="0"/>
                 <a:sym typeface="Jost-Regular"/>
               </a:rPr>
               <a:t>Tour-Guide</a:t>
@@ -8790,7 +9518,7 @@
           <p:cNvPr id="118" name="テキスト ボックス 17">
             <a:extLst>
               <a:ext uri="{FF2B5EF4-FFF2-40B4-BE49-F238E27FC236}">
-                <a16:creationId xmlns:a16="http://schemas.microsoft.com/office/drawing/2014/main" id="{3C83112A-5E24-4EDC-E84B-7A418B54ADB1}"/>
+                <a16:creationId xmlns:a16="http://schemas.microsoft.com/office/drawing/2014/main" id="{D76CDE77-EFA7-C65B-A6F4-D54B3E2BE198}"/>
               </a:ext>
             </a:extLst>
           </p:cNvPr>
@@ -8810,7 +9538,7 @@
           </a:ln>
           <a:extLst>
             <a:ext uri="{C572A759-6A51-4108-AA02-DFA0A04FC94B}">
-              <ma14:wrappingTextBoxFlag xmlns="" xmlns:m="http://schemas.openxmlformats.org/officeDocument/2006/math" xmlns:a14="http://schemas.microsoft.com/office/drawing/2010/main" xmlns:ma14="http://schemas.microsoft.com/office/mac/drawingml/2011/main" val="1"/>
+              <ma14:wrappingTextBoxFlag xmlns:ma14="http://schemas.microsoft.com/office/mac/drawingml/2011/main" xmlns:a14="http://schemas.microsoft.com/office/drawing/2010/main" xmlns:m="http://schemas.openxmlformats.org/officeDocument/2006/math" xmlns="" val="1"/>
             </a:ext>
           </a:extLst>
         </p:spPr>
@@ -8840,7 +9568,7 @@
           <p:cNvPr id="119" name="テキスト ボックス 18">
             <a:extLst>
               <a:ext uri="{FF2B5EF4-FFF2-40B4-BE49-F238E27FC236}">
-                <a16:creationId xmlns:a16="http://schemas.microsoft.com/office/drawing/2014/main" id="{1139D95F-C700-149F-93CE-3AC5F823FD44}"/>
+                <a16:creationId xmlns:a16="http://schemas.microsoft.com/office/drawing/2014/main" id="{A2E86BDF-BAB6-A60A-CFC3-7DA5945FF47C}"/>
               </a:ext>
             </a:extLst>
           </p:cNvPr>
@@ -8860,7 +9588,7 @@
           </a:ln>
           <a:extLst>
             <a:ext uri="{C572A759-6A51-4108-AA02-DFA0A04FC94B}">
-              <ma14:wrappingTextBoxFlag xmlns="" xmlns:m="http://schemas.openxmlformats.org/officeDocument/2006/math" xmlns:a14="http://schemas.microsoft.com/office/drawing/2010/main" xmlns:ma14="http://schemas.microsoft.com/office/mac/drawingml/2011/main" val="1"/>
+              <ma14:wrappingTextBoxFlag xmlns:ma14="http://schemas.microsoft.com/office/mac/drawingml/2011/main" xmlns:a14="http://schemas.microsoft.com/office/drawing/2010/main" xmlns:m="http://schemas.openxmlformats.org/officeDocument/2006/math" xmlns="" val="1"/>
             </a:ext>
           </a:extLst>
         </p:spPr>
@@ -8879,15 +9607,14 @@
               </a:defRPr>
             </a:pPr>
             <a:r>
-              <a:rPr lang="en-US" altLang="ja-JP" b="0" dirty="0">
-                <a:latin typeface="Jost Medium" pitchFamily="2" charset="0"/>
-                <a:ea typeface="Jost Medium" pitchFamily="2" charset="0"/>
-                <a:sym typeface="Jost-Regular"/>
+              <a:rPr dirty="0">
+                <a:latin typeface="Jost SemiBold" pitchFamily="2" charset="0"/>
+                <a:ea typeface="Jost SemiBold" pitchFamily="2" charset="0"/>
               </a:rPr>
               <a:t>FlexChroma</a:t>
             </a:r>
             <a:r>
-              <a:rPr lang="en-US" altLang="ja-JP" b="0" dirty="0">
+              <a:rPr b="0" dirty="0">
                 <a:latin typeface="+mn-lt"/>
                 <a:ea typeface="+mn-ea"/>
                 <a:cs typeface="+mn-cs"/>
@@ -9160,7 +9887,7 @@
           <p:cNvPr id="121" name="テキスト ボックス 20">
             <a:extLst>
               <a:ext uri="{FF2B5EF4-FFF2-40B4-BE49-F238E27FC236}">
-                <a16:creationId xmlns:a16="http://schemas.microsoft.com/office/drawing/2014/main" id="{C89A22A8-9C63-F6A9-D99B-BE1157857DC3}"/>
+                <a16:creationId xmlns:a16="http://schemas.microsoft.com/office/drawing/2014/main" id="{465F72B9-4CFC-E531-A452-E99357AC764F}"/>
               </a:ext>
             </a:extLst>
           </p:cNvPr>
@@ -9180,7 +9907,7 @@
           </a:ln>
           <a:extLst>
             <a:ext uri="{C572A759-6A51-4108-AA02-DFA0A04FC94B}">
-              <ma14:wrappingTextBoxFlag xmlns="" xmlns:m="http://schemas.openxmlformats.org/officeDocument/2006/math" xmlns:a14="http://schemas.microsoft.com/office/drawing/2010/main" xmlns:ma14="http://schemas.microsoft.com/office/mac/drawingml/2011/main" val="1"/>
+              <ma14:wrappingTextBoxFlag xmlns:ma14="http://schemas.microsoft.com/office/mac/drawingml/2011/main" xmlns:a14="http://schemas.microsoft.com/office/drawing/2010/main" xmlns:m="http://schemas.openxmlformats.org/officeDocument/2006/math" xmlns="" val="1"/>
             </a:ext>
           </a:extLst>
         </p:spPr>
@@ -9210,7 +9937,7 @@
           <p:cNvPr id="122" name="テキスト ボックス 21">
             <a:extLst>
               <a:ext uri="{FF2B5EF4-FFF2-40B4-BE49-F238E27FC236}">
-                <a16:creationId xmlns:a16="http://schemas.microsoft.com/office/drawing/2014/main" id="{1A4D55E4-1CC0-F260-C218-3C5FABD6E41B}"/>
+                <a16:creationId xmlns:a16="http://schemas.microsoft.com/office/drawing/2014/main" id="{3FC309F6-4E88-46EB-B269-CBE23329F449}"/>
               </a:ext>
             </a:extLst>
           </p:cNvPr>
@@ -9230,7 +9957,7 @@
           </a:ln>
           <a:extLst>
             <a:ext uri="{C572A759-6A51-4108-AA02-DFA0A04FC94B}">
-              <ma14:wrappingTextBoxFlag xmlns="" xmlns:m="http://schemas.openxmlformats.org/officeDocument/2006/math" xmlns:a14="http://schemas.microsoft.com/office/drawing/2010/main" xmlns:ma14="http://schemas.microsoft.com/office/mac/drawingml/2011/main" val="1"/>
+              <ma14:wrappingTextBoxFlag xmlns:ma14="http://schemas.microsoft.com/office/mac/drawingml/2011/main" xmlns:a14="http://schemas.microsoft.com/office/drawing/2010/main" xmlns:m="http://schemas.openxmlformats.org/officeDocument/2006/math" xmlns="" val="1"/>
             </a:ext>
           </a:extLst>
         </p:spPr>
@@ -9255,7 +9982,7 @@
           <p:cNvPr id="123" name="テキスト ボックス 24">
             <a:extLst>
               <a:ext uri="{FF2B5EF4-FFF2-40B4-BE49-F238E27FC236}">
-                <a16:creationId xmlns:a16="http://schemas.microsoft.com/office/drawing/2014/main" id="{85F6A698-3F75-1C1C-A794-F2EA27EED6AA}"/>
+                <a16:creationId xmlns:a16="http://schemas.microsoft.com/office/drawing/2014/main" id="{C5CBF040-442E-D025-4970-FEE7EAAB471E}"/>
               </a:ext>
             </a:extLst>
           </p:cNvPr>
@@ -9275,7 +10002,7 @@
           </a:ln>
           <a:extLst>
             <a:ext uri="{C572A759-6A51-4108-AA02-DFA0A04FC94B}">
-              <ma14:wrappingTextBoxFlag xmlns="" xmlns:m="http://schemas.openxmlformats.org/officeDocument/2006/math" xmlns:a14="http://schemas.microsoft.com/office/drawing/2010/main" xmlns:ma14="http://schemas.microsoft.com/office/mac/drawingml/2011/main" val="1"/>
+              <ma14:wrappingTextBoxFlag xmlns:ma14="http://schemas.microsoft.com/office/mac/drawingml/2011/main" xmlns:a14="http://schemas.microsoft.com/office/drawing/2010/main" xmlns:m="http://schemas.openxmlformats.org/officeDocument/2006/math" xmlns="" val="1"/>
             </a:ext>
           </a:extLst>
         </p:spPr>
@@ -9369,7 +10096,7 @@
           <p:cNvPr id="124" name="テキスト ボックス 25">
             <a:extLst>
               <a:ext uri="{FF2B5EF4-FFF2-40B4-BE49-F238E27FC236}">
-                <a16:creationId xmlns:a16="http://schemas.microsoft.com/office/drawing/2014/main" id="{027C453D-F9C9-F551-93DB-DB8E8582E58B}"/>
+                <a16:creationId xmlns:a16="http://schemas.microsoft.com/office/drawing/2014/main" id="{E6C92513-B935-CC95-61F5-EBF7D52377A4}"/>
               </a:ext>
             </a:extLst>
           </p:cNvPr>
@@ -9389,7 +10116,7 @@
           </a:ln>
           <a:extLst>
             <a:ext uri="{C572A759-6A51-4108-AA02-DFA0A04FC94B}">
-              <ma14:wrappingTextBoxFlag xmlns="" xmlns:m="http://schemas.openxmlformats.org/officeDocument/2006/math" xmlns:a14="http://schemas.microsoft.com/office/drawing/2010/main" xmlns:ma14="http://schemas.microsoft.com/office/mac/drawingml/2011/main" val="1"/>
+              <ma14:wrappingTextBoxFlag xmlns:ma14="http://schemas.microsoft.com/office/mac/drawingml/2011/main" xmlns:a14="http://schemas.microsoft.com/office/drawing/2010/main" xmlns:m="http://schemas.openxmlformats.org/officeDocument/2006/math" xmlns="" val="1"/>
             </a:ext>
           </a:extLst>
         </p:spPr>
@@ -9809,7 +10536,7 @@
           <p:cNvPr id="125" name="テキスト ボックス 26">
             <a:extLst>
               <a:ext uri="{FF2B5EF4-FFF2-40B4-BE49-F238E27FC236}">
-                <a16:creationId xmlns:a16="http://schemas.microsoft.com/office/drawing/2014/main" id="{8E8B847F-FA03-A969-8B37-801820A5731E}"/>
+                <a16:creationId xmlns:a16="http://schemas.microsoft.com/office/drawing/2014/main" id="{12FD37F0-7761-8A9A-42B9-E0742C229012}"/>
               </a:ext>
             </a:extLst>
           </p:cNvPr>
@@ -9819,7 +10546,7 @@
         <p:spPr>
           <a:xfrm>
             <a:off x="816562" y="8157903"/>
-            <a:ext cx="5372560" cy="421641"/>
+            <a:ext cx="5372560" cy="369332"/>
           </a:xfrm>
           <a:prstGeom prst="rect">
             <a:avLst/>
@@ -9829,7 +10556,7 @@
           </a:ln>
           <a:extLst>
             <a:ext uri="{C572A759-6A51-4108-AA02-DFA0A04FC94B}">
-              <ma14:wrappingTextBoxFlag xmlns="" xmlns:m="http://schemas.openxmlformats.org/officeDocument/2006/math" xmlns:a14="http://schemas.microsoft.com/office/drawing/2010/main" xmlns:ma14="http://schemas.microsoft.com/office/mac/drawingml/2011/main" val="1"/>
+              <ma14:wrappingTextBoxFlag xmlns:ma14="http://schemas.microsoft.com/office/mac/drawingml/2011/main" xmlns:a14="http://schemas.microsoft.com/office/drawing/2010/main" xmlns:m="http://schemas.openxmlformats.org/officeDocument/2006/math" xmlns="" val="1"/>
             </a:ext>
           </a:extLst>
         </p:spPr>
@@ -9848,7 +10575,99 @@
               </a:defRPr>
             </a:pPr>
             <a:r>
-              <a:t>*Hinweis: Der Begriff „Profil“ steht in FlexChroma für eine Einteilung nach Verwendungszweck, nicht für abweichende Druckeinstellungen.</a:t>
+              <a:rPr dirty="0"/>
+              <a:t>*</a:t>
+            </a:r>
+            <a:r>
+              <a:rPr dirty="0" err="1"/>
+              <a:t>Hinweis</a:t>
+            </a:r>
+            <a:r>
+              <a:rPr dirty="0"/>
+              <a:t>: Der </a:t>
+            </a:r>
+            <a:r>
+              <a:rPr dirty="0" err="1"/>
+              <a:t>Begriff</a:t>
+            </a:r>
+            <a:r>
+              <a:rPr dirty="0"/>
+              <a:t> „</a:t>
+            </a:r>
+            <a:r>
+              <a:rPr dirty="0" err="1"/>
+              <a:t>Profil</a:t>
+            </a:r>
+            <a:r>
+              <a:rPr dirty="0"/>
+              <a:t>“ </a:t>
+            </a:r>
+            <a:r>
+              <a:rPr dirty="0" err="1"/>
+              <a:t>steht</a:t>
+            </a:r>
+            <a:r>
+              <a:rPr dirty="0"/>
+              <a:t> in </a:t>
+            </a:r>
+            <a:r>
+              <a:rPr dirty="0">
+                <a:latin typeface="Jost SemiBold" pitchFamily="2" charset="0"/>
+                <a:ea typeface="Jost SemiBold" pitchFamily="2" charset="0"/>
+              </a:rPr>
+              <a:t>FlexChroma</a:t>
+            </a:r>
+            <a:r>
+              <a:rPr dirty="0"/>
+              <a:t> für </a:t>
+            </a:r>
+            <a:r>
+              <a:rPr dirty="0" err="1"/>
+              <a:t>eine</a:t>
+            </a:r>
+            <a:r>
+              <a:rPr dirty="0"/>
+              <a:t> </a:t>
+            </a:r>
+            <a:r>
+              <a:rPr dirty="0" err="1"/>
+              <a:t>Einteilung</a:t>
+            </a:r>
+            <a:r>
+              <a:rPr dirty="0"/>
+              <a:t> </a:t>
+            </a:r>
+            <a:r>
+              <a:rPr dirty="0" err="1"/>
+              <a:t>nach</a:t>
+            </a:r>
+            <a:r>
+              <a:rPr dirty="0"/>
+              <a:t> </a:t>
+            </a:r>
+            <a:r>
+              <a:rPr dirty="0" err="1"/>
+              <a:t>Verwendungszweck</a:t>
+            </a:r>
+            <a:r>
+              <a:rPr dirty="0"/>
+              <a:t>, nicht für </a:t>
+            </a:r>
+            <a:r>
+              <a:rPr dirty="0" err="1"/>
+              <a:t>abweichende</a:t>
+            </a:r>
+            <a:r>
+              <a:rPr dirty="0"/>
+              <a:t> </a:t>
+            </a:r>
+            <a:r>
+              <a:rPr dirty="0" err="1"/>
+              <a:t>Druckeinstellungen</a:t>
+            </a:r>
+            <a:r>
+              <a:rPr dirty="0"/>
+              <a:t>.</a:t>
             </a:r>
           </a:p>
         </p:txBody>
@@ -9858,7 +10677,7 @@
           <p:cNvPr id="132" name="テキスト ボックス 30">
             <a:extLst>
               <a:ext uri="{FF2B5EF4-FFF2-40B4-BE49-F238E27FC236}">
-                <a16:creationId xmlns:a16="http://schemas.microsoft.com/office/drawing/2014/main" id="{CFED4C0C-94D5-F7FE-7ABA-C963717D818B}"/>
+                <a16:creationId xmlns:a16="http://schemas.microsoft.com/office/drawing/2014/main" id="{82043691-E551-40E7-543E-A06D1DA319DC}"/>
               </a:ext>
             </a:extLst>
           </p:cNvPr>
@@ -9868,7 +10687,7 @@
         <p:spPr>
           <a:xfrm>
             <a:off x="1934144" y="1459500"/>
-            <a:ext cx="3107580" cy="338554"/>
+            <a:ext cx="3072314" cy="338554"/>
           </a:xfrm>
           <a:prstGeom prst="rect">
             <a:avLst/>
@@ -9878,7 +10697,7 @@
           </a:ln>
           <a:extLst>
             <a:ext uri="{C572A759-6A51-4108-AA02-DFA0A04FC94B}">
-              <ma14:wrappingTextBoxFlag xmlns="" xmlns:m="http://schemas.openxmlformats.org/officeDocument/2006/math" xmlns:a14="http://schemas.microsoft.com/office/drawing/2010/main" xmlns:ma14="http://schemas.microsoft.com/office/mac/drawingml/2011/main" val="1"/>
+              <ma14:wrappingTextBoxFlag xmlns:ma14="http://schemas.microsoft.com/office/mac/drawingml/2011/main" xmlns:a14="http://schemas.microsoft.com/office/drawing/2010/main" xmlns:m="http://schemas.openxmlformats.org/officeDocument/2006/math" xmlns="" val="1"/>
             </a:ext>
           </a:extLst>
         </p:spPr>
@@ -9898,8 +10717,8 @@
             </a:r>
             <a:r>
               <a:rPr dirty="0">
-                <a:latin typeface="Jost Medium" pitchFamily="2" charset="0"/>
-                <a:ea typeface="Jost Medium" pitchFamily="2" charset="0"/>
+                <a:latin typeface="Jost SemiBold" pitchFamily="2" charset="0"/>
+                <a:ea typeface="Jost SemiBold" pitchFamily="2" charset="0"/>
               </a:rPr>
               <a:t>FlexChroma</a:t>
             </a:r>
@@ -9908,7 +10727,10 @@
               <a:t> </a:t>
             </a:r>
             <a:r>
-              <a:rPr dirty="0" err="1"/>
+              <a:rPr dirty="0" err="1">
+                <a:latin typeface="Jost" pitchFamily="2" charset="0"/>
+                <a:ea typeface="Jost" pitchFamily="2" charset="0"/>
+              </a:rPr>
               <a:t>Dokumentenarchiv</a:t>
             </a:r>
             <a:r>
@@ -9923,7 +10745,7 @@
           <p:cNvPr id="133" name="テキスト ボックス 33">
             <a:extLst>
               <a:ext uri="{FF2B5EF4-FFF2-40B4-BE49-F238E27FC236}">
-                <a16:creationId xmlns:a16="http://schemas.microsoft.com/office/drawing/2014/main" id="{DD85EE58-2B6C-3D5C-CBB9-40D003BB3BC8}"/>
+                <a16:creationId xmlns:a16="http://schemas.microsoft.com/office/drawing/2014/main" id="{E444E9E8-9BED-83F3-3507-1FD7F7AF7B54}"/>
               </a:ext>
             </a:extLst>
           </p:cNvPr>
@@ -9943,7 +10765,7 @@
           </a:ln>
           <a:extLst>
             <a:ext uri="{C572A759-6A51-4108-AA02-DFA0A04FC94B}">
-              <ma14:wrappingTextBoxFlag xmlns="" xmlns:m="http://schemas.openxmlformats.org/officeDocument/2006/math" xmlns:a14="http://schemas.microsoft.com/office/drawing/2010/main" xmlns:ma14="http://schemas.microsoft.com/office/mac/drawingml/2011/main" val="1"/>
+              <ma14:wrappingTextBoxFlag xmlns:ma14="http://schemas.microsoft.com/office/mac/drawingml/2011/main" xmlns:a14="http://schemas.microsoft.com/office/drawing/2010/main" xmlns:m="http://schemas.openxmlformats.org/officeDocument/2006/math" xmlns="" val="1"/>
             </a:ext>
           </a:extLst>
         </p:spPr>
@@ -9958,6 +10780,7 @@
           </a:lstStyle>
           <a:p>
             <a:r>
+              <a:rPr dirty="0"/>
               <a:t>Ver.1.00  2026.9.1</a:t>
             </a:r>
           </a:p>
@@ -9968,7 +10791,7 @@
           <p:cNvPr id="134" name="FlexChroma-icon3.png" descr="FlexChroma-icon3.png">
             <a:extLst>
               <a:ext uri="{FF2B5EF4-FFF2-40B4-BE49-F238E27FC236}">
-                <a16:creationId xmlns:a16="http://schemas.microsoft.com/office/drawing/2014/main" id="{DAF96A4E-261E-83CF-EEA1-B63B3697F249}"/>
+                <a16:creationId xmlns:a16="http://schemas.microsoft.com/office/drawing/2014/main" id="{C9405ADB-56E4-E4C0-B790-D1B432573D40}"/>
               </a:ext>
             </a:extLst>
           </p:cNvPr>
@@ -9985,7 +10808,7 @@
         </p:blipFill>
         <p:spPr>
           <a:xfrm>
-            <a:off x="1062623" y="950702"/>
+            <a:off x="993972" y="877017"/>
             <a:ext cx="484295" cy="466866"/>
           </a:xfrm>
           <a:prstGeom prst="rect">
@@ -10001,7 +10824,7 @@
           <p:cNvPr id="2" name="図 1">
             <a:extLst>
               <a:ext uri="{FF2B5EF4-FFF2-40B4-BE49-F238E27FC236}">
-                <a16:creationId xmlns:a16="http://schemas.microsoft.com/office/drawing/2014/main" id="{4F3F5446-B5C9-6482-CD2E-BFEB90739B0D}"/>
+                <a16:creationId xmlns:a16="http://schemas.microsoft.com/office/drawing/2014/main" id="{0996FAAE-7061-99CB-76FF-3D4138B86DCB}"/>
               </a:ext>
             </a:extLst>
           </p:cNvPr>
@@ -10046,7 +10869,7 @@
     </p:spTree>
     <p:extLst>
       <p:ext uri="{BB962C8B-B14F-4D97-AF65-F5344CB8AC3E}">
-        <p14:creationId xmlns:p14="http://schemas.microsoft.com/office/powerpoint/2010/main" val="1508769660"/>
+        <p14:creationId xmlns:p14="http://schemas.microsoft.com/office/powerpoint/2010/main" val="879745843"/>
       </p:ext>
     </p:extLst>
   </p:cSld>
@@ -10065,7 +10888,7 @@
         <p:cNvPr id="1" name="">
           <a:extLst>
             <a:ext uri="{FF2B5EF4-FFF2-40B4-BE49-F238E27FC236}">
-              <a16:creationId xmlns:a16="http://schemas.microsoft.com/office/drawing/2014/main" id="{0E363A08-F6DA-C98D-7F81-40E0C00F90AF}"/>
+              <a16:creationId xmlns:a16="http://schemas.microsoft.com/office/drawing/2014/main" id="{9B95C8B7-8474-6382-68B0-B75938FC9E7A}"/>
             </a:ext>
           </a:extLst>
         </p:cNvPr>
@@ -10085,7 +10908,7 @@
           <p:cNvPr id="137" name="正方形/長方形 1">
             <a:extLst>
               <a:ext uri="{FF2B5EF4-FFF2-40B4-BE49-F238E27FC236}">
-                <a16:creationId xmlns:a16="http://schemas.microsoft.com/office/drawing/2014/main" id="{FE41F440-6320-04BB-8D8A-4A93DEF88F88}"/>
+                <a16:creationId xmlns:a16="http://schemas.microsoft.com/office/drawing/2014/main" id="{75B9A09D-F0CD-DF18-B4E1-7C64831AA409}"/>
               </a:ext>
             </a:extLst>
           </p:cNvPr>
@@ -10138,7 +10961,7 @@
           <p:cNvPr id="7" name="フリーフォーム: 図形 6">
             <a:extLst>
               <a:ext uri="{FF2B5EF4-FFF2-40B4-BE49-F238E27FC236}">
-                <a16:creationId xmlns:a16="http://schemas.microsoft.com/office/drawing/2014/main" id="{BEC6A02F-0DFC-E14F-FD82-8A1F0A796629}"/>
+                <a16:creationId xmlns:a16="http://schemas.microsoft.com/office/drawing/2014/main" id="{EB4251B7-B9EC-3E92-8BA4-1D71B8963A29}"/>
               </a:ext>
             </a:extLst>
           </p:cNvPr>
@@ -10153,228 +10976,228 @@
           <a:custGeom>
             <a:avLst/>
             <a:gdLst>
-              <a:gd name="connsiteX0" fmla="*/ 3727576 w 6858001"/>
-              <a:gd name="connsiteY0" fmla="*/ 8661917 h 9144000"/>
-              <a:gd name="connsiteX1" fmla="*/ 3727576 w 6858001"/>
-              <a:gd name="connsiteY1" fmla="*/ 8715918 h 9144000"/>
-              <a:gd name="connsiteX2" fmla="*/ 6319577 w 6858001"/>
-              <a:gd name="connsiteY2" fmla="*/ 8715918 h 9144000"/>
-              <a:gd name="connsiteX3" fmla="*/ 6319577 w 6858001"/>
-              <a:gd name="connsiteY3" fmla="*/ 8661917 h 9144000"/>
-              <a:gd name="connsiteX4" fmla="*/ 547269 w 6858001"/>
-              <a:gd name="connsiteY4" fmla="*/ 8661917 h 9144000"/>
-              <a:gd name="connsiteX5" fmla="*/ 547269 w 6858001"/>
-              <a:gd name="connsiteY5" fmla="*/ 8715918 h 9144000"/>
-              <a:gd name="connsiteX6" fmla="*/ 3139271 w 6858001"/>
-              <a:gd name="connsiteY6" fmla="*/ 8715918 h 9144000"/>
-              <a:gd name="connsiteX7" fmla="*/ 3139271 w 6858001"/>
-              <a:gd name="connsiteY7" fmla="*/ 8661917 h 9144000"/>
-              <a:gd name="connsiteX8" fmla="*/ 661242 w 6858001"/>
-              <a:gd name="connsiteY8" fmla="*/ 2534513 h 9144000"/>
-              <a:gd name="connsiteX9" fmla="*/ 558906 w 6858001"/>
-              <a:gd name="connsiteY9" fmla="*/ 2636849 h 9144000"/>
-              <a:gd name="connsiteX10" fmla="*/ 661242 w 6858001"/>
-              <a:gd name="connsiteY10" fmla="*/ 2739185 h 9144000"/>
-              <a:gd name="connsiteX11" fmla="*/ 763578 w 6858001"/>
-              <a:gd name="connsiteY11" fmla="*/ 2636849 h 9144000"/>
-              <a:gd name="connsiteX12" fmla="*/ 661242 w 6858001"/>
-              <a:gd name="connsiteY12" fmla="*/ 2534513 h 9144000"/>
-              <a:gd name="connsiteX13" fmla="*/ 661242 w 6858001"/>
-              <a:gd name="connsiteY13" fmla="*/ 655549 h 9144000"/>
-              <a:gd name="connsiteX14" fmla="*/ 558906 w 6858001"/>
-              <a:gd name="connsiteY14" fmla="*/ 757885 h 9144000"/>
-              <a:gd name="connsiteX15" fmla="*/ 661242 w 6858001"/>
-              <a:gd name="connsiteY15" fmla="*/ 860221 h 9144000"/>
-              <a:gd name="connsiteX16" fmla="*/ 763578 w 6858001"/>
-              <a:gd name="connsiteY16" fmla="*/ 757885 h 9144000"/>
-              <a:gd name="connsiteX17" fmla="*/ 661242 w 6858001"/>
-              <a:gd name="connsiteY17" fmla="*/ 655549 h 9144000"/>
-              <a:gd name="connsiteX18" fmla="*/ 547268 w 6858001"/>
-              <a:gd name="connsiteY18" fmla="*/ 452468 h 9144000"/>
-              <a:gd name="connsiteX19" fmla="*/ 547268 w 6858001"/>
-              <a:gd name="connsiteY19" fmla="*/ 506469 h 9144000"/>
-              <a:gd name="connsiteX20" fmla="*/ 6303463 w 6858001"/>
-              <a:gd name="connsiteY20" fmla="*/ 506469 h 9144000"/>
-              <a:gd name="connsiteX21" fmla="*/ 6303463 w 6858001"/>
-              <a:gd name="connsiteY21" fmla="*/ 452468 h 9144000"/>
-              <a:gd name="connsiteX22" fmla="*/ 0 w 6858001"/>
-              <a:gd name="connsiteY22" fmla="*/ 0 h 9144000"/>
-              <a:gd name="connsiteX23" fmla="*/ 6858001 w 6858001"/>
-              <a:gd name="connsiteY23" fmla="*/ 0 h 9144000"/>
-              <a:gd name="connsiteX24" fmla="*/ 6858001 w 6858001"/>
-              <a:gd name="connsiteY24" fmla="*/ 9144000 h 9144000"/>
-              <a:gd name="connsiteX25" fmla="*/ 0 w 6858001"/>
-              <a:gd name="connsiteY25" fmla="*/ 9144000 h 9144000"/>
+              <a:gd name="csX0" fmla="*/ 3727019 w 6858001"/>
+              <a:gd name="csY0" fmla="*/ 8661917 h 9144000"/>
+              <a:gd name="csX1" fmla="*/ 3727019 w 6858001"/>
+              <a:gd name="csY1" fmla="*/ 8715918 h 9144000"/>
+              <a:gd name="csX2" fmla="*/ 6319020 w 6858001"/>
+              <a:gd name="csY2" fmla="*/ 8715918 h 9144000"/>
+              <a:gd name="csX3" fmla="*/ 6319020 w 6858001"/>
+              <a:gd name="csY3" fmla="*/ 8661917 h 9144000"/>
+              <a:gd name="csX4" fmla="*/ 546712 w 6858001"/>
+              <a:gd name="csY4" fmla="*/ 8661917 h 9144000"/>
+              <a:gd name="csX5" fmla="*/ 546712 w 6858001"/>
+              <a:gd name="csY5" fmla="*/ 8715918 h 9144000"/>
+              <a:gd name="csX6" fmla="*/ 3138714 w 6858001"/>
+              <a:gd name="csY6" fmla="*/ 8715918 h 9144000"/>
+              <a:gd name="csX7" fmla="*/ 3138714 w 6858001"/>
+              <a:gd name="csY7" fmla="*/ 8661917 h 9144000"/>
+              <a:gd name="csX8" fmla="*/ 660685 w 6858001"/>
+              <a:gd name="csY8" fmla="*/ 2534513 h 9144000"/>
+              <a:gd name="csX9" fmla="*/ 558349 w 6858001"/>
+              <a:gd name="csY9" fmla="*/ 2636849 h 9144000"/>
+              <a:gd name="csX10" fmla="*/ 660685 w 6858001"/>
+              <a:gd name="csY10" fmla="*/ 2739185 h 9144000"/>
+              <a:gd name="csX11" fmla="*/ 763021 w 6858001"/>
+              <a:gd name="csY11" fmla="*/ 2636849 h 9144000"/>
+              <a:gd name="csX12" fmla="*/ 660685 w 6858001"/>
+              <a:gd name="csY12" fmla="*/ 2534513 h 9144000"/>
+              <a:gd name="csX13" fmla="*/ 660685 w 6858001"/>
+              <a:gd name="csY13" fmla="*/ 655549 h 9144000"/>
+              <a:gd name="csX14" fmla="*/ 558349 w 6858001"/>
+              <a:gd name="csY14" fmla="*/ 757885 h 9144000"/>
+              <a:gd name="csX15" fmla="*/ 660685 w 6858001"/>
+              <a:gd name="csY15" fmla="*/ 860221 h 9144000"/>
+              <a:gd name="csX16" fmla="*/ 763021 w 6858001"/>
+              <a:gd name="csY16" fmla="*/ 757885 h 9144000"/>
+              <a:gd name="csX17" fmla="*/ 660685 w 6858001"/>
+              <a:gd name="csY17" fmla="*/ 655549 h 9144000"/>
+              <a:gd name="csX18" fmla="*/ 546711 w 6858001"/>
+              <a:gd name="csY18" fmla="*/ 452468 h 9144000"/>
+              <a:gd name="csX19" fmla="*/ 546711 w 6858001"/>
+              <a:gd name="csY19" fmla="*/ 506469 h 9144000"/>
+              <a:gd name="csX20" fmla="*/ 6302906 w 6858001"/>
+              <a:gd name="csY20" fmla="*/ 506469 h 9144000"/>
+              <a:gd name="csX21" fmla="*/ 6302906 w 6858001"/>
+              <a:gd name="csY21" fmla="*/ 452468 h 9144000"/>
+              <a:gd name="csX22" fmla="*/ 0 w 6858001"/>
+              <a:gd name="csY22" fmla="*/ 0 h 9144000"/>
+              <a:gd name="csX23" fmla="*/ 6858001 w 6858001"/>
+              <a:gd name="csY23" fmla="*/ 0 h 9144000"/>
+              <a:gd name="csX24" fmla="*/ 6858001 w 6858001"/>
+              <a:gd name="csY24" fmla="*/ 9144000 h 9144000"/>
+              <a:gd name="csX25" fmla="*/ 0 w 6858001"/>
+              <a:gd name="csY25" fmla="*/ 9144000 h 9144000"/>
             </a:gdLst>
             <a:ahLst/>
             <a:cxnLst>
               <a:cxn ang="0">
-                <a:pos x="connsiteX0" y="connsiteY0"/>
+                <a:pos x="csX0" y="csY0"/>
               </a:cxn>
               <a:cxn ang="0">
-                <a:pos x="connsiteX1" y="connsiteY1"/>
+                <a:pos x="csX1" y="csY1"/>
               </a:cxn>
               <a:cxn ang="0">
-                <a:pos x="connsiteX2" y="connsiteY2"/>
+                <a:pos x="csX2" y="csY2"/>
               </a:cxn>
               <a:cxn ang="0">
-                <a:pos x="connsiteX3" y="connsiteY3"/>
+                <a:pos x="csX3" y="csY3"/>
               </a:cxn>
               <a:cxn ang="0">
-                <a:pos x="connsiteX4" y="connsiteY4"/>
+                <a:pos x="csX4" y="csY4"/>
               </a:cxn>
               <a:cxn ang="0">
-                <a:pos x="connsiteX5" y="connsiteY5"/>
+                <a:pos x="csX5" y="csY5"/>
               </a:cxn>
               <a:cxn ang="0">
-                <a:pos x="connsiteX6" y="connsiteY6"/>
+                <a:pos x="csX6" y="csY6"/>
               </a:cxn>
               <a:cxn ang="0">
-                <a:pos x="connsiteX7" y="connsiteY7"/>
+                <a:pos x="csX7" y="csY7"/>
               </a:cxn>
               <a:cxn ang="0">
-                <a:pos x="connsiteX8" y="connsiteY8"/>
+                <a:pos x="csX8" y="csY8"/>
               </a:cxn>
               <a:cxn ang="0">
-                <a:pos x="connsiteX9" y="connsiteY9"/>
+                <a:pos x="csX9" y="csY9"/>
               </a:cxn>
               <a:cxn ang="0">
-                <a:pos x="connsiteX10" y="connsiteY10"/>
+                <a:pos x="csX10" y="csY10"/>
               </a:cxn>
               <a:cxn ang="0">
-                <a:pos x="connsiteX11" y="connsiteY11"/>
+                <a:pos x="csX11" y="csY11"/>
               </a:cxn>
               <a:cxn ang="0">
-                <a:pos x="connsiteX12" y="connsiteY12"/>
+                <a:pos x="csX12" y="csY12"/>
               </a:cxn>
               <a:cxn ang="0">
-                <a:pos x="connsiteX13" y="connsiteY13"/>
+                <a:pos x="csX13" y="csY13"/>
               </a:cxn>
               <a:cxn ang="0">
-                <a:pos x="connsiteX14" y="connsiteY14"/>
+                <a:pos x="csX14" y="csY14"/>
               </a:cxn>
               <a:cxn ang="0">
-                <a:pos x="connsiteX15" y="connsiteY15"/>
+                <a:pos x="csX15" y="csY15"/>
               </a:cxn>
               <a:cxn ang="0">
-                <a:pos x="connsiteX16" y="connsiteY16"/>
+                <a:pos x="csX16" y="csY16"/>
               </a:cxn>
               <a:cxn ang="0">
-                <a:pos x="connsiteX17" y="connsiteY17"/>
+                <a:pos x="csX17" y="csY17"/>
               </a:cxn>
               <a:cxn ang="0">
-                <a:pos x="connsiteX18" y="connsiteY18"/>
+                <a:pos x="csX18" y="csY18"/>
               </a:cxn>
               <a:cxn ang="0">
-                <a:pos x="connsiteX19" y="connsiteY19"/>
+                <a:pos x="csX19" y="csY19"/>
               </a:cxn>
               <a:cxn ang="0">
-                <a:pos x="connsiteX20" y="connsiteY20"/>
+                <a:pos x="csX20" y="csY20"/>
               </a:cxn>
               <a:cxn ang="0">
-                <a:pos x="connsiteX21" y="connsiteY21"/>
+                <a:pos x="csX21" y="csY21"/>
               </a:cxn>
               <a:cxn ang="0">
-                <a:pos x="connsiteX22" y="connsiteY22"/>
+                <a:pos x="csX22" y="csY22"/>
               </a:cxn>
               <a:cxn ang="0">
-                <a:pos x="connsiteX23" y="connsiteY23"/>
+                <a:pos x="csX23" y="csY23"/>
               </a:cxn>
               <a:cxn ang="0">
-                <a:pos x="connsiteX24" y="connsiteY24"/>
+                <a:pos x="csX24" y="csY24"/>
               </a:cxn>
               <a:cxn ang="0">
-                <a:pos x="connsiteX25" y="connsiteY25"/>
+                <a:pos x="csX25" y="csY25"/>
               </a:cxn>
             </a:cxnLst>
             <a:rect l="l" t="t" r="r" b="b"/>
             <a:pathLst>
               <a:path w="6858001" h="9144000">
                 <a:moveTo>
-                  <a:pt x="3727576" y="8661917"/>
+                  <a:pt x="3727019" y="8661917"/>
                 </a:moveTo>
                 <a:lnTo>
-                  <a:pt x="3727576" y="8715918"/>
+                  <a:pt x="3727019" y="8715918"/>
                 </a:lnTo>
                 <a:lnTo>
-                  <a:pt x="6319577" y="8715918"/>
+                  <a:pt x="6319020" y="8715918"/>
                 </a:lnTo>
                 <a:lnTo>
-                  <a:pt x="6319577" y="8661917"/>
+                  <a:pt x="6319020" y="8661917"/>
                 </a:lnTo>
                 <a:close/>
                 <a:moveTo>
-                  <a:pt x="547269" y="8661917"/>
+                  <a:pt x="546712" y="8661917"/>
                 </a:moveTo>
                 <a:lnTo>
-                  <a:pt x="547269" y="8715918"/>
+                  <a:pt x="546712" y="8715918"/>
                 </a:lnTo>
                 <a:lnTo>
-                  <a:pt x="3139271" y="8715918"/>
+                  <a:pt x="3138714" y="8715918"/>
                 </a:lnTo>
                 <a:lnTo>
-                  <a:pt x="3139271" y="8661917"/>
+                  <a:pt x="3138714" y="8661917"/>
                 </a:lnTo>
                 <a:close/>
                 <a:moveTo>
-                  <a:pt x="661242" y="2534513"/>
+                  <a:pt x="660685" y="2534513"/>
                 </a:moveTo>
                 <a:cubicBezTo>
-                  <a:pt x="604723" y="2534513"/>
-                  <a:pt x="558906" y="2580330"/>
-                  <a:pt x="558906" y="2636849"/>
+                  <a:pt x="604166" y="2534513"/>
+                  <a:pt x="558349" y="2580330"/>
+                  <a:pt x="558349" y="2636849"/>
                 </a:cubicBezTo>
                 <a:cubicBezTo>
-                  <a:pt x="558906" y="2693368"/>
-                  <a:pt x="604723" y="2739185"/>
-                  <a:pt x="661242" y="2739185"/>
+                  <a:pt x="558349" y="2693368"/>
+                  <a:pt x="604166" y="2739185"/>
+                  <a:pt x="660685" y="2739185"/>
                 </a:cubicBezTo>
                 <a:cubicBezTo>
-                  <a:pt x="717761" y="2739185"/>
-                  <a:pt x="763578" y="2693368"/>
-                  <a:pt x="763578" y="2636849"/>
+                  <a:pt x="717204" y="2739185"/>
+                  <a:pt x="763021" y="2693368"/>
+                  <a:pt x="763021" y="2636849"/>
                 </a:cubicBezTo>
                 <a:cubicBezTo>
-                  <a:pt x="763578" y="2580330"/>
-                  <a:pt x="717761" y="2534513"/>
-                  <a:pt x="661242" y="2534513"/>
+                  <a:pt x="763021" y="2580330"/>
+                  <a:pt x="717204" y="2534513"/>
+                  <a:pt x="660685" y="2534513"/>
                 </a:cubicBezTo>
                 <a:close/>
                 <a:moveTo>
-                  <a:pt x="661242" y="655549"/>
+                  <a:pt x="660685" y="655549"/>
                 </a:moveTo>
                 <a:cubicBezTo>
-                  <a:pt x="604723" y="655549"/>
-                  <a:pt x="558906" y="701366"/>
-                  <a:pt x="558906" y="757885"/>
+                  <a:pt x="604166" y="655549"/>
+                  <a:pt x="558349" y="701366"/>
+                  <a:pt x="558349" y="757885"/>
                 </a:cubicBezTo>
                 <a:cubicBezTo>
-                  <a:pt x="558906" y="814404"/>
-                  <a:pt x="604723" y="860221"/>
-                  <a:pt x="661242" y="860221"/>
+                  <a:pt x="558349" y="814404"/>
+                  <a:pt x="604166" y="860221"/>
+                  <a:pt x="660685" y="860221"/>
                 </a:cubicBezTo>
                 <a:cubicBezTo>
-                  <a:pt x="717761" y="860221"/>
-                  <a:pt x="763578" y="814404"/>
-                  <a:pt x="763578" y="757885"/>
+                  <a:pt x="717204" y="860221"/>
+                  <a:pt x="763021" y="814404"/>
+                  <a:pt x="763021" y="757885"/>
                 </a:cubicBezTo>
                 <a:cubicBezTo>
-                  <a:pt x="763578" y="701366"/>
-                  <a:pt x="717761" y="655549"/>
-                  <a:pt x="661242" y="655549"/>
+                  <a:pt x="763021" y="701366"/>
+                  <a:pt x="717204" y="655549"/>
+                  <a:pt x="660685" y="655549"/>
                 </a:cubicBezTo>
                 <a:close/>
                 <a:moveTo>
-                  <a:pt x="547268" y="452468"/>
+                  <a:pt x="546711" y="452468"/>
                 </a:moveTo>
                 <a:lnTo>
-                  <a:pt x="547268" y="506469"/>
+                  <a:pt x="546711" y="506469"/>
                 </a:lnTo>
                 <a:lnTo>
-                  <a:pt x="6303463" y="506469"/>
+                  <a:pt x="6302906" y="506469"/>
                 </a:lnTo>
                 <a:lnTo>
-                  <a:pt x="6303463" y="452468"/>
+                  <a:pt x="6302906" y="452468"/>
                 </a:lnTo>
                 <a:close/>
                 <a:moveTo>
@@ -10422,7 +11245,7 @@
           <p:cNvPr id="147" name="テキスト ボックス 16">
             <a:extLst>
               <a:ext uri="{FF2B5EF4-FFF2-40B4-BE49-F238E27FC236}">
-                <a16:creationId xmlns:a16="http://schemas.microsoft.com/office/drawing/2014/main" id="{9C00153E-3BF6-ACC4-5308-E6AF5A49BF2F}"/>
+                <a16:creationId xmlns:a16="http://schemas.microsoft.com/office/drawing/2014/main" id="{784ABDA9-F1B4-3A6D-A196-61383CAEDF23}"/>
               </a:ext>
             </a:extLst>
           </p:cNvPr>
@@ -10442,7 +11265,7 @@
           </a:ln>
           <a:extLst>
             <a:ext uri="{C572A759-6A51-4108-AA02-DFA0A04FC94B}">
-              <ma14:wrappingTextBoxFlag xmlns="" xmlns:m="http://schemas.openxmlformats.org/officeDocument/2006/math" xmlns:a14="http://schemas.microsoft.com/office/drawing/2010/main" xmlns:ma14="http://schemas.microsoft.com/office/mac/drawingml/2011/main" val="1"/>
+              <ma14:wrappingTextBoxFlag xmlns:ma14="http://schemas.microsoft.com/office/mac/drawingml/2011/main" xmlns:a14="http://schemas.microsoft.com/office/drawing/2010/main" xmlns:m="http://schemas.openxmlformats.org/officeDocument/2006/math" xmlns="" val="1"/>
             </a:ext>
           </a:extLst>
         </p:spPr>
@@ -10465,7 +11288,7 @@
           <p:cNvPr id="150" name="テキスト ボックス 2">
             <a:extLst>
               <a:ext uri="{FF2B5EF4-FFF2-40B4-BE49-F238E27FC236}">
-                <a16:creationId xmlns:a16="http://schemas.microsoft.com/office/drawing/2014/main" id="{A354347C-BCC8-1E90-02B4-070AE102021D}"/>
+                <a16:creationId xmlns:a16="http://schemas.microsoft.com/office/drawing/2014/main" id="{92F6294C-72F6-6C9C-08F8-682DE857AADB}"/>
               </a:ext>
             </a:extLst>
           </p:cNvPr>
@@ -10485,7 +11308,7 @@
           </a:ln>
           <a:extLst>
             <a:ext uri="{C572A759-6A51-4108-AA02-DFA0A04FC94B}">
-              <ma14:wrappingTextBoxFlag xmlns="" xmlns:m="http://schemas.openxmlformats.org/officeDocument/2006/math" xmlns:a14="http://schemas.microsoft.com/office/drawing/2010/main" xmlns:ma14="http://schemas.microsoft.com/office/mac/drawingml/2011/main" val="1"/>
+              <ma14:wrappingTextBoxFlag xmlns:ma14="http://schemas.microsoft.com/office/mac/drawingml/2011/main" xmlns:a14="http://schemas.microsoft.com/office/drawing/2010/main" xmlns:m="http://schemas.openxmlformats.org/officeDocument/2006/math" xmlns="" val="1"/>
             </a:ext>
           </a:extLst>
         </p:spPr>
@@ -10516,7 +11339,7 @@
           <p:cNvPr id="151" name="テキスト ボックス 10">
             <a:extLst>
               <a:ext uri="{FF2B5EF4-FFF2-40B4-BE49-F238E27FC236}">
-                <a16:creationId xmlns:a16="http://schemas.microsoft.com/office/drawing/2014/main" id="{97AAD561-B768-F02F-DFBC-0C864E489FA7}"/>
+                <a16:creationId xmlns:a16="http://schemas.microsoft.com/office/drawing/2014/main" id="{99B88456-7497-76A0-F46B-B3B4CCEF5598}"/>
               </a:ext>
             </a:extLst>
           </p:cNvPr>
@@ -10536,7 +11359,7 @@
           </a:ln>
           <a:extLst>
             <a:ext uri="{C572A759-6A51-4108-AA02-DFA0A04FC94B}">
-              <ma14:wrappingTextBoxFlag xmlns="" xmlns:m="http://schemas.openxmlformats.org/officeDocument/2006/math" xmlns:a14="http://schemas.microsoft.com/office/drawing/2010/main" xmlns:ma14="http://schemas.microsoft.com/office/mac/drawingml/2011/main" val="1"/>
+              <ma14:wrappingTextBoxFlag xmlns:ma14="http://schemas.microsoft.com/office/mac/drawingml/2011/main" xmlns:a14="http://schemas.microsoft.com/office/drawing/2010/main" xmlns:m="http://schemas.openxmlformats.org/officeDocument/2006/math" xmlns="" val="1"/>
             </a:ext>
           </a:extLst>
         </p:spPr>
@@ -10555,8 +11378,8 @@
             </a:r>
             <a:r>
               <a:rPr dirty="0">
-                <a:latin typeface="Jost Medium" pitchFamily="2" charset="0"/>
-                <a:ea typeface="Jost Medium" pitchFamily="2" charset="0"/>
+                <a:latin typeface="Jost SemiBold" pitchFamily="2" charset="0"/>
+                <a:ea typeface="Jost SemiBold" pitchFamily="2" charset="0"/>
               </a:rPr>
               <a:t>FlexChroma</a:t>
             </a:r>
@@ -10805,7 +11628,7 @@
           <p:cNvPr id="152" name="テキスト ボックス 11">
             <a:extLst>
               <a:ext uri="{FF2B5EF4-FFF2-40B4-BE49-F238E27FC236}">
-                <a16:creationId xmlns:a16="http://schemas.microsoft.com/office/drawing/2014/main" id="{BB2A2762-36EA-D126-7AEA-66FD3A54D01F}"/>
+                <a16:creationId xmlns:a16="http://schemas.microsoft.com/office/drawing/2014/main" id="{FC983AA2-A123-525C-3402-6C17EE284E0B}"/>
               </a:ext>
             </a:extLst>
           </p:cNvPr>
@@ -10825,7 +11648,7 @@
           </a:ln>
           <a:extLst>
             <a:ext uri="{C572A759-6A51-4108-AA02-DFA0A04FC94B}">
-              <ma14:wrappingTextBoxFlag xmlns="" xmlns:m="http://schemas.openxmlformats.org/officeDocument/2006/math" xmlns:a14="http://schemas.microsoft.com/office/drawing/2010/main" xmlns:ma14="http://schemas.microsoft.com/office/mac/drawingml/2011/main" val="1"/>
+              <ma14:wrappingTextBoxFlag xmlns:ma14="http://schemas.microsoft.com/office/mac/drawingml/2011/main" xmlns:a14="http://schemas.microsoft.com/office/drawing/2010/main" xmlns:m="http://schemas.openxmlformats.org/officeDocument/2006/math" xmlns="" val="1"/>
             </a:ext>
           </a:extLst>
         </p:spPr>
@@ -10855,7 +11678,7 @@
           <p:cNvPr id="153" name="テキスト ボックス 22">
             <a:extLst>
               <a:ext uri="{FF2B5EF4-FFF2-40B4-BE49-F238E27FC236}">
-                <a16:creationId xmlns:a16="http://schemas.microsoft.com/office/drawing/2014/main" id="{3B69E9F9-BDD8-5DFB-ECBD-91CDAB1FC0C8}"/>
+                <a16:creationId xmlns:a16="http://schemas.microsoft.com/office/drawing/2014/main" id="{4DEDC911-F6D4-7D86-FB0B-008033A6195D}"/>
               </a:ext>
             </a:extLst>
           </p:cNvPr>
@@ -10865,7 +11688,7 @@
         <p:spPr>
           <a:xfrm>
             <a:off x="714228" y="2819223"/>
-            <a:ext cx="5550784" cy="1704341"/>
+            <a:ext cx="5550784" cy="1400383"/>
           </a:xfrm>
           <a:prstGeom prst="rect">
             <a:avLst/>
@@ -10875,7 +11698,7 @@
           </a:ln>
           <a:extLst>
             <a:ext uri="{C572A759-6A51-4108-AA02-DFA0A04FC94B}">
-              <ma14:wrappingTextBoxFlag xmlns="" xmlns:m="http://schemas.openxmlformats.org/officeDocument/2006/math" xmlns:a14="http://schemas.microsoft.com/office/drawing/2010/main" xmlns:ma14="http://schemas.microsoft.com/office/mac/drawingml/2011/main" val="1"/>
+              <ma14:wrappingTextBoxFlag xmlns:ma14="http://schemas.microsoft.com/office/mac/drawingml/2011/main" xmlns:a14="http://schemas.microsoft.com/office/drawing/2010/main" xmlns:m="http://schemas.openxmlformats.org/officeDocument/2006/math" xmlns="" val="1"/>
             </a:ext>
           </a:extLst>
         </p:spPr>
@@ -10889,7 +11712,155 @@
               <a:defRPr sz="1000"/>
             </a:pPr>
             <a:r>
-              <a:t>Die Mischfilament Serie bildet das grundlegendste Sortiment von FlexChroma. Sie ermöglicht es Ihnen, zwei Filamente in verschiedenen Verhältnissen zu mischen, um Ihre eigene individuelle Farbe zu kreieren. </a:t>
+              <a:rPr dirty="0"/>
+              <a:t>Die </a:t>
+            </a:r>
+            <a:r>
+              <a:rPr dirty="0" err="1"/>
+              <a:t>Mischfilament</a:t>
+            </a:r>
+            <a:r>
+              <a:rPr dirty="0"/>
+              <a:t> Serie </a:t>
+            </a:r>
+            <a:r>
+              <a:rPr dirty="0" err="1"/>
+              <a:t>bildet</a:t>
+            </a:r>
+            <a:r>
+              <a:rPr dirty="0"/>
+              <a:t> das </a:t>
+            </a:r>
+            <a:r>
+              <a:rPr dirty="0" err="1"/>
+              <a:t>grundlegendste</a:t>
+            </a:r>
+            <a:r>
+              <a:rPr dirty="0"/>
+              <a:t> </a:t>
+            </a:r>
+            <a:r>
+              <a:rPr dirty="0" err="1"/>
+              <a:t>Sortiment</a:t>
+            </a:r>
+            <a:r>
+              <a:rPr dirty="0"/>
+              <a:t> von </a:t>
+            </a:r>
+            <a:r>
+              <a:rPr dirty="0">
+                <a:latin typeface="Jost SemiBold" pitchFamily="2" charset="0"/>
+                <a:ea typeface="Jost SemiBold" pitchFamily="2" charset="0"/>
+              </a:rPr>
+              <a:t>FlexChroma</a:t>
+            </a:r>
+            <a:r>
+              <a:rPr dirty="0"/>
+              <a:t>. Sie </a:t>
+            </a:r>
+            <a:r>
+              <a:rPr dirty="0" err="1"/>
+              <a:t>ermöglicht</a:t>
+            </a:r>
+            <a:r>
+              <a:rPr dirty="0"/>
+              <a:t> es Ihnen, </a:t>
+            </a:r>
+            <a:r>
+              <a:rPr dirty="0" err="1"/>
+              <a:t>zwei</a:t>
+            </a:r>
+            <a:r>
+              <a:rPr dirty="0"/>
+              <a:t> </a:t>
+            </a:r>
+            <a:r>
+              <a:rPr dirty="0" err="1"/>
+              <a:t>Filamente</a:t>
+            </a:r>
+            <a:r>
+              <a:rPr dirty="0"/>
+              <a:t> in </a:t>
+            </a:r>
+            <a:r>
+              <a:rPr dirty="0" err="1"/>
+              <a:t>verschiedenen</a:t>
+            </a:r>
+            <a:r>
+              <a:rPr dirty="0"/>
+              <a:t> </a:t>
+            </a:r>
+            <a:r>
+              <a:rPr dirty="0" err="1"/>
+              <a:t>Verhältnissen</a:t>
+            </a:r>
+            <a:r>
+              <a:rPr dirty="0"/>
+              <a:t> </a:t>
+            </a:r>
+            <a:r>
+              <a:rPr dirty="0" err="1"/>
+              <a:t>zu</a:t>
+            </a:r>
+            <a:r>
+              <a:rPr dirty="0"/>
+              <a:t> </a:t>
+            </a:r>
+            <a:r>
+              <a:rPr dirty="0" err="1"/>
+              <a:t>mischen</a:t>
+            </a:r>
+            <a:r>
+              <a:rPr dirty="0"/>
+              <a:t>, um </a:t>
+            </a:r>
+            <a:r>
+              <a:rPr dirty="0" err="1"/>
+              <a:t>Ihre</a:t>
+            </a:r>
+            <a:r>
+              <a:rPr dirty="0"/>
+              <a:t> </a:t>
+            </a:r>
+            <a:r>
+              <a:rPr dirty="0" err="1"/>
+              <a:t>eigene</a:t>
+            </a:r>
+            <a:r>
+              <a:rPr dirty="0"/>
+              <a:t> </a:t>
+            </a:r>
+            <a:r>
+              <a:rPr dirty="0" err="1"/>
+              <a:t>individuelle</a:t>
+            </a:r>
+            <a:r>
+              <a:rPr dirty="0"/>
+              <a:t> </a:t>
+            </a:r>
+            <a:r>
+              <a:rPr dirty="0" err="1"/>
+              <a:t>Farbe</a:t>
+            </a:r>
+            <a:r>
+              <a:rPr dirty="0"/>
+              <a:t> </a:t>
+            </a:r>
+            <a:r>
+              <a:rPr dirty="0" err="1"/>
+              <a:t>zu</a:t>
+            </a:r>
+            <a:r>
+              <a:rPr dirty="0"/>
+              <a:t> </a:t>
+            </a:r>
+            <a:r>
+              <a:rPr dirty="0" err="1"/>
+              <a:t>kreieren</a:t>
+            </a:r>
+            <a:r>
+              <a:rPr dirty="0"/>
+              <a:t>. </a:t>
             </a:r>
           </a:p>
           <a:p>
@@ -10902,8 +11873,74 @@
               </a:defRPr>
             </a:pPr>
             <a:r>
-              <a:t>Jedes Modell deckt dabei Mischungsverhältnisse von 50 % bis 99,5 % ab. Für Werte unter 50 % tauschen Sie einfach Filament A und Filament B aus.</a:t>
-            </a:r>
+              <a:rPr dirty="0" err="1"/>
+              <a:t>Jedes</a:t>
+            </a:r>
+            <a:r>
+              <a:rPr dirty="0"/>
+              <a:t> Modell </a:t>
+            </a:r>
+            <a:r>
+              <a:rPr dirty="0" err="1"/>
+              <a:t>deckt</a:t>
+            </a:r>
+            <a:r>
+              <a:rPr dirty="0"/>
+              <a:t> </a:t>
+            </a:r>
+            <a:r>
+              <a:rPr dirty="0" err="1"/>
+              <a:t>dabei</a:t>
+            </a:r>
+            <a:r>
+              <a:rPr dirty="0"/>
+              <a:t> </a:t>
+            </a:r>
+            <a:r>
+              <a:rPr dirty="0" err="1"/>
+              <a:t>Mischungsverhältnisse</a:t>
+            </a:r>
+            <a:r>
+              <a:rPr dirty="0"/>
+              <a:t> von 50 % bis 99,5 % ab. Für </a:t>
+            </a:r>
+            <a:r>
+              <a:rPr dirty="0" err="1"/>
+              <a:t>Werte</a:t>
+            </a:r>
+            <a:r>
+              <a:rPr dirty="0"/>
+              <a:t> </a:t>
+            </a:r>
+            <a:r>
+              <a:rPr dirty="0" err="1"/>
+              <a:t>unter</a:t>
+            </a:r>
+            <a:r>
+              <a:rPr dirty="0"/>
+              <a:t> 50 % </a:t>
+            </a:r>
+            <a:r>
+              <a:rPr dirty="0" err="1"/>
+              <a:t>tauschen</a:t>
+            </a:r>
+            <a:r>
+              <a:rPr dirty="0"/>
+              <a:t> Sie </a:t>
+            </a:r>
+            <a:r>
+              <a:rPr dirty="0" err="1"/>
+              <a:t>einfach</a:t>
+            </a:r>
+            <a:r>
+              <a:rPr dirty="0"/>
+              <a:t> Filament A und Filament B </a:t>
+            </a:r>
+            <a:r>
+              <a:rPr dirty="0" err="1"/>
+              <a:t>aus.</a:t>
+            </a:r>
+            <a:endParaRPr dirty="0"/>
           </a:p>
           <a:p>
             <a:pPr>
@@ -10914,14 +11951,131 @@
                 <a:sym typeface="JostRoman-Bold"/>
               </a:defRPr>
             </a:pPr>
-            <a:endParaRPr/>
+            <a:endParaRPr dirty="0"/>
           </a:p>
           <a:p>
             <a:pPr>
               <a:defRPr sz="1000"/>
             </a:pPr>
             <a:r>
-              <a:t>Beispiel: Um ein Filament mit 25 % Cyan gemischt in Gelb zu erstellen, lesen Sie den Wert der Druckplatte als Verhältnis von Filament A ab, interpretieren diesen als 75 % Gelb und slicen das Modell entsprechend.</a:t>
+              <a:rPr dirty="0" err="1"/>
+              <a:t>Beispiel</a:t>
+            </a:r>
+            <a:r>
+              <a:rPr dirty="0"/>
+              <a:t>: Um </a:t>
+            </a:r>
+            <a:r>
+              <a:rPr dirty="0" err="1"/>
+              <a:t>ein</a:t>
+            </a:r>
+            <a:r>
+              <a:rPr dirty="0"/>
+              <a:t> Filament </a:t>
+            </a:r>
+            <a:r>
+              <a:rPr dirty="0" err="1"/>
+              <a:t>mit</a:t>
+            </a:r>
+            <a:r>
+              <a:rPr dirty="0"/>
+              <a:t> 25 % Cyan </a:t>
+            </a:r>
+            <a:r>
+              <a:rPr dirty="0" err="1"/>
+              <a:t>gemischt</a:t>
+            </a:r>
+            <a:r>
+              <a:rPr dirty="0"/>
+              <a:t> in Gelb </a:t>
+            </a:r>
+            <a:r>
+              <a:rPr dirty="0" err="1"/>
+              <a:t>zu</a:t>
+            </a:r>
+            <a:r>
+              <a:rPr dirty="0"/>
+              <a:t> </a:t>
+            </a:r>
+            <a:r>
+              <a:rPr dirty="0" err="1"/>
+              <a:t>erstellen</a:t>
+            </a:r>
+            <a:r>
+              <a:rPr dirty="0"/>
+              <a:t>, </a:t>
+            </a:r>
+            <a:r>
+              <a:rPr dirty="0" err="1"/>
+              <a:t>lesen</a:t>
+            </a:r>
+            <a:r>
+              <a:rPr dirty="0"/>
+              <a:t> Sie den Wert der </a:t>
+            </a:r>
+            <a:r>
+              <a:rPr dirty="0" err="1"/>
+              <a:t>Druckplatte</a:t>
+            </a:r>
+            <a:r>
+              <a:rPr dirty="0"/>
+              <a:t> </a:t>
+            </a:r>
+            <a:r>
+              <a:rPr dirty="0" err="1"/>
+              <a:t>als</a:t>
+            </a:r>
+            <a:r>
+              <a:rPr dirty="0"/>
+              <a:t> </a:t>
+            </a:r>
+            <a:r>
+              <a:rPr dirty="0" err="1"/>
+              <a:t>Verhältnis</a:t>
+            </a:r>
+            <a:r>
+              <a:rPr dirty="0"/>
+              <a:t> von Filament A ab, </a:t>
+            </a:r>
+            <a:r>
+              <a:rPr dirty="0" err="1"/>
+              <a:t>interpretieren</a:t>
+            </a:r>
+            <a:r>
+              <a:rPr dirty="0"/>
+              <a:t> </a:t>
+            </a:r>
+            <a:r>
+              <a:rPr dirty="0" err="1"/>
+              <a:t>diesen</a:t>
+            </a:r>
+            <a:r>
+              <a:rPr dirty="0"/>
+              <a:t> </a:t>
+            </a:r>
+            <a:r>
+              <a:rPr dirty="0" err="1"/>
+              <a:t>als</a:t>
+            </a:r>
+            <a:r>
+              <a:rPr dirty="0"/>
+              <a:t> 75 % Gelb und </a:t>
+            </a:r>
+            <a:r>
+              <a:rPr dirty="0" err="1"/>
+              <a:t>slicen</a:t>
+            </a:r>
+            <a:r>
+              <a:rPr dirty="0"/>
+              <a:t> das Modell </a:t>
+            </a:r>
+            <a:r>
+              <a:rPr dirty="0" err="1"/>
+              <a:t>entsprechend</a:t>
+            </a:r>
+            <a:r>
+              <a:rPr dirty="0"/>
+              <a:t>.</a:t>
             </a:r>
           </a:p>
         </p:txBody>
@@ -10931,7 +12085,7 @@
           <p:cNvPr id="154" name="テキスト ボックス 23">
             <a:extLst>
               <a:ext uri="{FF2B5EF4-FFF2-40B4-BE49-F238E27FC236}">
-                <a16:creationId xmlns:a16="http://schemas.microsoft.com/office/drawing/2014/main" id="{172C0EF1-2B71-0731-E3AF-2BB40F7C9795}"/>
+                <a16:creationId xmlns:a16="http://schemas.microsoft.com/office/drawing/2014/main" id="{1D3CE8A8-32C8-466B-03DA-E93BBBE737F8}"/>
               </a:ext>
             </a:extLst>
           </p:cNvPr>
@@ -10940,7 +12094,7 @@
         </p:nvSpPr>
         <p:spPr>
           <a:xfrm>
-            <a:off x="717862" y="5373022"/>
+            <a:off x="717862" y="5392072"/>
             <a:ext cx="5550783" cy="281941"/>
           </a:xfrm>
           <a:prstGeom prst="rect">
@@ -10951,7 +12105,7 @@
           </a:ln>
           <a:extLst>
             <a:ext uri="{C572A759-6A51-4108-AA02-DFA0A04FC94B}">
-              <ma14:wrappingTextBoxFlag xmlns="" xmlns:m="http://schemas.openxmlformats.org/officeDocument/2006/math" xmlns:a14="http://schemas.microsoft.com/office/drawing/2010/main" xmlns:ma14="http://schemas.microsoft.com/office/mac/drawingml/2011/main" val="1"/>
+              <ma14:wrappingTextBoxFlag xmlns:ma14="http://schemas.microsoft.com/office/mac/drawingml/2011/main" xmlns:a14="http://schemas.microsoft.com/office/drawing/2010/main" xmlns:m="http://schemas.openxmlformats.org/officeDocument/2006/math" xmlns="" val="1"/>
             </a:ext>
           </a:extLst>
         </p:spPr>
@@ -10976,7 +12130,7 @@
           <p:cNvPr id="155" name="図 21" descr="図 21">
             <a:extLst>
               <a:ext uri="{FF2B5EF4-FFF2-40B4-BE49-F238E27FC236}">
-                <a16:creationId xmlns:a16="http://schemas.microsoft.com/office/drawing/2014/main" id="{648A668E-8B8F-EAEE-9D4E-D6FDF7EB215F}"/>
+                <a16:creationId xmlns:a16="http://schemas.microsoft.com/office/drawing/2014/main" id="{FCF3C4FC-2999-D6A1-FA94-F559C6655AB7}"/>
               </a:ext>
             </a:extLst>
           </p:cNvPr>
@@ -10993,7 +12147,7 @@
         </p:blipFill>
         <p:spPr>
           <a:xfrm>
-            <a:off x="1224630" y="5640758"/>
+            <a:off x="1224630" y="5663618"/>
             <a:ext cx="4408740" cy="2901785"/>
           </a:xfrm>
           <a:prstGeom prst="rect">
@@ -11009,7 +12163,7 @@
           <p:cNvPr id="156" name="ペーストされたムービー.png" descr="ペーストされたムービー.png">
             <a:extLst>
               <a:ext uri="{FF2B5EF4-FFF2-40B4-BE49-F238E27FC236}">
-                <a16:creationId xmlns:a16="http://schemas.microsoft.com/office/drawing/2014/main" id="{0B6AF062-4E92-582C-A0E2-26B5152489CE}"/>
+                <a16:creationId xmlns:a16="http://schemas.microsoft.com/office/drawing/2014/main" id="{72172A1C-8B13-2EEA-1971-951F089B0203}"/>
               </a:ext>
             </a:extLst>
           </p:cNvPr>
@@ -11042,7 +12196,7 @@
           <p:cNvPr id="5" name="図 4">
             <a:extLst>
               <a:ext uri="{FF2B5EF4-FFF2-40B4-BE49-F238E27FC236}">
-                <a16:creationId xmlns:a16="http://schemas.microsoft.com/office/drawing/2014/main" id="{CA8D5765-0413-AB84-AC5C-DC51DC685415}"/>
+                <a16:creationId xmlns:a16="http://schemas.microsoft.com/office/drawing/2014/main" id="{5EBED3F9-C934-970A-251D-5244A4063EB9}"/>
               </a:ext>
             </a:extLst>
           </p:cNvPr>
@@ -11087,7 +12241,7 @@
     </p:spTree>
     <p:extLst>
       <p:ext uri="{BB962C8B-B14F-4D97-AF65-F5344CB8AC3E}">
-        <p14:creationId xmlns:p14="http://schemas.microsoft.com/office/powerpoint/2010/main" val="3182504864"/>
+        <p14:creationId xmlns:p14="http://schemas.microsoft.com/office/powerpoint/2010/main" val="63210824"/>
       </p:ext>
     </p:extLst>
   </p:cSld>
@@ -11106,7 +12260,7 @@
         <p:cNvPr id="1" name="">
           <a:extLst>
             <a:ext uri="{FF2B5EF4-FFF2-40B4-BE49-F238E27FC236}">
-              <a16:creationId xmlns:a16="http://schemas.microsoft.com/office/drawing/2014/main" id="{69BBB94A-357A-8CC1-6092-5E4642B721AD}"/>
+              <a16:creationId xmlns:a16="http://schemas.microsoft.com/office/drawing/2014/main" id="{F60F7990-FC31-4160-B5BE-33485D4CF68A}"/>
             </a:ext>
           </a:extLst>
         </p:cNvPr>
@@ -11126,7 +12280,7 @@
           <p:cNvPr id="159" name="正方形/長方形 29">
             <a:extLst>
               <a:ext uri="{FF2B5EF4-FFF2-40B4-BE49-F238E27FC236}">
-                <a16:creationId xmlns:a16="http://schemas.microsoft.com/office/drawing/2014/main" id="{9C2D9634-BAD8-E396-FADC-1CD25BD4BC1F}"/>
+                <a16:creationId xmlns:a16="http://schemas.microsoft.com/office/drawing/2014/main" id="{76CBF687-85F7-65A3-42D8-114954417083}"/>
               </a:ext>
             </a:extLst>
           </p:cNvPr>
@@ -11176,10 +12330,10 @@
       </p:sp>
       <p:sp>
         <p:nvSpPr>
-          <p:cNvPr id="6" name="フリーフォーム: 図形 5">
+          <p:cNvPr id="7" name="フリーフォーム: 図形 6">
             <a:extLst>
               <a:ext uri="{FF2B5EF4-FFF2-40B4-BE49-F238E27FC236}">
-                <a16:creationId xmlns:a16="http://schemas.microsoft.com/office/drawing/2014/main" id="{2D9A8B50-FD90-91BE-4FC0-A204DAAEEE2F}"/>
+                <a16:creationId xmlns:a16="http://schemas.microsoft.com/office/drawing/2014/main" id="{D1168AD2-EB7E-AA66-BAE6-FB389058FACC}"/>
               </a:ext>
             </a:extLst>
           </p:cNvPr>
@@ -11188,185 +12342,185 @@
         </p:nvSpPr>
         <p:spPr>
           <a:xfrm>
-            <a:off x="17134" y="0"/>
+            <a:off x="16816" y="-24384"/>
             <a:ext cx="6858001" cy="9144000"/>
           </a:xfrm>
           <a:custGeom>
             <a:avLst/>
             <a:gdLst>
-              <a:gd name="connsiteX0" fmla="*/ 3717710 w 6858001"/>
-              <a:gd name="connsiteY0" fmla="*/ 8661917 h 9144000"/>
-              <a:gd name="connsiteX1" fmla="*/ 3717710 w 6858001"/>
-              <a:gd name="connsiteY1" fmla="*/ 8715918 h 9144000"/>
-              <a:gd name="connsiteX2" fmla="*/ 6309711 w 6858001"/>
-              <a:gd name="connsiteY2" fmla="*/ 8715918 h 9144000"/>
-              <a:gd name="connsiteX3" fmla="*/ 6309711 w 6858001"/>
-              <a:gd name="connsiteY3" fmla="*/ 8661917 h 9144000"/>
-              <a:gd name="connsiteX4" fmla="*/ 537403 w 6858001"/>
-              <a:gd name="connsiteY4" fmla="*/ 8661917 h 9144000"/>
-              <a:gd name="connsiteX5" fmla="*/ 537403 w 6858001"/>
-              <a:gd name="connsiteY5" fmla="*/ 8715918 h 9144000"/>
-              <a:gd name="connsiteX6" fmla="*/ 3129405 w 6858001"/>
-              <a:gd name="connsiteY6" fmla="*/ 8715918 h 9144000"/>
-              <a:gd name="connsiteX7" fmla="*/ 3129405 w 6858001"/>
-              <a:gd name="connsiteY7" fmla="*/ 8661917 h 9144000"/>
-              <a:gd name="connsiteX8" fmla="*/ 651376 w 6858001"/>
-              <a:gd name="connsiteY8" fmla="*/ 677901 h 9144000"/>
-              <a:gd name="connsiteX9" fmla="*/ 549040 w 6858001"/>
-              <a:gd name="connsiteY9" fmla="*/ 780237 h 9144000"/>
-              <a:gd name="connsiteX10" fmla="*/ 651376 w 6858001"/>
-              <a:gd name="connsiteY10" fmla="*/ 882573 h 9144000"/>
-              <a:gd name="connsiteX11" fmla="*/ 753712 w 6858001"/>
-              <a:gd name="connsiteY11" fmla="*/ 780237 h 9144000"/>
-              <a:gd name="connsiteX12" fmla="*/ 651376 w 6858001"/>
-              <a:gd name="connsiteY12" fmla="*/ 677901 h 9144000"/>
-              <a:gd name="connsiteX13" fmla="*/ 537402 w 6858001"/>
-              <a:gd name="connsiteY13" fmla="*/ 452468 h 9144000"/>
-              <a:gd name="connsiteX14" fmla="*/ 537402 w 6858001"/>
-              <a:gd name="connsiteY14" fmla="*/ 506469 h 9144000"/>
-              <a:gd name="connsiteX15" fmla="*/ 6293597 w 6858001"/>
-              <a:gd name="connsiteY15" fmla="*/ 506469 h 9144000"/>
-              <a:gd name="connsiteX16" fmla="*/ 6293597 w 6858001"/>
-              <a:gd name="connsiteY16" fmla="*/ 452468 h 9144000"/>
-              <a:gd name="connsiteX17" fmla="*/ 0 w 6858001"/>
-              <a:gd name="connsiteY17" fmla="*/ 0 h 9144000"/>
-              <a:gd name="connsiteX18" fmla="*/ 6858001 w 6858001"/>
-              <a:gd name="connsiteY18" fmla="*/ 0 h 9144000"/>
-              <a:gd name="connsiteX19" fmla="*/ 6858001 w 6858001"/>
-              <a:gd name="connsiteY19" fmla="*/ 9144000 h 9144000"/>
-              <a:gd name="connsiteX20" fmla="*/ 0 w 6858001"/>
-              <a:gd name="connsiteY20" fmla="*/ 9144000 h 9144000"/>
+              <a:gd name="csX0" fmla="*/ 3718028 w 6858001"/>
+              <a:gd name="csY0" fmla="*/ 8686301 h 9144000"/>
+              <a:gd name="csX1" fmla="*/ 3718028 w 6858001"/>
+              <a:gd name="csY1" fmla="*/ 8740302 h 9144000"/>
+              <a:gd name="csX2" fmla="*/ 6310029 w 6858001"/>
+              <a:gd name="csY2" fmla="*/ 8740302 h 9144000"/>
+              <a:gd name="csX3" fmla="*/ 6310029 w 6858001"/>
+              <a:gd name="csY3" fmla="*/ 8686301 h 9144000"/>
+              <a:gd name="csX4" fmla="*/ 537721 w 6858001"/>
+              <a:gd name="csY4" fmla="*/ 8686301 h 9144000"/>
+              <a:gd name="csX5" fmla="*/ 537721 w 6858001"/>
+              <a:gd name="csY5" fmla="*/ 8740302 h 9144000"/>
+              <a:gd name="csX6" fmla="*/ 3129723 w 6858001"/>
+              <a:gd name="csY6" fmla="*/ 8740302 h 9144000"/>
+              <a:gd name="csX7" fmla="*/ 3129723 w 6858001"/>
+              <a:gd name="csY7" fmla="*/ 8686301 h 9144000"/>
+              <a:gd name="csX8" fmla="*/ 651694 w 6858001"/>
+              <a:gd name="csY8" fmla="*/ 702285 h 9144000"/>
+              <a:gd name="csX9" fmla="*/ 549358 w 6858001"/>
+              <a:gd name="csY9" fmla="*/ 804621 h 9144000"/>
+              <a:gd name="csX10" fmla="*/ 651694 w 6858001"/>
+              <a:gd name="csY10" fmla="*/ 906957 h 9144000"/>
+              <a:gd name="csX11" fmla="*/ 754030 w 6858001"/>
+              <a:gd name="csY11" fmla="*/ 804621 h 9144000"/>
+              <a:gd name="csX12" fmla="*/ 651694 w 6858001"/>
+              <a:gd name="csY12" fmla="*/ 702285 h 9144000"/>
+              <a:gd name="csX13" fmla="*/ 537720 w 6858001"/>
+              <a:gd name="csY13" fmla="*/ 476852 h 9144000"/>
+              <a:gd name="csX14" fmla="*/ 537720 w 6858001"/>
+              <a:gd name="csY14" fmla="*/ 530853 h 9144000"/>
+              <a:gd name="csX15" fmla="*/ 6293915 w 6858001"/>
+              <a:gd name="csY15" fmla="*/ 530853 h 9144000"/>
+              <a:gd name="csX16" fmla="*/ 6293915 w 6858001"/>
+              <a:gd name="csY16" fmla="*/ 476852 h 9144000"/>
+              <a:gd name="csX17" fmla="*/ 0 w 6858001"/>
+              <a:gd name="csY17" fmla="*/ 0 h 9144000"/>
+              <a:gd name="csX18" fmla="*/ 6858001 w 6858001"/>
+              <a:gd name="csY18" fmla="*/ 0 h 9144000"/>
+              <a:gd name="csX19" fmla="*/ 6858001 w 6858001"/>
+              <a:gd name="csY19" fmla="*/ 9144000 h 9144000"/>
+              <a:gd name="csX20" fmla="*/ 0 w 6858001"/>
+              <a:gd name="csY20" fmla="*/ 9144000 h 9144000"/>
             </a:gdLst>
             <a:ahLst/>
             <a:cxnLst>
               <a:cxn ang="0">
-                <a:pos x="connsiteX0" y="connsiteY0"/>
+                <a:pos x="csX0" y="csY0"/>
               </a:cxn>
               <a:cxn ang="0">
-                <a:pos x="connsiteX1" y="connsiteY1"/>
+                <a:pos x="csX1" y="csY1"/>
               </a:cxn>
               <a:cxn ang="0">
-                <a:pos x="connsiteX2" y="connsiteY2"/>
+                <a:pos x="csX2" y="csY2"/>
               </a:cxn>
               <a:cxn ang="0">
-                <a:pos x="connsiteX3" y="connsiteY3"/>
+                <a:pos x="csX3" y="csY3"/>
               </a:cxn>
               <a:cxn ang="0">
-                <a:pos x="connsiteX4" y="connsiteY4"/>
+                <a:pos x="csX4" y="csY4"/>
               </a:cxn>
               <a:cxn ang="0">
-                <a:pos x="connsiteX5" y="connsiteY5"/>
+                <a:pos x="csX5" y="csY5"/>
               </a:cxn>
               <a:cxn ang="0">
-                <a:pos x="connsiteX6" y="connsiteY6"/>
+                <a:pos x="csX6" y="csY6"/>
               </a:cxn>
               <a:cxn ang="0">
-                <a:pos x="connsiteX7" y="connsiteY7"/>
+                <a:pos x="csX7" y="csY7"/>
               </a:cxn>
               <a:cxn ang="0">
-                <a:pos x="connsiteX8" y="connsiteY8"/>
+                <a:pos x="csX8" y="csY8"/>
               </a:cxn>
               <a:cxn ang="0">
-                <a:pos x="connsiteX9" y="connsiteY9"/>
+                <a:pos x="csX9" y="csY9"/>
               </a:cxn>
               <a:cxn ang="0">
-                <a:pos x="connsiteX10" y="connsiteY10"/>
+                <a:pos x="csX10" y="csY10"/>
               </a:cxn>
               <a:cxn ang="0">
-                <a:pos x="connsiteX11" y="connsiteY11"/>
+                <a:pos x="csX11" y="csY11"/>
               </a:cxn>
               <a:cxn ang="0">
-                <a:pos x="connsiteX12" y="connsiteY12"/>
+                <a:pos x="csX12" y="csY12"/>
               </a:cxn>
               <a:cxn ang="0">
-                <a:pos x="connsiteX13" y="connsiteY13"/>
+                <a:pos x="csX13" y="csY13"/>
               </a:cxn>
               <a:cxn ang="0">
-                <a:pos x="connsiteX14" y="connsiteY14"/>
+                <a:pos x="csX14" y="csY14"/>
               </a:cxn>
               <a:cxn ang="0">
-                <a:pos x="connsiteX15" y="connsiteY15"/>
+                <a:pos x="csX15" y="csY15"/>
               </a:cxn>
               <a:cxn ang="0">
-                <a:pos x="connsiteX16" y="connsiteY16"/>
+                <a:pos x="csX16" y="csY16"/>
               </a:cxn>
               <a:cxn ang="0">
-                <a:pos x="connsiteX17" y="connsiteY17"/>
+                <a:pos x="csX17" y="csY17"/>
               </a:cxn>
               <a:cxn ang="0">
-                <a:pos x="connsiteX18" y="connsiteY18"/>
+                <a:pos x="csX18" y="csY18"/>
               </a:cxn>
               <a:cxn ang="0">
-                <a:pos x="connsiteX19" y="connsiteY19"/>
+                <a:pos x="csX19" y="csY19"/>
               </a:cxn>
               <a:cxn ang="0">
-                <a:pos x="connsiteX20" y="connsiteY20"/>
+                <a:pos x="csX20" y="csY20"/>
               </a:cxn>
             </a:cxnLst>
             <a:rect l="l" t="t" r="r" b="b"/>
             <a:pathLst>
               <a:path w="6858001" h="9144000">
                 <a:moveTo>
-                  <a:pt x="3717710" y="8661917"/>
+                  <a:pt x="3718028" y="8686301"/>
                 </a:moveTo>
                 <a:lnTo>
-                  <a:pt x="3717710" y="8715918"/>
+                  <a:pt x="3718028" y="8740302"/>
                 </a:lnTo>
                 <a:lnTo>
-                  <a:pt x="6309711" y="8715918"/>
+                  <a:pt x="6310029" y="8740302"/>
                 </a:lnTo>
                 <a:lnTo>
-                  <a:pt x="6309711" y="8661917"/>
+                  <a:pt x="6310029" y="8686301"/>
                 </a:lnTo>
                 <a:close/>
                 <a:moveTo>
-                  <a:pt x="537403" y="8661917"/>
+                  <a:pt x="537721" y="8686301"/>
                 </a:moveTo>
                 <a:lnTo>
-                  <a:pt x="537403" y="8715918"/>
+                  <a:pt x="537721" y="8740302"/>
                 </a:lnTo>
                 <a:lnTo>
-                  <a:pt x="3129405" y="8715918"/>
+                  <a:pt x="3129723" y="8740302"/>
                 </a:lnTo>
                 <a:lnTo>
-                  <a:pt x="3129405" y="8661917"/>
+                  <a:pt x="3129723" y="8686301"/>
                 </a:lnTo>
                 <a:close/>
                 <a:moveTo>
-                  <a:pt x="651376" y="677901"/>
+                  <a:pt x="651694" y="702285"/>
                 </a:moveTo>
                 <a:cubicBezTo>
-                  <a:pt x="594857" y="677901"/>
-                  <a:pt x="549040" y="723718"/>
-                  <a:pt x="549040" y="780237"/>
+                  <a:pt x="595175" y="702285"/>
+                  <a:pt x="549358" y="748102"/>
+                  <a:pt x="549358" y="804621"/>
                 </a:cubicBezTo>
                 <a:cubicBezTo>
-                  <a:pt x="549040" y="836756"/>
-                  <a:pt x="594857" y="882573"/>
-                  <a:pt x="651376" y="882573"/>
+                  <a:pt x="549358" y="861140"/>
+                  <a:pt x="595175" y="906957"/>
+                  <a:pt x="651694" y="906957"/>
                 </a:cubicBezTo>
                 <a:cubicBezTo>
-                  <a:pt x="707895" y="882573"/>
-                  <a:pt x="753712" y="836756"/>
-                  <a:pt x="753712" y="780237"/>
+                  <a:pt x="708213" y="906957"/>
+                  <a:pt x="754030" y="861140"/>
+                  <a:pt x="754030" y="804621"/>
                 </a:cubicBezTo>
                 <a:cubicBezTo>
-                  <a:pt x="753712" y="723718"/>
-                  <a:pt x="707895" y="677901"/>
-                  <a:pt x="651376" y="677901"/>
+                  <a:pt x="754030" y="748102"/>
+                  <a:pt x="708213" y="702285"/>
+                  <a:pt x="651694" y="702285"/>
                 </a:cubicBezTo>
                 <a:close/>
                 <a:moveTo>
-                  <a:pt x="537402" y="452468"/>
+                  <a:pt x="537720" y="476852"/>
                 </a:moveTo>
                 <a:lnTo>
-                  <a:pt x="537402" y="506469"/>
+                  <a:pt x="537720" y="530853"/>
                 </a:lnTo>
                 <a:lnTo>
-                  <a:pt x="6293597" y="506469"/>
+                  <a:pt x="6293915" y="530853"/>
                 </a:lnTo>
                 <a:lnTo>
-                  <a:pt x="6293597" y="452468"/>
+                  <a:pt x="6293915" y="476852"/>
                 </a:lnTo>
                 <a:close/>
                 <a:moveTo>
@@ -11414,7 +12568,7 @@
           <p:cNvPr id="169" name="テキスト ボックス 16">
             <a:extLst>
               <a:ext uri="{FF2B5EF4-FFF2-40B4-BE49-F238E27FC236}">
-                <a16:creationId xmlns:a16="http://schemas.microsoft.com/office/drawing/2014/main" id="{2401B375-2507-885F-D35B-A7B7404C2D62}"/>
+                <a16:creationId xmlns:a16="http://schemas.microsoft.com/office/drawing/2014/main" id="{191A636B-8154-D84F-E822-0CF8A52508AA}"/>
               </a:ext>
             </a:extLst>
           </p:cNvPr>
@@ -11423,7 +12577,7 @@
         </p:nvSpPr>
         <p:spPr>
           <a:xfrm>
-            <a:off x="3209546" y="8485377"/>
+            <a:off x="3194306" y="8485377"/>
             <a:ext cx="484295" cy="421641"/>
           </a:xfrm>
           <a:prstGeom prst="rect">
@@ -11434,7 +12588,7 @@
           </a:ln>
           <a:extLst>
             <a:ext uri="{C572A759-6A51-4108-AA02-DFA0A04FC94B}">
-              <ma14:wrappingTextBoxFlag xmlns="" xmlns:m="http://schemas.openxmlformats.org/officeDocument/2006/math" xmlns:a14="http://schemas.microsoft.com/office/drawing/2010/main" xmlns:ma14="http://schemas.microsoft.com/office/mac/drawingml/2011/main" val="1"/>
+              <ma14:wrappingTextBoxFlag xmlns:ma14="http://schemas.microsoft.com/office/mac/drawingml/2011/main" xmlns:a14="http://schemas.microsoft.com/office/drawing/2010/main" xmlns:m="http://schemas.openxmlformats.org/officeDocument/2006/math" xmlns="" val="1"/>
             </a:ext>
           </a:extLst>
         </p:spPr>
@@ -11447,6 +12601,7 @@
           </a:lstStyle>
           <a:p>
             <a:r>
+              <a:rPr dirty="0"/>
               <a:t>3</a:t>
             </a:r>
           </a:p>
@@ -11457,7 +12612,7 @@
           <p:cNvPr id="171" name="テキスト ボックス 30">
             <a:extLst>
               <a:ext uri="{FF2B5EF4-FFF2-40B4-BE49-F238E27FC236}">
-                <a16:creationId xmlns:a16="http://schemas.microsoft.com/office/drawing/2014/main" id="{88F34578-DCC1-68E5-B4AC-69C030967868}"/>
+                <a16:creationId xmlns:a16="http://schemas.microsoft.com/office/drawing/2014/main" id="{1A1BC54F-26FF-7F5E-7713-5B0DE197343A}"/>
               </a:ext>
             </a:extLst>
           </p:cNvPr>
@@ -11477,7 +12632,7 @@
           </a:ln>
           <a:extLst>
             <a:ext uri="{C572A759-6A51-4108-AA02-DFA0A04FC94B}">
-              <ma14:wrappingTextBoxFlag xmlns="" xmlns:m="http://schemas.openxmlformats.org/officeDocument/2006/math" xmlns:a14="http://schemas.microsoft.com/office/drawing/2010/main" xmlns:ma14="http://schemas.microsoft.com/office/mac/drawingml/2011/main" val="1"/>
+              <ma14:wrappingTextBoxFlag xmlns:ma14="http://schemas.microsoft.com/office/mac/drawingml/2011/main" xmlns:a14="http://schemas.microsoft.com/office/drawing/2010/main" xmlns:m="http://schemas.openxmlformats.org/officeDocument/2006/math" xmlns="" val="1"/>
             </a:ext>
           </a:extLst>
         </p:spPr>
@@ -11516,7 +12671,7 @@
           <p:cNvPr id="172" name="テキスト ボックス 32">
             <a:extLst>
               <a:ext uri="{FF2B5EF4-FFF2-40B4-BE49-F238E27FC236}">
-                <a16:creationId xmlns:a16="http://schemas.microsoft.com/office/drawing/2014/main" id="{EECE8F1E-0BB0-4D94-1D67-4BE275F3C55E}"/>
+                <a16:creationId xmlns:a16="http://schemas.microsoft.com/office/drawing/2014/main" id="{5113D10C-7B88-EA2B-C85A-47EA5C6D0671}"/>
               </a:ext>
             </a:extLst>
           </p:cNvPr>
@@ -11536,7 +12691,7 @@
           </a:ln>
           <a:extLst>
             <a:ext uri="{C572A759-6A51-4108-AA02-DFA0A04FC94B}">
-              <ma14:wrappingTextBoxFlag xmlns="" xmlns:m="http://schemas.openxmlformats.org/officeDocument/2006/math" xmlns:a14="http://schemas.microsoft.com/office/drawing/2010/main" xmlns:ma14="http://schemas.microsoft.com/office/mac/drawingml/2011/main" val="1"/>
+              <ma14:wrappingTextBoxFlag xmlns:ma14="http://schemas.microsoft.com/office/mac/drawingml/2011/main" xmlns:a14="http://schemas.microsoft.com/office/drawing/2010/main" xmlns:m="http://schemas.openxmlformats.org/officeDocument/2006/math" xmlns="" val="1"/>
             </a:ext>
           </a:extLst>
         </p:spPr>
@@ -11590,7 +12745,7 @@
           <p:cNvPr id="174" name="テキスト ボックス 18">
             <a:extLst>
               <a:ext uri="{FF2B5EF4-FFF2-40B4-BE49-F238E27FC236}">
-                <a16:creationId xmlns:a16="http://schemas.microsoft.com/office/drawing/2014/main" id="{654BEC8C-B846-E75C-F208-611E4592D15F}"/>
+                <a16:creationId xmlns:a16="http://schemas.microsoft.com/office/drawing/2014/main" id="{137E6AE8-9544-E7E5-3C67-39AADC090622}"/>
               </a:ext>
             </a:extLst>
           </p:cNvPr>
@@ -11610,7 +12765,7 @@
           </a:ln>
           <a:extLst>
             <a:ext uri="{C572A759-6A51-4108-AA02-DFA0A04FC94B}">
-              <ma14:wrappingTextBoxFlag xmlns="" xmlns:m="http://schemas.openxmlformats.org/officeDocument/2006/math" xmlns:a14="http://schemas.microsoft.com/office/drawing/2010/main" xmlns:ma14="http://schemas.microsoft.com/office/mac/drawingml/2011/main" val="1"/>
+              <ma14:wrappingTextBoxFlag xmlns:ma14="http://schemas.microsoft.com/office/mac/drawingml/2011/main" xmlns:a14="http://schemas.microsoft.com/office/drawing/2010/main" xmlns:m="http://schemas.openxmlformats.org/officeDocument/2006/math" xmlns="" val="1"/>
             </a:ext>
           </a:extLst>
         </p:spPr>
@@ -11624,14 +12779,135 @@
               <a:defRPr sz="1000"/>
             </a:pPr>
             <a:r>
-              <a:t>Die Farbverlaufsfilament Serie bietet mehrere farbwechselnde Profile und Druckplatten mit unterschiedlichen Zyklusanzahlen. Die Details variieren je nach Modell. Bitte beachten Sie daher die Beschreibung des jeweiligen Modells.</a:t>
+              <a:rPr dirty="0"/>
+              <a:t>Die </a:t>
+            </a:r>
+            <a:r>
+              <a:rPr dirty="0" err="1"/>
+              <a:t>Farbverlaufsfilament</a:t>
+            </a:r>
+            <a:r>
+              <a:rPr dirty="0"/>
+              <a:t> Serie </a:t>
+            </a:r>
+            <a:r>
+              <a:rPr dirty="0" err="1"/>
+              <a:t>bietet</a:t>
+            </a:r>
+            <a:r>
+              <a:rPr dirty="0"/>
+              <a:t> </a:t>
+            </a:r>
+            <a:r>
+              <a:rPr dirty="0" err="1"/>
+              <a:t>mehrere</a:t>
+            </a:r>
+            <a:r>
+              <a:rPr dirty="0"/>
+              <a:t> </a:t>
+            </a:r>
+            <a:r>
+              <a:rPr dirty="0" err="1"/>
+              <a:t>farbwechselnde</a:t>
+            </a:r>
+            <a:r>
+              <a:rPr dirty="0"/>
+              <a:t> Profile und </a:t>
+            </a:r>
+            <a:r>
+              <a:rPr dirty="0" err="1"/>
+              <a:t>Druckplatten</a:t>
+            </a:r>
+            <a:r>
+              <a:rPr dirty="0"/>
+              <a:t> </a:t>
+            </a:r>
+            <a:r>
+              <a:rPr dirty="0" err="1"/>
+              <a:t>mit</a:t>
+            </a:r>
+            <a:r>
+              <a:rPr dirty="0"/>
+              <a:t> </a:t>
+            </a:r>
+            <a:r>
+              <a:rPr dirty="0" err="1"/>
+              <a:t>unterschiedlichen</a:t>
+            </a:r>
+            <a:r>
+              <a:rPr dirty="0"/>
+              <a:t> </a:t>
+            </a:r>
+            <a:r>
+              <a:rPr dirty="0" err="1"/>
+              <a:t>Zyklusanzahlen</a:t>
+            </a:r>
+            <a:r>
+              <a:rPr dirty="0"/>
+              <a:t>. Die Details </a:t>
+            </a:r>
+            <a:r>
+              <a:rPr dirty="0" err="1"/>
+              <a:t>variieren</a:t>
+            </a:r>
+            <a:r>
+              <a:rPr dirty="0"/>
+              <a:t> je </a:t>
+            </a:r>
+            <a:r>
+              <a:rPr dirty="0" err="1"/>
+              <a:t>nach</a:t>
+            </a:r>
+            <a:r>
+              <a:rPr dirty="0"/>
+              <a:t> Modell. Bitte </a:t>
+            </a:r>
+            <a:r>
+              <a:rPr dirty="0" err="1"/>
+              <a:t>beachten</a:t>
+            </a:r>
+            <a:r>
+              <a:rPr dirty="0"/>
+              <a:t> Sie </a:t>
+            </a:r>
+            <a:r>
+              <a:rPr dirty="0" err="1"/>
+              <a:t>daher</a:t>
+            </a:r>
+            <a:r>
+              <a:rPr dirty="0"/>
+              <a:t> die </a:t>
+            </a:r>
+            <a:r>
+              <a:rPr dirty="0" err="1"/>
+              <a:t>Beschreibung</a:t>
+            </a:r>
+            <a:r>
+              <a:rPr dirty="0"/>
+              <a:t> des </a:t>
+            </a:r>
+            <a:r>
+              <a:rPr dirty="0" err="1"/>
+              <a:t>jeweiligen</a:t>
+            </a:r>
+            <a:r>
+              <a:rPr dirty="0"/>
+              <a:t> </a:t>
+            </a:r>
+            <a:r>
+              <a:rPr dirty="0" err="1"/>
+              <a:t>Modells</a:t>
+            </a:r>
+            <a:r>
+              <a:rPr dirty="0"/>
+              <a:t>.</a:t>
             </a:r>
           </a:p>
           <a:p>
             <a:pPr>
               <a:defRPr sz="1000"/>
             </a:pPr>
-            <a:endParaRPr/>
+            <a:endParaRPr dirty="0"/>
           </a:p>
           <a:p>
             <a:pPr marL="171450" indent="-171450">
@@ -11641,14 +12917,131 @@
               <a:defRPr sz="1000"/>
             </a:pPr>
             <a:r>
-              <a:t>Farbkurve: Einstellungen basierend auf Farbkombinationen. Diese Option ermöglicht es Ihnen, den optimalen Verlauf für jede Farbe auszuwählen – zum Beispiel „Lebendig“ für Cyan und Gelb oder „Kontrast“ für Weiß und Magenta.</a:t>
+              <a:rPr dirty="0" err="1"/>
+              <a:t>Farbkurve</a:t>
+            </a:r>
+            <a:r>
+              <a:rPr dirty="0"/>
+              <a:t>: </a:t>
+            </a:r>
+            <a:r>
+              <a:rPr dirty="0" err="1"/>
+              <a:t>Einstellungen</a:t>
+            </a:r>
+            <a:r>
+              <a:rPr dirty="0"/>
+              <a:t> </a:t>
+            </a:r>
+            <a:r>
+              <a:rPr dirty="0" err="1"/>
+              <a:t>basierend</a:t>
+            </a:r>
+            <a:r>
+              <a:rPr dirty="0"/>
+              <a:t> auf </a:t>
+            </a:r>
+            <a:r>
+              <a:rPr dirty="0" err="1"/>
+              <a:t>Farbkombinationen</a:t>
+            </a:r>
+            <a:r>
+              <a:rPr dirty="0"/>
+              <a:t>. </a:t>
+            </a:r>
+            <a:r>
+              <a:rPr dirty="0" err="1"/>
+              <a:t>Diese</a:t>
+            </a:r>
+            <a:r>
+              <a:rPr dirty="0"/>
+              <a:t> Option </a:t>
+            </a:r>
+            <a:r>
+              <a:rPr dirty="0" err="1"/>
+              <a:t>ermöglicht</a:t>
+            </a:r>
+            <a:r>
+              <a:rPr dirty="0"/>
+              <a:t> es Ihnen, den </a:t>
+            </a:r>
+            <a:r>
+              <a:rPr dirty="0" err="1"/>
+              <a:t>optimalen</a:t>
+            </a:r>
+            <a:r>
+              <a:rPr dirty="0"/>
+              <a:t> </a:t>
+            </a:r>
+            <a:r>
+              <a:rPr dirty="0" err="1"/>
+              <a:t>Verlauf</a:t>
+            </a:r>
+            <a:r>
+              <a:rPr dirty="0"/>
+              <a:t> für </a:t>
+            </a:r>
+            <a:r>
+              <a:rPr dirty="0" err="1"/>
+              <a:t>jede</a:t>
+            </a:r>
+            <a:r>
+              <a:rPr dirty="0"/>
+              <a:t> </a:t>
+            </a:r>
+            <a:r>
+              <a:rPr dirty="0" err="1"/>
+              <a:t>Farbe</a:t>
+            </a:r>
+            <a:r>
+              <a:rPr dirty="0"/>
+              <a:t> </a:t>
+            </a:r>
+            <a:r>
+              <a:rPr dirty="0" err="1"/>
+              <a:t>auszuwählen</a:t>
+            </a:r>
+            <a:r>
+              <a:rPr dirty="0"/>
+              <a:t> – </a:t>
+            </a:r>
+            <a:r>
+              <a:rPr dirty="0" err="1"/>
+              <a:t>zum</a:t>
+            </a:r>
+            <a:r>
+              <a:rPr dirty="0"/>
+              <a:t> </a:t>
+            </a:r>
+            <a:r>
+              <a:rPr dirty="0" err="1"/>
+              <a:t>Beispiel</a:t>
+            </a:r>
+            <a:r>
+              <a:rPr dirty="0"/>
+              <a:t> „Lebendig“ für Cyan und Gelb </a:t>
+            </a:r>
+            <a:r>
+              <a:rPr dirty="0" err="1"/>
+              <a:t>oder</a:t>
+            </a:r>
+            <a:r>
+              <a:rPr dirty="0"/>
+              <a:t> „</a:t>
+            </a:r>
+            <a:r>
+              <a:rPr dirty="0" err="1"/>
+              <a:t>Kontrast</a:t>
+            </a:r>
+            <a:r>
+              <a:rPr dirty="0"/>
+              <a:t>“ für Weiß und Magenta.</a:t>
             </a:r>
           </a:p>
           <a:p>
             <a:pPr>
               <a:defRPr sz="600"/>
             </a:pPr>
-            <a:endParaRPr/>
+            <a:endParaRPr dirty="0"/>
           </a:p>
           <a:p>
             <a:pPr marL="171450" indent="-171450">
@@ -11658,21 +13051,311 @@
               <a:defRPr sz="1000"/>
             </a:pPr>
             <a:r>
-              <a:t>Zyklusanzahl: Die Zahl, welche die Häufigkeit des Verlaufs bestimmt. Als ein Zyklus zählt ein vollständiger Durchlauf, in dem das Filament von A nach B nach A und wieder zurück wechselt.</a:t>
+              <a:rPr dirty="0" err="1"/>
+              <a:t>Zyklusanzahl</a:t>
+            </a:r>
+            <a:r>
+              <a:rPr dirty="0"/>
+              <a:t>: Die Zahl, </a:t>
+            </a:r>
+            <a:r>
+              <a:rPr dirty="0" err="1"/>
+              <a:t>welche</a:t>
+            </a:r>
+            <a:r>
+              <a:rPr dirty="0"/>
+              <a:t> die </a:t>
+            </a:r>
+            <a:r>
+              <a:rPr dirty="0" err="1"/>
+              <a:t>Häufigkeit</a:t>
+            </a:r>
+            <a:r>
+              <a:rPr dirty="0"/>
+              <a:t> des </a:t>
+            </a:r>
+            <a:r>
+              <a:rPr dirty="0" err="1"/>
+              <a:t>Verlaufs</a:t>
+            </a:r>
+            <a:r>
+              <a:rPr dirty="0"/>
+              <a:t> </a:t>
+            </a:r>
+            <a:r>
+              <a:rPr dirty="0" err="1"/>
+              <a:t>bestimmt</a:t>
+            </a:r>
+            <a:r>
+              <a:rPr dirty="0"/>
+              <a:t>. Als </a:t>
+            </a:r>
+            <a:r>
+              <a:rPr dirty="0" err="1"/>
+              <a:t>ein</a:t>
+            </a:r>
+            <a:r>
+              <a:rPr dirty="0"/>
+              <a:t> </a:t>
+            </a:r>
+            <a:r>
+              <a:rPr dirty="0" err="1"/>
+              <a:t>Zyklus</a:t>
+            </a:r>
+            <a:r>
+              <a:rPr dirty="0"/>
+              <a:t> </a:t>
+            </a:r>
+            <a:r>
+              <a:rPr dirty="0" err="1"/>
+              <a:t>zählt</a:t>
+            </a:r>
+            <a:r>
+              <a:rPr dirty="0"/>
+              <a:t> </a:t>
+            </a:r>
+            <a:r>
+              <a:rPr dirty="0" err="1"/>
+              <a:t>ein</a:t>
+            </a:r>
+            <a:r>
+              <a:rPr dirty="0"/>
+              <a:t> </a:t>
+            </a:r>
+            <a:r>
+              <a:rPr dirty="0" err="1"/>
+              <a:t>vollständiger</a:t>
+            </a:r>
+            <a:r>
+              <a:rPr dirty="0"/>
+              <a:t> </a:t>
+            </a:r>
+            <a:r>
+              <a:rPr dirty="0" err="1"/>
+              <a:t>Durchlauf</a:t>
+            </a:r>
+            <a:r>
+              <a:rPr dirty="0"/>
+              <a:t>, in dem das Filament von A </a:t>
+            </a:r>
+            <a:r>
+              <a:rPr dirty="0" err="1"/>
+              <a:t>nach</a:t>
+            </a:r>
+            <a:r>
+              <a:rPr dirty="0"/>
+              <a:t> B </a:t>
+            </a:r>
+            <a:r>
+              <a:rPr dirty="0" err="1"/>
+              <a:t>nach</a:t>
+            </a:r>
+            <a:r>
+              <a:rPr dirty="0"/>
+              <a:t> A und </a:t>
+            </a:r>
+            <a:r>
+              <a:rPr dirty="0" err="1"/>
+              <a:t>wieder</a:t>
+            </a:r>
+            <a:r>
+              <a:rPr dirty="0"/>
+              <a:t> </a:t>
+            </a:r>
+            <a:r>
+              <a:rPr dirty="0" err="1"/>
+              <a:t>zurück</a:t>
+            </a:r>
+            <a:r>
+              <a:rPr dirty="0"/>
+              <a:t> </a:t>
+            </a:r>
+            <a:r>
+              <a:rPr dirty="0" err="1"/>
+              <a:t>wechselt</a:t>
+            </a:r>
+            <a:r>
+              <a:rPr dirty="0"/>
+              <a:t>.</a:t>
             </a:r>
           </a:p>
           <a:p>
             <a:pPr>
               <a:defRPr sz="1000"/>
             </a:pPr>
-            <a:endParaRPr/>
+            <a:endParaRPr dirty="0"/>
           </a:p>
           <a:p>
             <a:pPr>
               <a:defRPr sz="1000"/>
             </a:pPr>
             <a:r>
-              <a:t>Beispiel: Um ein schnell wechselndes Farbverlaufsfilament mit Cyan und Magenta zu erstellen, wählen Sie ein S4 Modell, entscheiden sich für eine 4 Zyklus Druckplatte und nutzen aufgrund des hohen Farbkontrasts das Profil mit der Kurve Lebendig.</a:t>
+              <a:rPr dirty="0" err="1"/>
+              <a:t>Beispiel</a:t>
+            </a:r>
+            <a:r>
+              <a:rPr dirty="0"/>
+              <a:t>: Um </a:t>
+            </a:r>
+            <a:r>
+              <a:rPr dirty="0" err="1"/>
+              <a:t>ein</a:t>
+            </a:r>
+            <a:r>
+              <a:rPr dirty="0"/>
+              <a:t> schnell </a:t>
+            </a:r>
+            <a:r>
+              <a:rPr dirty="0" err="1"/>
+              <a:t>wechselndes</a:t>
+            </a:r>
+            <a:r>
+              <a:rPr dirty="0"/>
+              <a:t> </a:t>
+            </a:r>
+            <a:r>
+              <a:rPr dirty="0" err="1"/>
+              <a:t>Farbverlaufsfilament</a:t>
+            </a:r>
+            <a:r>
+              <a:rPr dirty="0"/>
+              <a:t> </a:t>
+            </a:r>
+            <a:r>
+              <a:rPr dirty="0" err="1"/>
+              <a:t>mit</a:t>
+            </a:r>
+            <a:r>
+              <a:rPr dirty="0"/>
+              <a:t> Cyan und Magenta </a:t>
+            </a:r>
+            <a:r>
+              <a:rPr dirty="0" err="1"/>
+              <a:t>zu</a:t>
+            </a:r>
+            <a:r>
+              <a:rPr dirty="0"/>
+              <a:t> </a:t>
+            </a:r>
+            <a:r>
+              <a:rPr dirty="0" err="1"/>
+              <a:t>erstellen</a:t>
+            </a:r>
+            <a:r>
+              <a:rPr dirty="0"/>
+              <a:t>, </a:t>
+            </a:r>
+            <a:r>
+              <a:rPr dirty="0" err="1"/>
+              <a:t>wählen</a:t>
+            </a:r>
+            <a:r>
+              <a:rPr dirty="0"/>
+              <a:t> Sie </a:t>
+            </a:r>
+            <a:r>
+              <a:rPr dirty="0" err="1"/>
+              <a:t>ein</a:t>
+            </a:r>
+            <a:r>
+              <a:rPr dirty="0"/>
+              <a:t> S4 Modell, </a:t>
+            </a:r>
+            <a:r>
+              <a:rPr dirty="0" err="1"/>
+              <a:t>entscheiden</a:t>
+            </a:r>
+            <a:r>
+              <a:rPr dirty="0"/>
+              <a:t> </a:t>
+            </a:r>
+            <a:r>
+              <a:rPr dirty="0" err="1"/>
+              <a:t>sich</a:t>
+            </a:r>
+            <a:r>
+              <a:rPr dirty="0"/>
+              <a:t> für </a:t>
+            </a:r>
+            <a:r>
+              <a:rPr dirty="0" err="1"/>
+              <a:t>eine</a:t>
+            </a:r>
+            <a:r>
+              <a:rPr dirty="0"/>
+              <a:t> 4 </a:t>
+            </a:r>
+            <a:r>
+              <a:rPr dirty="0" err="1"/>
+              <a:t>Zyklus</a:t>
+            </a:r>
+            <a:r>
+              <a:rPr dirty="0"/>
+              <a:t> </a:t>
+            </a:r>
+            <a:r>
+              <a:rPr dirty="0" err="1"/>
+              <a:t>Druckplatte</a:t>
+            </a:r>
+            <a:r>
+              <a:rPr dirty="0"/>
+              <a:t> und </a:t>
+            </a:r>
+            <a:r>
+              <a:rPr dirty="0" err="1"/>
+              <a:t>nutzen</a:t>
+            </a:r>
+            <a:r>
+              <a:rPr dirty="0"/>
+              <a:t> </a:t>
+            </a:r>
+            <a:r>
+              <a:rPr dirty="0" err="1"/>
+              <a:t>aufgrund</a:t>
+            </a:r>
+            <a:r>
+              <a:rPr dirty="0"/>
+              <a:t> des </a:t>
+            </a:r>
+            <a:r>
+              <a:rPr dirty="0" err="1"/>
+              <a:t>hohen</a:t>
+            </a:r>
+            <a:r>
+              <a:rPr dirty="0"/>
+              <a:t> </a:t>
+            </a:r>
+            <a:r>
+              <a:rPr dirty="0" err="1"/>
+              <a:t>Farbkontrasts</a:t>
+            </a:r>
+            <a:r>
+              <a:rPr dirty="0"/>
+              <a:t> das </a:t>
+            </a:r>
+            <a:r>
+              <a:rPr dirty="0" err="1"/>
+              <a:t>Profil</a:t>
+            </a:r>
+            <a:r>
+              <a:rPr dirty="0"/>
+              <a:t> </a:t>
+            </a:r>
+            <a:r>
+              <a:rPr dirty="0" err="1"/>
+              <a:t>mit</a:t>
+            </a:r>
+            <a:r>
+              <a:rPr dirty="0"/>
+              <a:t> der </a:t>
+            </a:r>
+            <a:r>
+              <a:rPr dirty="0" err="1"/>
+              <a:t>Kurve</a:t>
+            </a:r>
+            <a:r>
+              <a:rPr dirty="0"/>
+              <a:t> Lebendig.</a:t>
             </a:r>
           </a:p>
         </p:txBody>
@@ -11682,7 +13365,7 @@
           <p:cNvPr id="4" name="図 3">
             <a:extLst>
               <a:ext uri="{FF2B5EF4-FFF2-40B4-BE49-F238E27FC236}">
-                <a16:creationId xmlns:a16="http://schemas.microsoft.com/office/drawing/2014/main" id="{F38C1769-2964-372D-55F4-2CF36C321C5B}"/>
+                <a16:creationId xmlns:a16="http://schemas.microsoft.com/office/drawing/2014/main" id="{B2CBAABB-F109-CE7D-31DD-F5051C37601A}"/>
               </a:ext>
             </a:extLst>
           </p:cNvPr>
@@ -11726,10 +13409,10 @@
       </p:pic>
       <p:pic>
         <p:nvPicPr>
-          <p:cNvPr id="7" name="図 6">
+          <p:cNvPr id="3" name="図 2">
             <a:extLst>
               <a:ext uri="{FF2B5EF4-FFF2-40B4-BE49-F238E27FC236}">
-                <a16:creationId xmlns:a16="http://schemas.microsoft.com/office/drawing/2014/main" id="{17992F70-9740-0BCE-1CB9-0A784448932E}"/>
+                <a16:creationId xmlns:a16="http://schemas.microsoft.com/office/drawing/2014/main" id="{35B71BF1-727B-33C3-4D4C-3C0DA7AFA783}"/>
               </a:ext>
             </a:extLst>
           </p:cNvPr>
@@ -11774,7 +13457,7 @@
     </p:spTree>
     <p:extLst>
       <p:ext uri="{BB962C8B-B14F-4D97-AF65-F5344CB8AC3E}">
-        <p14:creationId xmlns:p14="http://schemas.microsoft.com/office/powerpoint/2010/main" val="3757303950"/>
+        <p14:creationId xmlns:p14="http://schemas.microsoft.com/office/powerpoint/2010/main" val="1472029063"/>
       </p:ext>
     </p:extLst>
   </p:cSld>
@@ -11793,7 +13476,7 @@
         <p:cNvPr id="1" name="">
           <a:extLst>
             <a:ext uri="{FF2B5EF4-FFF2-40B4-BE49-F238E27FC236}">
-              <a16:creationId xmlns:a16="http://schemas.microsoft.com/office/drawing/2014/main" id="{B2518F59-9DB2-8DBB-57D4-B1DFC727DE93}"/>
+              <a16:creationId xmlns:a16="http://schemas.microsoft.com/office/drawing/2014/main" id="{05D80327-9469-24FE-80F0-3CA7C09B6181}"/>
             </a:ext>
           </a:extLst>
         </p:cNvPr>
@@ -11813,7 +13496,7 @@
           <p:cNvPr id="177" name="正方形/長方形 29">
             <a:extLst>
               <a:ext uri="{FF2B5EF4-FFF2-40B4-BE49-F238E27FC236}">
-                <a16:creationId xmlns:a16="http://schemas.microsoft.com/office/drawing/2014/main" id="{E3C405C9-5B94-2B73-9968-361092C8FA9F}"/>
+                <a16:creationId xmlns:a16="http://schemas.microsoft.com/office/drawing/2014/main" id="{6BD72277-B50B-1435-4296-365527F8AEC7}"/>
               </a:ext>
             </a:extLst>
           </p:cNvPr>
@@ -11863,10 +13546,10 @@
       </p:sp>
       <p:sp>
         <p:nvSpPr>
-          <p:cNvPr id="5" name="フリーフォーム: 図形 4">
+          <p:cNvPr id="6" name="フリーフォーム: 図形 5">
             <a:extLst>
               <a:ext uri="{FF2B5EF4-FFF2-40B4-BE49-F238E27FC236}">
-                <a16:creationId xmlns:a16="http://schemas.microsoft.com/office/drawing/2014/main" id="{2B7B299E-3851-A4B8-9022-0CB8448C98B8}"/>
+                <a16:creationId xmlns:a16="http://schemas.microsoft.com/office/drawing/2014/main" id="{C5ADF236-4A27-8B20-F573-DA3E4F548CE7}"/>
               </a:ext>
             </a:extLst>
           </p:cNvPr>
@@ -11881,113 +13564,113 @@
           <a:custGeom>
             <a:avLst/>
             <a:gdLst>
-              <a:gd name="connsiteX0" fmla="*/ 3717793 w 6858001"/>
-              <a:gd name="connsiteY0" fmla="*/ 8656387 h 9144001"/>
-              <a:gd name="connsiteX1" fmla="*/ 3717793 w 6858001"/>
-              <a:gd name="connsiteY1" fmla="*/ 8710388 h 9144001"/>
-              <a:gd name="connsiteX2" fmla="*/ 6309794 w 6858001"/>
-              <a:gd name="connsiteY2" fmla="*/ 8710388 h 9144001"/>
-              <a:gd name="connsiteX3" fmla="*/ 6309794 w 6858001"/>
-              <a:gd name="connsiteY3" fmla="*/ 8656387 h 9144001"/>
-              <a:gd name="connsiteX4" fmla="*/ 537486 w 6858001"/>
-              <a:gd name="connsiteY4" fmla="*/ 8656387 h 9144001"/>
-              <a:gd name="connsiteX5" fmla="*/ 537486 w 6858001"/>
-              <a:gd name="connsiteY5" fmla="*/ 8710388 h 9144001"/>
-              <a:gd name="connsiteX6" fmla="*/ 3129488 w 6858001"/>
-              <a:gd name="connsiteY6" fmla="*/ 8710388 h 9144001"/>
-              <a:gd name="connsiteX7" fmla="*/ 3129488 w 6858001"/>
-              <a:gd name="connsiteY7" fmla="*/ 8656387 h 9144001"/>
-              <a:gd name="connsiteX8" fmla="*/ 631632 w 6858001"/>
-              <a:gd name="connsiteY8" fmla="*/ 811545 h 9144001"/>
-              <a:gd name="connsiteX9" fmla="*/ 529296 w 6858001"/>
-              <a:gd name="connsiteY9" fmla="*/ 913881 h 9144001"/>
-              <a:gd name="connsiteX10" fmla="*/ 631632 w 6858001"/>
-              <a:gd name="connsiteY10" fmla="*/ 1016217 h 9144001"/>
-              <a:gd name="connsiteX11" fmla="*/ 733968 w 6858001"/>
-              <a:gd name="connsiteY11" fmla="*/ 913881 h 9144001"/>
-              <a:gd name="connsiteX12" fmla="*/ 631632 w 6858001"/>
-              <a:gd name="connsiteY12" fmla="*/ 811545 h 9144001"/>
-              <a:gd name="connsiteX13" fmla="*/ 537485 w 6858001"/>
-              <a:gd name="connsiteY13" fmla="*/ 446938 h 9144001"/>
-              <a:gd name="connsiteX14" fmla="*/ 537485 w 6858001"/>
-              <a:gd name="connsiteY14" fmla="*/ 500939 h 9144001"/>
-              <a:gd name="connsiteX15" fmla="*/ 6293680 w 6858001"/>
-              <a:gd name="connsiteY15" fmla="*/ 500939 h 9144001"/>
-              <a:gd name="connsiteX16" fmla="*/ 6293680 w 6858001"/>
-              <a:gd name="connsiteY16" fmla="*/ 446938 h 9144001"/>
-              <a:gd name="connsiteX17" fmla="*/ 0 w 6858001"/>
-              <a:gd name="connsiteY17" fmla="*/ 0 h 9144001"/>
-              <a:gd name="connsiteX18" fmla="*/ 6858001 w 6858001"/>
-              <a:gd name="connsiteY18" fmla="*/ 0 h 9144001"/>
-              <a:gd name="connsiteX19" fmla="*/ 6858001 w 6858001"/>
-              <a:gd name="connsiteY19" fmla="*/ 9144001 h 9144001"/>
-              <a:gd name="connsiteX20" fmla="*/ 0 w 6858001"/>
-              <a:gd name="connsiteY20" fmla="*/ 9144001 h 9144001"/>
+              <a:gd name="csX0" fmla="*/ 3717793 w 6858001"/>
+              <a:gd name="csY0" fmla="*/ 8656387 h 9144001"/>
+              <a:gd name="csX1" fmla="*/ 3717793 w 6858001"/>
+              <a:gd name="csY1" fmla="*/ 8710388 h 9144001"/>
+              <a:gd name="csX2" fmla="*/ 6309794 w 6858001"/>
+              <a:gd name="csY2" fmla="*/ 8710388 h 9144001"/>
+              <a:gd name="csX3" fmla="*/ 6309794 w 6858001"/>
+              <a:gd name="csY3" fmla="*/ 8656387 h 9144001"/>
+              <a:gd name="csX4" fmla="*/ 537486 w 6858001"/>
+              <a:gd name="csY4" fmla="*/ 8656387 h 9144001"/>
+              <a:gd name="csX5" fmla="*/ 537486 w 6858001"/>
+              <a:gd name="csY5" fmla="*/ 8710388 h 9144001"/>
+              <a:gd name="csX6" fmla="*/ 3129488 w 6858001"/>
+              <a:gd name="csY6" fmla="*/ 8710388 h 9144001"/>
+              <a:gd name="csX7" fmla="*/ 3129488 w 6858001"/>
+              <a:gd name="csY7" fmla="*/ 8656387 h 9144001"/>
+              <a:gd name="csX8" fmla="*/ 631632 w 6858001"/>
+              <a:gd name="csY8" fmla="*/ 811545 h 9144001"/>
+              <a:gd name="csX9" fmla="*/ 529296 w 6858001"/>
+              <a:gd name="csY9" fmla="*/ 913881 h 9144001"/>
+              <a:gd name="csX10" fmla="*/ 631632 w 6858001"/>
+              <a:gd name="csY10" fmla="*/ 1016217 h 9144001"/>
+              <a:gd name="csX11" fmla="*/ 733968 w 6858001"/>
+              <a:gd name="csY11" fmla="*/ 913881 h 9144001"/>
+              <a:gd name="csX12" fmla="*/ 631632 w 6858001"/>
+              <a:gd name="csY12" fmla="*/ 811545 h 9144001"/>
+              <a:gd name="csX13" fmla="*/ 537485 w 6858001"/>
+              <a:gd name="csY13" fmla="*/ 446938 h 9144001"/>
+              <a:gd name="csX14" fmla="*/ 537485 w 6858001"/>
+              <a:gd name="csY14" fmla="*/ 500939 h 9144001"/>
+              <a:gd name="csX15" fmla="*/ 6293680 w 6858001"/>
+              <a:gd name="csY15" fmla="*/ 500939 h 9144001"/>
+              <a:gd name="csX16" fmla="*/ 6293680 w 6858001"/>
+              <a:gd name="csY16" fmla="*/ 446938 h 9144001"/>
+              <a:gd name="csX17" fmla="*/ 0 w 6858001"/>
+              <a:gd name="csY17" fmla="*/ 0 h 9144001"/>
+              <a:gd name="csX18" fmla="*/ 6858001 w 6858001"/>
+              <a:gd name="csY18" fmla="*/ 0 h 9144001"/>
+              <a:gd name="csX19" fmla="*/ 6858001 w 6858001"/>
+              <a:gd name="csY19" fmla="*/ 9144001 h 9144001"/>
+              <a:gd name="csX20" fmla="*/ 0 w 6858001"/>
+              <a:gd name="csY20" fmla="*/ 9144001 h 9144001"/>
             </a:gdLst>
             <a:ahLst/>
             <a:cxnLst>
               <a:cxn ang="0">
-                <a:pos x="connsiteX0" y="connsiteY0"/>
+                <a:pos x="csX0" y="csY0"/>
               </a:cxn>
               <a:cxn ang="0">
-                <a:pos x="connsiteX1" y="connsiteY1"/>
+                <a:pos x="csX1" y="csY1"/>
               </a:cxn>
               <a:cxn ang="0">
-                <a:pos x="connsiteX2" y="connsiteY2"/>
+                <a:pos x="csX2" y="csY2"/>
               </a:cxn>
               <a:cxn ang="0">
-                <a:pos x="connsiteX3" y="connsiteY3"/>
+                <a:pos x="csX3" y="csY3"/>
               </a:cxn>
               <a:cxn ang="0">
-                <a:pos x="connsiteX4" y="connsiteY4"/>
+                <a:pos x="csX4" y="csY4"/>
               </a:cxn>
               <a:cxn ang="0">
-                <a:pos x="connsiteX5" y="connsiteY5"/>
+                <a:pos x="csX5" y="csY5"/>
               </a:cxn>
               <a:cxn ang="0">
-                <a:pos x="connsiteX6" y="connsiteY6"/>
+                <a:pos x="csX6" y="csY6"/>
               </a:cxn>
               <a:cxn ang="0">
-                <a:pos x="connsiteX7" y="connsiteY7"/>
+                <a:pos x="csX7" y="csY7"/>
               </a:cxn>
               <a:cxn ang="0">
-                <a:pos x="connsiteX8" y="connsiteY8"/>
+                <a:pos x="csX8" y="csY8"/>
               </a:cxn>
               <a:cxn ang="0">
-                <a:pos x="connsiteX9" y="connsiteY9"/>
+                <a:pos x="csX9" y="csY9"/>
               </a:cxn>
               <a:cxn ang="0">
-                <a:pos x="connsiteX10" y="connsiteY10"/>
+                <a:pos x="csX10" y="csY10"/>
               </a:cxn>
               <a:cxn ang="0">
-                <a:pos x="connsiteX11" y="connsiteY11"/>
+                <a:pos x="csX11" y="csY11"/>
               </a:cxn>
               <a:cxn ang="0">
-                <a:pos x="connsiteX12" y="connsiteY12"/>
+                <a:pos x="csX12" y="csY12"/>
               </a:cxn>
               <a:cxn ang="0">
-                <a:pos x="connsiteX13" y="connsiteY13"/>
+                <a:pos x="csX13" y="csY13"/>
               </a:cxn>
               <a:cxn ang="0">
-                <a:pos x="connsiteX14" y="connsiteY14"/>
+                <a:pos x="csX14" y="csY14"/>
               </a:cxn>
               <a:cxn ang="0">
-                <a:pos x="connsiteX15" y="connsiteY15"/>
+                <a:pos x="csX15" y="csY15"/>
               </a:cxn>
               <a:cxn ang="0">
-                <a:pos x="connsiteX16" y="connsiteY16"/>
+                <a:pos x="csX16" y="csY16"/>
               </a:cxn>
               <a:cxn ang="0">
-                <a:pos x="connsiteX17" y="connsiteY17"/>
+                <a:pos x="csX17" y="csY17"/>
               </a:cxn>
               <a:cxn ang="0">
-                <a:pos x="connsiteX18" y="connsiteY18"/>
+                <a:pos x="csX18" y="csY18"/>
               </a:cxn>
               <a:cxn ang="0">
-                <a:pos x="connsiteX19" y="connsiteY19"/>
+                <a:pos x="csX19" y="csY19"/>
               </a:cxn>
               <a:cxn ang="0">
-                <a:pos x="connsiteX20" y="connsiteY20"/>
+                <a:pos x="csX20" y="csY20"/>
               </a:cxn>
             </a:cxnLst>
             <a:rect l="l" t="t" r="r" b="b"/>
@@ -12092,7 +13775,7 @@
                 </a:solidFill>
               </a:defRPr>
             </a:pPr>
-            <a:endParaRPr/>
+            <a:endParaRPr b="1"/>
           </a:p>
         </p:txBody>
       </p:sp>
@@ -12101,7 +13784,7 @@
           <p:cNvPr id="187" name="テキスト ボックス 16">
             <a:extLst>
               <a:ext uri="{FF2B5EF4-FFF2-40B4-BE49-F238E27FC236}">
-                <a16:creationId xmlns:a16="http://schemas.microsoft.com/office/drawing/2014/main" id="{0C730130-D168-B011-DBF1-80B0EA2265F8}"/>
+                <a16:creationId xmlns:a16="http://schemas.microsoft.com/office/drawing/2014/main" id="{79C717FF-486D-5135-6F40-4E74484AFC88}"/>
               </a:ext>
             </a:extLst>
           </p:cNvPr>
@@ -12110,8 +13793,8 @@
         </p:nvSpPr>
         <p:spPr>
           <a:xfrm>
-            <a:off x="3209546" y="8485377"/>
-            <a:ext cx="484295" cy="421641"/>
+            <a:off x="3209546" y="8511531"/>
+            <a:ext cx="484295" cy="369332"/>
           </a:xfrm>
           <a:prstGeom prst="rect">
             <a:avLst/>
@@ -12121,7 +13804,7 @@
           </a:ln>
           <a:extLst>
             <a:ext uri="{C572A759-6A51-4108-AA02-DFA0A04FC94B}">
-              <ma14:wrappingTextBoxFlag xmlns="" xmlns:m="http://schemas.openxmlformats.org/officeDocument/2006/math" xmlns:a14="http://schemas.microsoft.com/office/drawing/2010/main" xmlns:ma14="http://schemas.microsoft.com/office/mac/drawingml/2011/main" val="1"/>
+              <ma14:wrappingTextBoxFlag xmlns:ma14="http://schemas.microsoft.com/office/mac/drawingml/2011/main" xmlns:a14="http://schemas.microsoft.com/office/drawing/2010/main" xmlns:m="http://schemas.openxmlformats.org/officeDocument/2006/math" xmlns="" val="1"/>
             </a:ext>
           </a:extLst>
         </p:spPr>
@@ -12134,6 +13817,7 @@
           </a:lstStyle>
           <a:p>
             <a:r>
+              <a:rPr dirty="0"/>
               <a:t>4</a:t>
             </a:r>
           </a:p>
@@ -12144,7 +13828,7 @@
           <p:cNvPr id="189" name="テキスト ボックス 33">
             <a:extLst>
               <a:ext uri="{FF2B5EF4-FFF2-40B4-BE49-F238E27FC236}">
-                <a16:creationId xmlns:a16="http://schemas.microsoft.com/office/drawing/2014/main" id="{DF2D9F74-0CB8-7397-100E-CAFF919500A2}"/>
+                <a16:creationId xmlns:a16="http://schemas.microsoft.com/office/drawing/2014/main" id="{44154982-DCE0-1E6F-2C06-F1F161FE10F5}"/>
               </a:ext>
             </a:extLst>
           </p:cNvPr>
@@ -12153,8 +13837,8 @@
         </p:nvSpPr>
         <p:spPr>
           <a:xfrm>
-            <a:off x="823834" y="762576"/>
-            <a:ext cx="1804552" cy="383541"/>
+            <a:off x="823834" y="772101"/>
+            <a:ext cx="1865252" cy="338554"/>
           </a:xfrm>
           <a:prstGeom prst="rect">
             <a:avLst/>
@@ -12164,7 +13848,7 @@
           </a:ln>
           <a:extLst>
             <a:ext uri="{C572A759-6A51-4108-AA02-DFA0A04FC94B}">
-              <ma14:wrappingTextBoxFlag xmlns="" xmlns:m="http://schemas.openxmlformats.org/officeDocument/2006/math" xmlns:a14="http://schemas.microsoft.com/office/drawing/2010/main" xmlns:ma14="http://schemas.microsoft.com/office/mac/drawingml/2011/main" val="1"/>
+              <ma14:wrappingTextBoxFlag xmlns:ma14="http://schemas.microsoft.com/office/mac/drawingml/2011/main" xmlns:a14="http://schemas.microsoft.com/office/drawing/2010/main" xmlns:m="http://schemas.openxmlformats.org/officeDocument/2006/math" xmlns="" val="1"/>
             </a:ext>
           </a:extLst>
         </p:spPr>
@@ -12184,14 +13868,20 @@
           </a:lstStyle>
           <a:p>
             <a:r>
-              <a:rPr dirty="0"/>
+              <a:rPr dirty="0">
+                <a:latin typeface="+mj-lt"/>
+              </a:rPr>
               <a:t>6. Update </a:t>
             </a:r>
             <a:r>
-              <a:rPr dirty="0" err="1"/>
+              <a:rPr dirty="0" err="1">
+                <a:latin typeface="+mj-lt"/>
+              </a:rPr>
               <a:t>Historie</a:t>
             </a:r>
-            <a:endParaRPr dirty="0"/>
+            <a:endParaRPr dirty="0">
+              <a:latin typeface="+mj-lt"/>
+            </a:endParaRPr>
           </a:p>
         </p:txBody>
       </p:sp>
@@ -12200,7 +13890,7 @@
           <p:cNvPr id="190" name="テキスト ボックス 34">
             <a:extLst>
               <a:ext uri="{FF2B5EF4-FFF2-40B4-BE49-F238E27FC236}">
-                <a16:creationId xmlns:a16="http://schemas.microsoft.com/office/drawing/2014/main" id="{0CC5E96C-B429-EA10-B007-210BB6EC074E}"/>
+                <a16:creationId xmlns:a16="http://schemas.microsoft.com/office/drawing/2014/main" id="{930F3AD8-7BA6-AA24-8D34-A50C6555B586}"/>
               </a:ext>
             </a:extLst>
           </p:cNvPr>
@@ -12210,7 +13900,7 @@
         <p:spPr>
           <a:xfrm>
             <a:off x="684043" y="1115239"/>
-            <a:ext cx="5558051" cy="256541"/>
+            <a:ext cx="5558051" cy="230832"/>
           </a:xfrm>
           <a:prstGeom prst="rect">
             <a:avLst/>
@@ -12220,7 +13910,7 @@
           </a:ln>
           <a:extLst>
             <a:ext uri="{C572A759-6A51-4108-AA02-DFA0A04FC94B}">
-              <ma14:wrappingTextBoxFlag xmlns="" xmlns:m="http://schemas.openxmlformats.org/officeDocument/2006/math" xmlns:a14="http://schemas.microsoft.com/office/drawing/2010/main" xmlns:ma14="http://schemas.microsoft.com/office/mac/drawingml/2011/main" val="1"/>
+              <ma14:wrappingTextBoxFlag xmlns:ma14="http://schemas.microsoft.com/office/mac/drawingml/2011/main" xmlns:a14="http://schemas.microsoft.com/office/drawing/2010/main" xmlns:m="http://schemas.openxmlformats.org/officeDocument/2006/math" xmlns="" val="1"/>
             </a:ext>
           </a:extLst>
         </p:spPr>
@@ -12235,23 +13925,29 @@
           </a:lstStyle>
           <a:p>
             <a:r>
-              <a:rPr dirty="0"/>
+              <a:rPr dirty="0">
+                <a:latin typeface="+mj-lt"/>
+              </a:rPr>
               <a:t>Ver.1.00  2026-09-01  Erste Version </a:t>
             </a:r>
             <a:r>
-              <a:rPr dirty="0" err="1"/>
+              <a:rPr dirty="0" err="1">
+                <a:latin typeface="+mj-lt"/>
+              </a:rPr>
               <a:t>veröffentlicht</a:t>
             </a:r>
-            <a:endParaRPr dirty="0"/>
+            <a:endParaRPr dirty="0">
+              <a:latin typeface="+mj-lt"/>
+            </a:endParaRPr>
           </a:p>
         </p:txBody>
       </p:sp>
       <p:sp>
         <p:nvSpPr>
-          <p:cNvPr id="6" name="テキスト ボックス 34">
+          <p:cNvPr id="3" name="テキスト ボックス 34">
             <a:extLst>
               <a:ext uri="{FF2B5EF4-FFF2-40B4-BE49-F238E27FC236}">
-                <a16:creationId xmlns:a16="http://schemas.microsoft.com/office/drawing/2014/main" id="{646A821F-C4D4-9F6F-D616-F25161195522}"/>
+                <a16:creationId xmlns:a16="http://schemas.microsoft.com/office/drawing/2014/main" id="{508EA612-37A6-81BD-ABBB-3A1CAF9A02B7}"/>
               </a:ext>
             </a:extLst>
           </p:cNvPr>
@@ -12271,7 +13967,7 @@
           </a:ln>
           <a:extLst>
             <a:ext uri="{C572A759-6A51-4108-AA02-DFA0A04FC94B}">
-              <ma14:wrappingTextBoxFlag xmlns="" xmlns:m="http://schemas.openxmlformats.org/officeDocument/2006/math" xmlns:a14="http://schemas.microsoft.com/office/drawing/2010/main" xmlns:ma14="http://schemas.microsoft.com/office/mac/drawingml/2011/main" val="1"/>
+              <ma14:wrappingTextBoxFlag xmlns:ma14="http://schemas.microsoft.com/office/mac/drawingml/2011/main" xmlns:a14="http://schemas.microsoft.com/office/drawing/2010/main" xmlns:m="http://schemas.openxmlformats.org/officeDocument/2006/math" xmlns="" val="1"/>
             </a:ext>
           </a:extLst>
         </p:spPr>
@@ -12286,35 +13982,47 @@
           </a:lstStyle>
           <a:p>
             <a:r>
-              <a:rPr lang="en-US" sz="1000" dirty="0" err="1"/>
+              <a:rPr lang="en-US" sz="1000" dirty="0" err="1">
+                <a:latin typeface="+mj-lt"/>
+              </a:rPr>
               <a:t>Nennung</a:t>
             </a:r>
             <a:r>
-              <a:rPr lang="en-US" sz="1000" dirty="0"/>
+              <a:rPr lang="en-US" sz="1000" dirty="0">
+                <a:latin typeface="+mj-lt"/>
+              </a:rPr>
               <a:t> : </a:t>
             </a:r>
           </a:p>
           <a:p>
             <a:r>
-              <a:rPr lang="en-US" sz="1000" dirty="0"/>
+              <a:rPr lang="en-US" sz="1000" dirty="0">
+                <a:latin typeface="+mj-lt"/>
+              </a:rPr>
               <a:t> Deutsche </a:t>
             </a:r>
             <a:r>
-              <a:rPr lang="en-US" sz="1000" dirty="0" err="1"/>
+              <a:rPr lang="en-US" sz="1000" dirty="0" err="1">
+                <a:latin typeface="+mj-lt"/>
+              </a:rPr>
               <a:t>Übersetzung</a:t>
             </a:r>
             <a:r>
-              <a:rPr lang="en-US" sz="1000" dirty="0"/>
+              <a:rPr lang="en-US" sz="1000" dirty="0">
+                <a:latin typeface="+mj-lt"/>
+              </a:rPr>
               <a:t> –Domenik</a:t>
             </a:r>
-            <a:endParaRPr sz="1000" dirty="0"/>
+            <a:endParaRPr sz="1000" dirty="0">
+              <a:latin typeface="+mj-lt"/>
+            </a:endParaRPr>
           </a:p>
         </p:txBody>
       </p:sp>
     </p:spTree>
     <p:extLst>
       <p:ext uri="{BB962C8B-B14F-4D97-AF65-F5344CB8AC3E}">
-        <p14:creationId xmlns:p14="http://schemas.microsoft.com/office/powerpoint/2010/main" val="1738846206"/>
+        <p14:creationId xmlns:p14="http://schemas.microsoft.com/office/powerpoint/2010/main" val="1224571376"/>
       </p:ext>
     </p:extLst>
   </p:cSld>

</xml_diff>